<commit_message>
HP added week 8 images
</commit_message>
<xml_diff>
--- a/media/week_8/diagrams_dicts_tuples.pptx
+++ b/media/week_8/diagrams_dicts_tuples.pptx
@@ -7,6 +7,7 @@
   <p:sldIdLst>
     <p:sldId id="256" r:id="rId2"/>
     <p:sldId id="257" r:id="rId3"/>
+    <p:sldId id="258" r:id="rId4"/>
   </p:sldIdLst>
   <p:sldSz cx="12192000" cy="6858000"/>
   <p:notesSz cx="6858000" cy="9144000"/>
@@ -113,7 +114,7 @@
   <pc:docChgLst>
     <pc:chgData name="Hemma Philamore" userId="db50e2f3-17b2-4cc0-b719-fb6254d3e9df" providerId="ADAL" clId="{976AD799-FE43-55CA-A221-11B5AB66B93B}"/>
     <pc:docChg chg="undo custSel addSld modSld">
-      <pc:chgData name="Hemma Philamore" userId="db50e2f3-17b2-4cc0-b719-fb6254d3e9df" providerId="ADAL" clId="{976AD799-FE43-55CA-A221-11B5AB66B93B}" dt="2026-10-26T12:00:48.260" v="129" actId="164"/>
+      <pc:chgData name="Hemma Philamore" userId="db50e2f3-17b2-4cc0-b719-fb6254d3e9df" providerId="ADAL" clId="{976AD799-FE43-55CA-A221-11B5AB66B93B}" dt="2026-10-26T14:29:15.369" v="348" actId="164"/>
       <pc:docMkLst>
         <pc:docMk/>
       </pc:docMkLst>
@@ -569,6 +570,725 @@
             <pc:docMk/>
             <pc:sldMk cId="918735867" sldId="257"/>
             <ac:cxnSpMk id="41" creationId="{FDD3ABB9-215C-7F46-7BB3-3E7BB9129CB2}"/>
+          </ac:cxnSpMkLst>
+        </pc:cxnChg>
+      </pc:sldChg>
+      <pc:sldChg chg="addSp delSp modSp add mod">
+        <pc:chgData name="Hemma Philamore" userId="db50e2f3-17b2-4cc0-b719-fb6254d3e9df" providerId="ADAL" clId="{976AD799-FE43-55CA-A221-11B5AB66B93B}" dt="2026-10-26T14:29:15.369" v="348" actId="164"/>
+        <pc:sldMkLst>
+          <pc:docMk/>
+          <pc:sldMk cId="818822214" sldId="258"/>
+        </pc:sldMkLst>
+        <pc:spChg chg="topLvl">
+          <ac:chgData name="Hemma Philamore" userId="db50e2f3-17b2-4cc0-b719-fb6254d3e9df" providerId="ADAL" clId="{976AD799-FE43-55CA-A221-11B5AB66B93B}" dt="2026-10-26T14:01:57.370" v="142" actId="165"/>
+          <ac:spMkLst>
+            <pc:docMk/>
+            <pc:sldMk cId="818822214" sldId="258"/>
+            <ac:spMk id="2" creationId="{1166DCA7-BE25-075C-C4EB-C3A91B2B4558}"/>
+          </ac:spMkLst>
+        </pc:spChg>
+        <pc:spChg chg="del">
+          <ac:chgData name="Hemma Philamore" userId="db50e2f3-17b2-4cc0-b719-fb6254d3e9df" providerId="ADAL" clId="{976AD799-FE43-55CA-A221-11B5AB66B93B}" dt="2026-10-26T14:01:37.096" v="131" actId="478"/>
+          <ac:spMkLst>
+            <pc:docMk/>
+            <pc:sldMk cId="818822214" sldId="258"/>
+            <ac:spMk id="3" creationId="{0B6CC2A2-25F1-702A-6F65-CC7DEA5A1F73}"/>
+          </ac:spMkLst>
+        </pc:spChg>
+        <pc:spChg chg="add mod">
+          <ac:chgData name="Hemma Philamore" userId="db50e2f3-17b2-4cc0-b719-fb6254d3e9df" providerId="ADAL" clId="{976AD799-FE43-55CA-A221-11B5AB66B93B}" dt="2026-10-26T14:01:46.070" v="139" actId="1076"/>
+          <ac:spMkLst>
+            <pc:docMk/>
+            <pc:sldMk cId="818822214" sldId="258"/>
+            <ac:spMk id="5" creationId="{A8068F53-98F4-86A2-1022-96C32A264124}"/>
+          </ac:spMkLst>
+        </pc:spChg>
+        <pc:spChg chg="add mod">
+          <ac:chgData name="Hemma Philamore" userId="db50e2f3-17b2-4cc0-b719-fb6254d3e9df" providerId="ADAL" clId="{976AD799-FE43-55CA-A221-11B5AB66B93B}" dt="2026-10-26T14:02:20.886" v="156" actId="1076"/>
+          <ac:spMkLst>
+            <pc:docMk/>
+            <pc:sldMk cId="818822214" sldId="258"/>
+            <ac:spMk id="6" creationId="{8E0F47BF-4885-964F-0D60-B4639C8A9BE6}"/>
+          </ac:spMkLst>
+        </pc:spChg>
+        <pc:spChg chg="add mod">
+          <ac:chgData name="Hemma Philamore" userId="db50e2f3-17b2-4cc0-b719-fb6254d3e9df" providerId="ADAL" clId="{976AD799-FE43-55CA-A221-11B5AB66B93B}" dt="2026-10-26T14:02:40.590" v="177" actId="1076"/>
+          <ac:spMkLst>
+            <pc:docMk/>
+            <pc:sldMk cId="818822214" sldId="258"/>
+            <ac:spMk id="7" creationId="{91D8E25D-1B4C-F9BC-6D09-A03B452EEF3D}"/>
+          </ac:spMkLst>
+        </pc:spChg>
+        <pc:spChg chg="add mod">
+          <ac:chgData name="Hemma Philamore" userId="db50e2f3-17b2-4cc0-b719-fb6254d3e9df" providerId="ADAL" clId="{976AD799-FE43-55CA-A221-11B5AB66B93B}" dt="2026-10-26T14:03:07.925" v="193" actId="1076"/>
+          <ac:spMkLst>
+            <pc:docMk/>
+            <pc:sldMk cId="818822214" sldId="258"/>
+            <ac:spMk id="8" creationId="{E0633738-F0B1-A4FD-DA17-78FA70ED5802}"/>
+          </ac:spMkLst>
+        </pc:spChg>
+        <pc:spChg chg="add mod">
+          <ac:chgData name="Hemma Philamore" userId="db50e2f3-17b2-4cc0-b719-fb6254d3e9df" providerId="ADAL" clId="{976AD799-FE43-55CA-A221-11B5AB66B93B}" dt="2026-10-26T14:03:38.125" v="203" actId="1076"/>
+          <ac:spMkLst>
+            <pc:docMk/>
+            <pc:sldMk cId="818822214" sldId="258"/>
+            <ac:spMk id="9" creationId="{63FA04A2-A263-3D7E-6B3B-5A206D134AA4}"/>
+          </ac:spMkLst>
+        </pc:spChg>
+        <pc:spChg chg="add mod">
+          <ac:chgData name="Hemma Philamore" userId="db50e2f3-17b2-4cc0-b719-fb6254d3e9df" providerId="ADAL" clId="{976AD799-FE43-55CA-A221-11B5AB66B93B}" dt="2026-10-26T14:06:24.895" v="239" actId="1076"/>
+          <ac:spMkLst>
+            <pc:docMk/>
+            <pc:sldMk cId="818822214" sldId="258"/>
+            <ac:spMk id="10" creationId="{711322C6-5D34-34D5-158F-F28376BB0BAC}"/>
+          </ac:spMkLst>
+        </pc:spChg>
+        <pc:spChg chg="topLvl">
+          <ac:chgData name="Hemma Philamore" userId="db50e2f3-17b2-4cc0-b719-fb6254d3e9df" providerId="ADAL" clId="{976AD799-FE43-55CA-A221-11B5AB66B93B}" dt="2026-10-26T14:02:00.479" v="143" actId="478"/>
+          <ac:spMkLst>
+            <pc:docMk/>
+            <pc:sldMk cId="818822214" sldId="258"/>
+            <ac:spMk id="12" creationId="{4D0FB3C7-9C73-BC39-5690-7EFF4A2894AF}"/>
+          </ac:spMkLst>
+        </pc:spChg>
+        <pc:spChg chg="del topLvl">
+          <ac:chgData name="Hemma Philamore" userId="db50e2f3-17b2-4cc0-b719-fb6254d3e9df" providerId="ADAL" clId="{976AD799-FE43-55CA-A221-11B5AB66B93B}" dt="2026-10-26T14:02:00.479" v="143" actId="478"/>
+          <ac:spMkLst>
+            <pc:docMk/>
+            <pc:sldMk cId="818822214" sldId="258"/>
+            <ac:spMk id="13" creationId="{37B39678-CCA2-2160-EE6B-F3FFA9DE56F5}"/>
+          </ac:spMkLst>
+        </pc:spChg>
+        <pc:spChg chg="topLvl">
+          <ac:chgData name="Hemma Philamore" userId="db50e2f3-17b2-4cc0-b719-fb6254d3e9df" providerId="ADAL" clId="{976AD799-FE43-55CA-A221-11B5AB66B93B}" dt="2026-10-26T14:01:57.370" v="142" actId="165"/>
+          <ac:spMkLst>
+            <pc:docMk/>
+            <pc:sldMk cId="818822214" sldId="258"/>
+            <ac:spMk id="15" creationId="{075391DC-F7E3-F41D-1365-DF93FA2D0B76}"/>
+          </ac:spMkLst>
+        </pc:spChg>
+        <pc:spChg chg="del">
+          <ac:chgData name="Hemma Philamore" userId="db50e2f3-17b2-4cc0-b719-fb6254d3e9df" providerId="ADAL" clId="{976AD799-FE43-55CA-A221-11B5AB66B93B}" dt="2026-10-26T14:01:52.136" v="141" actId="478"/>
+          <ac:spMkLst>
+            <pc:docMk/>
+            <pc:sldMk cId="818822214" sldId="258"/>
+            <ac:spMk id="16" creationId="{D27389F5-42BB-3C70-DE01-14C4C4FE654F}"/>
+          </ac:spMkLst>
+        </pc:spChg>
+        <pc:spChg chg="topLvl">
+          <ac:chgData name="Hemma Philamore" userId="db50e2f3-17b2-4cc0-b719-fb6254d3e9df" providerId="ADAL" clId="{976AD799-FE43-55CA-A221-11B5AB66B93B}" dt="2026-10-26T14:02:02.304" v="144" actId="478"/>
+          <ac:spMkLst>
+            <pc:docMk/>
+            <pc:sldMk cId="818822214" sldId="258"/>
+            <ac:spMk id="18" creationId="{FB009A0A-1C4C-CCAF-7B85-986E3BB01521}"/>
+          </ac:spMkLst>
+        </pc:spChg>
+        <pc:spChg chg="del topLvl">
+          <ac:chgData name="Hemma Philamore" userId="db50e2f3-17b2-4cc0-b719-fb6254d3e9df" providerId="ADAL" clId="{976AD799-FE43-55CA-A221-11B5AB66B93B}" dt="2026-10-26T14:02:02.304" v="144" actId="478"/>
+          <ac:spMkLst>
+            <pc:docMk/>
+            <pc:sldMk cId="818822214" sldId="258"/>
+            <ac:spMk id="19" creationId="{7405E25B-B77D-65B9-058C-63428652E40E}"/>
+          </ac:spMkLst>
+        </pc:spChg>
+        <pc:spChg chg="topLvl">
+          <ac:chgData name="Hemma Philamore" userId="db50e2f3-17b2-4cc0-b719-fb6254d3e9df" providerId="ADAL" clId="{976AD799-FE43-55CA-A221-11B5AB66B93B}" dt="2026-10-26T14:01:57.370" v="142" actId="165"/>
+          <ac:spMkLst>
+            <pc:docMk/>
+            <pc:sldMk cId="818822214" sldId="258"/>
+            <ac:spMk id="21" creationId="{62B9B986-9CBD-1052-25FD-39E6133B2A70}"/>
+          </ac:spMkLst>
+        </pc:spChg>
+        <pc:spChg chg="del">
+          <ac:chgData name="Hemma Philamore" userId="db50e2f3-17b2-4cc0-b719-fb6254d3e9df" providerId="ADAL" clId="{976AD799-FE43-55CA-A221-11B5AB66B93B}" dt="2026-10-26T14:01:49.624" v="140" actId="478"/>
+          <ac:spMkLst>
+            <pc:docMk/>
+            <pc:sldMk cId="818822214" sldId="258"/>
+            <ac:spMk id="22" creationId="{C2F1FDE3-3920-1024-B120-E47CA3F25E3D}"/>
+          </ac:spMkLst>
+        </pc:spChg>
+        <pc:spChg chg="add mod">
+          <ac:chgData name="Hemma Philamore" userId="db50e2f3-17b2-4cc0-b719-fb6254d3e9df" providerId="ADAL" clId="{976AD799-FE43-55CA-A221-11B5AB66B93B}" dt="2026-10-26T14:07:37.863" v="263" actId="14100"/>
+          <ac:spMkLst>
+            <pc:docMk/>
+            <pc:sldMk cId="818822214" sldId="258"/>
+            <ac:spMk id="23" creationId="{446A178C-C437-313B-ED62-CE951E3F45F1}"/>
+          </ac:spMkLst>
+        </pc:spChg>
+        <pc:spChg chg="add del mod">
+          <ac:chgData name="Hemma Philamore" userId="db50e2f3-17b2-4cc0-b719-fb6254d3e9df" providerId="ADAL" clId="{976AD799-FE43-55CA-A221-11B5AB66B93B}" dt="2026-10-26T14:09:09.289" v="279" actId="478"/>
+          <ac:spMkLst>
+            <pc:docMk/>
+            <pc:sldMk cId="818822214" sldId="258"/>
+            <ac:spMk id="24" creationId="{6D790245-D61A-359E-E774-41FB675737AA}"/>
+          </ac:spMkLst>
+        </pc:spChg>
+        <pc:spChg chg="add del mod">
+          <ac:chgData name="Hemma Philamore" userId="db50e2f3-17b2-4cc0-b719-fb6254d3e9df" providerId="ADAL" clId="{976AD799-FE43-55CA-A221-11B5AB66B93B}" dt="2026-10-26T14:09:11.689" v="281" actId="478"/>
+          <ac:spMkLst>
+            <pc:docMk/>
+            <pc:sldMk cId="818822214" sldId="258"/>
+            <ac:spMk id="25" creationId="{B23047DA-1FB2-6F32-5E7D-EEC547097651}"/>
+          </ac:spMkLst>
+        </pc:spChg>
+        <pc:spChg chg="mod topLvl">
+          <ac:chgData name="Hemma Philamore" userId="db50e2f3-17b2-4cc0-b719-fb6254d3e9df" providerId="ADAL" clId="{976AD799-FE43-55CA-A221-11B5AB66B93B}" dt="2026-10-26T14:10:18.109" v="295" actId="20577"/>
+          <ac:spMkLst>
+            <pc:docMk/>
+            <pc:sldMk cId="818822214" sldId="258"/>
+            <ac:spMk id="42" creationId="{DF004EF6-E142-1614-EE3B-1100C1965C40}"/>
+          </ac:spMkLst>
+        </pc:spChg>
+        <pc:spChg chg="mod topLvl">
+          <ac:chgData name="Hemma Philamore" userId="db50e2f3-17b2-4cc0-b719-fb6254d3e9df" providerId="ADAL" clId="{976AD799-FE43-55CA-A221-11B5AB66B93B}" dt="2026-10-26T14:10:23.881" v="298" actId="20577"/>
+          <ac:spMkLst>
+            <pc:docMk/>
+            <pc:sldMk cId="818822214" sldId="258"/>
+            <ac:spMk id="43" creationId="{4A06994E-FB0B-7B1B-7212-5CABC63777CF}"/>
+          </ac:spMkLst>
+        </pc:spChg>
+        <pc:spChg chg="mod topLvl">
+          <ac:chgData name="Hemma Philamore" userId="db50e2f3-17b2-4cc0-b719-fb6254d3e9df" providerId="ADAL" clId="{976AD799-FE43-55CA-A221-11B5AB66B93B}" dt="2026-10-26T14:10:38.553" v="303" actId="20577"/>
+          <ac:spMkLst>
+            <pc:docMk/>
+            <pc:sldMk cId="818822214" sldId="258"/>
+            <ac:spMk id="44" creationId="{1426A36C-9368-D130-7B58-77E95C4566DD}"/>
+          </ac:spMkLst>
+        </pc:spChg>
+        <pc:spChg chg="del">
+          <ac:chgData name="Hemma Philamore" userId="db50e2f3-17b2-4cc0-b719-fb6254d3e9df" providerId="ADAL" clId="{976AD799-FE43-55CA-A221-11B5AB66B93B}" dt="2026-10-26T14:06:37.057" v="241" actId="478"/>
+          <ac:spMkLst>
+            <pc:docMk/>
+            <pc:sldMk cId="818822214" sldId="258"/>
+            <ac:spMk id="45" creationId="{9B01EE50-9BC2-915E-BFB6-C39B3AF6AD6C}"/>
+          </ac:spMkLst>
+        </pc:spChg>
+        <pc:spChg chg="mod topLvl">
+          <ac:chgData name="Hemma Philamore" userId="db50e2f3-17b2-4cc0-b719-fb6254d3e9df" providerId="ADAL" clId="{976AD799-FE43-55CA-A221-11B5AB66B93B}" dt="2026-10-26T14:10:30.327" v="302" actId="20577"/>
+          <ac:spMkLst>
+            <pc:docMk/>
+            <pc:sldMk cId="818822214" sldId="258"/>
+            <ac:spMk id="46" creationId="{FA7B7597-0100-DB49-F5FD-4C8F209EF168}"/>
+          </ac:spMkLst>
+        </pc:spChg>
+        <pc:spChg chg="mod topLvl">
+          <ac:chgData name="Hemma Philamore" userId="db50e2f3-17b2-4cc0-b719-fb6254d3e9df" providerId="ADAL" clId="{976AD799-FE43-55CA-A221-11B5AB66B93B}" dt="2026-10-26T14:10:20.520" v="297" actId="20577"/>
+          <ac:spMkLst>
+            <pc:docMk/>
+            <pc:sldMk cId="818822214" sldId="258"/>
+            <ac:spMk id="47" creationId="{985ED467-F9D2-E3D8-486F-C5B73DE24BEC}"/>
+          </ac:spMkLst>
+        </pc:spChg>
+        <pc:spChg chg="del mod topLvl">
+          <ac:chgData name="Hemma Philamore" userId="db50e2f3-17b2-4cc0-b719-fb6254d3e9df" providerId="ADAL" clId="{976AD799-FE43-55CA-A221-11B5AB66B93B}" dt="2026-10-26T14:08:51.817" v="276" actId="478"/>
+          <ac:spMkLst>
+            <pc:docMk/>
+            <pc:sldMk cId="818822214" sldId="258"/>
+            <ac:spMk id="48" creationId="{A50920EA-BEF7-BA04-465A-91FC90FDF5D5}"/>
+          </ac:spMkLst>
+        </pc:spChg>
+        <pc:spChg chg="mod topLvl">
+          <ac:chgData name="Hemma Philamore" userId="db50e2f3-17b2-4cc0-b719-fb6254d3e9df" providerId="ADAL" clId="{976AD799-FE43-55CA-A221-11B5AB66B93B}" dt="2026-10-26T14:10:27.207" v="300" actId="20577"/>
+          <ac:spMkLst>
+            <pc:docMk/>
+            <pc:sldMk cId="818822214" sldId="258"/>
+            <ac:spMk id="49" creationId="{2696082F-1587-CBC0-D621-0D22E15B2350}"/>
+          </ac:spMkLst>
+        </pc:spChg>
+        <pc:spChg chg="del">
+          <ac:chgData name="Hemma Philamore" userId="db50e2f3-17b2-4cc0-b719-fb6254d3e9df" providerId="ADAL" clId="{976AD799-FE43-55CA-A221-11B5AB66B93B}" dt="2026-10-26T14:11:47.891" v="324" actId="478"/>
+          <ac:spMkLst>
+            <pc:docMk/>
+            <pc:sldMk cId="818822214" sldId="258"/>
+            <ac:spMk id="86" creationId="{A64E81F8-9AFD-AEBD-C138-0E2EEEFEF570}"/>
+          </ac:spMkLst>
+        </pc:spChg>
+        <pc:spChg chg="add mod">
+          <ac:chgData name="Hemma Philamore" userId="db50e2f3-17b2-4cc0-b719-fb6254d3e9df" providerId="ADAL" clId="{976AD799-FE43-55CA-A221-11B5AB66B93B}" dt="2026-10-26T14:09:01.467" v="278" actId="1076"/>
+          <ac:spMkLst>
+            <pc:docMk/>
+            <pc:sldMk cId="818822214" sldId="258"/>
+            <ac:spMk id="87" creationId="{D1E39551-EB9F-48E5-8BD0-27DD519F263C}"/>
+          </ac:spMkLst>
+        </pc:spChg>
+        <pc:spChg chg="add del mod">
+          <ac:chgData name="Hemma Philamore" userId="db50e2f3-17b2-4cc0-b719-fb6254d3e9df" providerId="ADAL" clId="{976AD799-FE43-55CA-A221-11B5AB66B93B}" dt="2026-10-26T14:11:33.922" v="321" actId="478"/>
+          <ac:spMkLst>
+            <pc:docMk/>
+            <pc:sldMk cId="818822214" sldId="258"/>
+            <ac:spMk id="88" creationId="{1B379102-956F-C630-2A1D-3B8154491BFD}"/>
+          </ac:spMkLst>
+        </pc:spChg>
+        <pc:spChg chg="del">
+          <ac:chgData name="Hemma Philamore" userId="db50e2f3-17b2-4cc0-b719-fb6254d3e9df" providerId="ADAL" clId="{976AD799-FE43-55CA-A221-11B5AB66B93B}" dt="2026-10-26T14:11:33.922" v="321" actId="478"/>
+          <ac:spMkLst>
+            <pc:docMk/>
+            <pc:sldMk cId="818822214" sldId="258"/>
+            <ac:spMk id="98" creationId="{5C52D5CC-F625-4F5F-5FE0-054921630E7F}"/>
+          </ac:spMkLst>
+        </pc:spChg>
+        <pc:spChg chg="add mod">
+          <ac:chgData name="Hemma Philamore" userId="db50e2f3-17b2-4cc0-b719-fb6254d3e9df" providerId="ADAL" clId="{976AD799-FE43-55CA-A221-11B5AB66B93B}" dt="2026-10-26T14:09:01.467" v="278" actId="1076"/>
+          <ac:spMkLst>
+            <pc:docMk/>
+            <pc:sldMk cId="818822214" sldId="258"/>
+            <ac:spMk id="99" creationId="{93638AF1-46D6-09AA-F2C9-480FC5A6A7F6}"/>
+          </ac:spMkLst>
+        </pc:spChg>
+        <pc:spChg chg="add mod">
+          <ac:chgData name="Hemma Philamore" userId="db50e2f3-17b2-4cc0-b719-fb6254d3e9df" providerId="ADAL" clId="{976AD799-FE43-55CA-A221-11B5AB66B93B}" dt="2026-10-26T14:09:01.467" v="278" actId="1076"/>
+          <ac:spMkLst>
+            <pc:docMk/>
+            <pc:sldMk cId="818822214" sldId="258"/>
+            <ac:spMk id="100" creationId="{2EBD65D6-364C-48C0-08FF-186EC69538CF}"/>
+          </ac:spMkLst>
+        </pc:spChg>
+        <pc:spChg chg="add del mod">
+          <ac:chgData name="Hemma Philamore" userId="db50e2f3-17b2-4cc0-b719-fb6254d3e9df" providerId="ADAL" clId="{976AD799-FE43-55CA-A221-11B5AB66B93B}" dt="2026-10-26T14:11:33.922" v="321" actId="478"/>
+          <ac:spMkLst>
+            <pc:docMk/>
+            <pc:sldMk cId="818822214" sldId="258"/>
+            <ac:spMk id="101" creationId="{F904DC4D-9F7E-F78D-A308-4A18D42B6A3E}"/>
+          </ac:spMkLst>
+        </pc:spChg>
+        <pc:spChg chg="add del mod">
+          <ac:chgData name="Hemma Philamore" userId="db50e2f3-17b2-4cc0-b719-fb6254d3e9df" providerId="ADAL" clId="{976AD799-FE43-55CA-A221-11B5AB66B93B}" dt="2026-10-26T14:11:33.922" v="321" actId="478"/>
+          <ac:spMkLst>
+            <pc:docMk/>
+            <pc:sldMk cId="818822214" sldId="258"/>
+            <ac:spMk id="102" creationId="{B31EEC6E-D870-6915-276A-5DB3CD5AC11A}"/>
+          </ac:spMkLst>
+        </pc:spChg>
+        <pc:spChg chg="del">
+          <ac:chgData name="Hemma Philamore" userId="db50e2f3-17b2-4cc0-b719-fb6254d3e9df" providerId="ADAL" clId="{976AD799-FE43-55CA-A221-11B5AB66B93B}" dt="2026-10-26T14:11:33.922" v="321" actId="478"/>
+          <ac:spMkLst>
+            <pc:docMk/>
+            <pc:sldMk cId="818822214" sldId="258"/>
+            <ac:spMk id="103" creationId="{8B35FF13-F2F2-46A1-36ED-610A37714B79}"/>
+          </ac:spMkLst>
+        </pc:spChg>
+        <pc:spChg chg="del">
+          <ac:chgData name="Hemma Philamore" userId="db50e2f3-17b2-4cc0-b719-fb6254d3e9df" providerId="ADAL" clId="{976AD799-FE43-55CA-A221-11B5AB66B93B}" dt="2026-10-26T14:11:33.922" v="321" actId="478"/>
+          <ac:spMkLst>
+            <pc:docMk/>
+            <pc:sldMk cId="818822214" sldId="258"/>
+            <ac:spMk id="104" creationId="{475AE8FD-5901-9B93-9142-F719F6D63E9D}"/>
+          </ac:spMkLst>
+        </pc:spChg>
+        <pc:spChg chg="add del mod">
+          <ac:chgData name="Hemma Philamore" userId="db50e2f3-17b2-4cc0-b719-fb6254d3e9df" providerId="ADAL" clId="{976AD799-FE43-55CA-A221-11B5AB66B93B}" dt="2026-10-26T14:11:49.514" v="325" actId="478"/>
+          <ac:spMkLst>
+            <pc:docMk/>
+            <pc:sldMk cId="818822214" sldId="258"/>
+            <ac:spMk id="105" creationId="{10FFC99D-E1C2-D2DC-6FAB-C80FAB7789A3}"/>
+          </ac:spMkLst>
+        </pc:spChg>
+        <pc:spChg chg="add del mod">
+          <ac:chgData name="Hemma Philamore" userId="db50e2f3-17b2-4cc0-b719-fb6254d3e9df" providerId="ADAL" clId="{976AD799-FE43-55CA-A221-11B5AB66B93B}" dt="2026-10-26T14:11:33.922" v="321" actId="478"/>
+          <ac:spMkLst>
+            <pc:docMk/>
+            <pc:sldMk cId="818822214" sldId="258"/>
+            <ac:spMk id="106" creationId="{D8899B61-8B8D-95A3-4E9C-FFD41EF5A09F}"/>
+          </ac:spMkLst>
+        </pc:spChg>
+        <pc:spChg chg="del">
+          <ac:chgData name="Hemma Philamore" userId="db50e2f3-17b2-4cc0-b719-fb6254d3e9df" providerId="ADAL" clId="{976AD799-FE43-55CA-A221-11B5AB66B93B}" dt="2026-10-26T14:11:33.922" v="321" actId="478"/>
+          <ac:spMkLst>
+            <pc:docMk/>
+            <pc:sldMk cId="818822214" sldId="258"/>
+            <ac:spMk id="107" creationId="{82FA24D6-D964-25AF-2A1B-7E46FAC75E74}"/>
+          </ac:spMkLst>
+        </pc:spChg>
+        <pc:spChg chg="del">
+          <ac:chgData name="Hemma Philamore" userId="db50e2f3-17b2-4cc0-b719-fb6254d3e9df" providerId="ADAL" clId="{976AD799-FE43-55CA-A221-11B5AB66B93B}" dt="2026-10-26T14:11:33.922" v="321" actId="478"/>
+          <ac:spMkLst>
+            <pc:docMk/>
+            <pc:sldMk cId="818822214" sldId="258"/>
+            <ac:spMk id="108" creationId="{A251CB68-F817-4C3B-AECD-DE75AFC10DFB}"/>
+          </ac:spMkLst>
+        </pc:spChg>
+        <pc:spChg chg="del">
+          <ac:chgData name="Hemma Philamore" userId="db50e2f3-17b2-4cc0-b719-fb6254d3e9df" providerId="ADAL" clId="{976AD799-FE43-55CA-A221-11B5AB66B93B}" dt="2026-10-26T14:11:33.922" v="321" actId="478"/>
+          <ac:spMkLst>
+            <pc:docMk/>
+            <pc:sldMk cId="818822214" sldId="258"/>
+            <ac:spMk id="110" creationId="{1127DE7C-EF36-BB85-89C5-B7BC5B1DFC78}"/>
+          </ac:spMkLst>
+        </pc:spChg>
+        <pc:spChg chg="add mod topLvl">
+          <ac:chgData name="Hemma Philamore" userId="db50e2f3-17b2-4cc0-b719-fb6254d3e9df" providerId="ADAL" clId="{976AD799-FE43-55CA-A221-11B5AB66B93B}" dt="2026-10-26T14:12:05.777" v="328" actId="14100"/>
+          <ac:spMkLst>
+            <pc:docMk/>
+            <pc:sldMk cId="818822214" sldId="258"/>
+            <ac:spMk id="111" creationId="{C63B4B8F-493B-2448-8664-868D2B4C7003}"/>
+          </ac:spMkLst>
+        </pc:spChg>
+        <pc:spChg chg="add mod topLvl">
+          <ac:chgData name="Hemma Philamore" userId="db50e2f3-17b2-4cc0-b719-fb6254d3e9df" providerId="ADAL" clId="{976AD799-FE43-55CA-A221-11B5AB66B93B}" dt="2026-10-26T14:12:05.777" v="328" actId="14100"/>
+          <ac:spMkLst>
+            <pc:docMk/>
+            <pc:sldMk cId="818822214" sldId="258"/>
+            <ac:spMk id="112" creationId="{7EE30EA5-128D-9698-1BEA-DA7102282D15}"/>
+          </ac:spMkLst>
+        </pc:spChg>
+        <pc:spChg chg="add mod">
+          <ac:chgData name="Hemma Philamore" userId="db50e2f3-17b2-4cc0-b719-fb6254d3e9df" providerId="ADAL" clId="{976AD799-FE43-55CA-A221-11B5AB66B93B}" dt="2026-10-26T14:10:48.440" v="307" actId="20577"/>
+          <ac:spMkLst>
+            <pc:docMk/>
+            <pc:sldMk cId="818822214" sldId="258"/>
+            <ac:spMk id="118" creationId="{43132931-2181-0358-9025-FE93DECC5822}"/>
+          </ac:spMkLst>
+        </pc:spChg>
+        <pc:spChg chg="add mod">
+          <ac:chgData name="Hemma Philamore" userId="db50e2f3-17b2-4cc0-b719-fb6254d3e9df" providerId="ADAL" clId="{976AD799-FE43-55CA-A221-11B5AB66B93B}" dt="2026-10-26T14:10:55.557" v="311" actId="20577"/>
+          <ac:spMkLst>
+            <pc:docMk/>
+            <pc:sldMk cId="818822214" sldId="258"/>
+            <ac:spMk id="119" creationId="{318F769D-6D75-FEF3-8629-50C3B3EEB1A8}"/>
+          </ac:spMkLst>
+        </pc:spChg>
+        <pc:spChg chg="add mod">
+          <ac:chgData name="Hemma Philamore" userId="db50e2f3-17b2-4cc0-b719-fb6254d3e9df" providerId="ADAL" clId="{976AD799-FE43-55CA-A221-11B5AB66B93B}" dt="2026-10-26T14:11:02.473" v="315" actId="20577"/>
+          <ac:spMkLst>
+            <pc:docMk/>
+            <pc:sldMk cId="818822214" sldId="258"/>
+            <ac:spMk id="120" creationId="{73BA9F1C-4011-3116-9BC8-7808AB74D149}"/>
+          </ac:spMkLst>
+        </pc:spChg>
+        <pc:spChg chg="add mod">
+          <ac:chgData name="Hemma Philamore" userId="db50e2f3-17b2-4cc0-b719-fb6254d3e9df" providerId="ADAL" clId="{976AD799-FE43-55CA-A221-11B5AB66B93B}" dt="2026-10-26T14:11:09.559" v="318" actId="20577"/>
+          <ac:spMkLst>
+            <pc:docMk/>
+            <pc:sldMk cId="818822214" sldId="258"/>
+            <ac:spMk id="121" creationId="{DC4ACEFF-F814-4908-3FEC-A05988081730}"/>
+          </ac:spMkLst>
+        </pc:spChg>
+        <pc:spChg chg="add mod">
+          <ac:chgData name="Hemma Philamore" userId="db50e2f3-17b2-4cc0-b719-fb6254d3e9df" providerId="ADAL" clId="{976AD799-FE43-55CA-A221-11B5AB66B93B}" dt="2026-10-26T14:11:46.076" v="323" actId="1076"/>
+          <ac:spMkLst>
+            <pc:docMk/>
+            <pc:sldMk cId="818822214" sldId="258"/>
+            <ac:spMk id="124" creationId="{A13F0B98-D814-9718-9925-D2611AAF5D33}"/>
+          </ac:spMkLst>
+        </pc:spChg>
+        <pc:spChg chg="add mod">
+          <ac:chgData name="Hemma Philamore" userId="db50e2f3-17b2-4cc0-b719-fb6254d3e9df" providerId="ADAL" clId="{976AD799-FE43-55CA-A221-11B5AB66B93B}" dt="2026-10-26T14:11:46.076" v="323" actId="1076"/>
+          <ac:spMkLst>
+            <pc:docMk/>
+            <pc:sldMk cId="818822214" sldId="258"/>
+            <ac:spMk id="127" creationId="{FA0EAEB6-933C-0344-DB08-6E57355F2543}"/>
+          </ac:spMkLst>
+        </pc:spChg>
+        <pc:spChg chg="add mod">
+          <ac:chgData name="Hemma Philamore" userId="db50e2f3-17b2-4cc0-b719-fb6254d3e9df" providerId="ADAL" clId="{976AD799-FE43-55CA-A221-11B5AB66B93B}" dt="2026-10-26T14:12:14.799" v="330" actId="1076"/>
+          <ac:spMkLst>
+            <pc:docMk/>
+            <pc:sldMk cId="818822214" sldId="258"/>
+            <ac:spMk id="136" creationId="{40925F2C-3F02-51B7-F32A-7B2C595EA570}"/>
+          </ac:spMkLst>
+        </pc:spChg>
+        <pc:spChg chg="add mod">
+          <ac:chgData name="Hemma Philamore" userId="db50e2f3-17b2-4cc0-b719-fb6254d3e9df" providerId="ADAL" clId="{976AD799-FE43-55CA-A221-11B5AB66B93B}" dt="2026-10-26T14:11:46.076" v="323" actId="1076"/>
+          <ac:spMkLst>
+            <pc:docMk/>
+            <pc:sldMk cId="818822214" sldId="258"/>
+            <ac:spMk id="138" creationId="{6BDBCF13-8BD8-8619-F8B6-8F1959B8F78C}"/>
+          </ac:spMkLst>
+        </pc:spChg>
+        <pc:spChg chg="mod">
+          <ac:chgData name="Hemma Philamore" userId="db50e2f3-17b2-4cc0-b719-fb6254d3e9df" providerId="ADAL" clId="{976AD799-FE43-55CA-A221-11B5AB66B93B}" dt="2026-10-26T14:15:27.489" v="346" actId="207"/>
+          <ac:spMkLst>
+            <pc:docMk/>
+            <pc:sldMk cId="818822214" sldId="258"/>
+            <ac:spMk id="139" creationId="{B43BD31F-F83A-5776-2940-6634DB822B8F}"/>
+          </ac:spMkLst>
+        </pc:spChg>
+        <pc:spChg chg="add mod">
+          <ac:chgData name="Hemma Philamore" userId="db50e2f3-17b2-4cc0-b719-fb6254d3e9df" providerId="ADAL" clId="{976AD799-FE43-55CA-A221-11B5AB66B93B}" dt="2026-10-26T14:11:46.076" v="323" actId="1076"/>
+          <ac:spMkLst>
+            <pc:docMk/>
+            <pc:sldMk cId="818822214" sldId="258"/>
+            <ac:spMk id="142" creationId="{CEAF4C90-AE2C-7827-DCF3-2A271ECD185B}"/>
+          </ac:spMkLst>
+        </pc:spChg>
+        <pc:spChg chg="add mod">
+          <ac:chgData name="Hemma Philamore" userId="db50e2f3-17b2-4cc0-b719-fb6254d3e9df" providerId="ADAL" clId="{976AD799-FE43-55CA-A221-11B5AB66B93B}" dt="2026-10-26T14:11:46.076" v="323" actId="1076"/>
+          <ac:spMkLst>
+            <pc:docMk/>
+            <pc:sldMk cId="818822214" sldId="258"/>
+            <ac:spMk id="145" creationId="{682D751E-1538-A972-A34E-222CAC8E8C43}"/>
+          </ac:spMkLst>
+        </pc:spChg>
+        <pc:spChg chg="add mod">
+          <ac:chgData name="Hemma Philamore" userId="db50e2f3-17b2-4cc0-b719-fb6254d3e9df" providerId="ADAL" clId="{976AD799-FE43-55CA-A221-11B5AB66B93B}" dt="2026-10-26T14:11:46.076" v="323" actId="1076"/>
+          <ac:spMkLst>
+            <pc:docMk/>
+            <pc:sldMk cId="818822214" sldId="258"/>
+            <ac:spMk id="147" creationId="{7236C944-3E04-C958-3E18-0DA0EA763104}"/>
+          </ac:spMkLst>
+        </pc:spChg>
+        <pc:spChg chg="add mod">
+          <ac:chgData name="Hemma Philamore" userId="db50e2f3-17b2-4cc0-b719-fb6254d3e9df" providerId="ADAL" clId="{976AD799-FE43-55CA-A221-11B5AB66B93B}" dt="2026-10-26T14:11:46.076" v="323" actId="1076"/>
+          <ac:spMkLst>
+            <pc:docMk/>
+            <pc:sldMk cId="818822214" sldId="258"/>
+            <ac:spMk id="148" creationId="{FB687C8D-F8B7-55E4-00D4-FCF77A06E4F2}"/>
+          </ac:spMkLst>
+        </pc:spChg>
+        <pc:spChg chg="add mod">
+          <ac:chgData name="Hemma Philamore" userId="db50e2f3-17b2-4cc0-b719-fb6254d3e9df" providerId="ADAL" clId="{976AD799-FE43-55CA-A221-11B5AB66B93B}" dt="2026-10-26T14:11:46.076" v="323" actId="1076"/>
+          <ac:spMkLst>
+            <pc:docMk/>
+            <pc:sldMk cId="818822214" sldId="258"/>
+            <ac:spMk id="153" creationId="{34D013CB-DB02-4605-84C3-37CF024F87BF}"/>
+          </ac:spMkLst>
+        </pc:spChg>
+        <pc:spChg chg="add mod">
+          <ac:chgData name="Hemma Philamore" userId="db50e2f3-17b2-4cc0-b719-fb6254d3e9df" providerId="ADAL" clId="{976AD799-FE43-55CA-A221-11B5AB66B93B}" dt="2026-10-26T14:11:46.076" v="323" actId="1076"/>
+          <ac:spMkLst>
+            <pc:docMk/>
+            <pc:sldMk cId="818822214" sldId="258"/>
+            <ac:spMk id="154" creationId="{D94AEBCF-43E1-DC16-2798-C6F633CF38D6}"/>
+          </ac:spMkLst>
+        </pc:spChg>
+        <pc:spChg chg="add mod">
+          <ac:chgData name="Hemma Philamore" userId="db50e2f3-17b2-4cc0-b719-fb6254d3e9df" providerId="ADAL" clId="{976AD799-FE43-55CA-A221-11B5AB66B93B}" dt="2026-10-26T14:12:29.672" v="337" actId="207"/>
+          <ac:spMkLst>
+            <pc:docMk/>
+            <pc:sldMk cId="818822214" sldId="258"/>
+            <ac:spMk id="157" creationId="{0502A777-EFA5-D949-964E-161252600201}"/>
+          </ac:spMkLst>
+        </pc:spChg>
+        <pc:spChg chg="add mod">
+          <ac:chgData name="Hemma Philamore" userId="db50e2f3-17b2-4cc0-b719-fb6254d3e9df" providerId="ADAL" clId="{976AD799-FE43-55CA-A221-11B5AB66B93B}" dt="2026-10-26T14:12:39.720" v="341" actId="20577"/>
+          <ac:spMkLst>
+            <pc:docMk/>
+            <pc:sldMk cId="818822214" sldId="258"/>
+            <ac:spMk id="158" creationId="{7B05C46F-4A21-E57B-EF67-C89DE45F63EC}"/>
+          </ac:spMkLst>
+        </pc:spChg>
+        <pc:spChg chg="add mod">
+          <ac:chgData name="Hemma Philamore" userId="db50e2f3-17b2-4cc0-b719-fb6254d3e9df" providerId="ADAL" clId="{976AD799-FE43-55CA-A221-11B5AB66B93B}" dt="2026-10-26T14:12:48.298" v="344" actId="20577"/>
+          <ac:spMkLst>
+            <pc:docMk/>
+            <pc:sldMk cId="818822214" sldId="258"/>
+            <ac:spMk id="159" creationId="{427A000A-9BA2-4FF6-1BB1-EC4FAF0F5DCA}"/>
+          </ac:spMkLst>
+        </pc:spChg>
+        <pc:grpChg chg="del">
+          <ac:chgData name="Hemma Philamore" userId="db50e2f3-17b2-4cc0-b719-fb6254d3e9df" providerId="ADAL" clId="{976AD799-FE43-55CA-A221-11B5AB66B93B}" dt="2026-10-26T14:01:37.096" v="131" actId="478"/>
+          <ac:grpSpMkLst>
+            <pc:docMk/>
+            <pc:sldMk cId="818822214" sldId="258"/>
+            <ac:grpSpMk id="4" creationId="{22B12B85-67C8-67AE-6EC9-5721AFCA6E35}"/>
+          </ac:grpSpMkLst>
+        </pc:grpChg>
+        <pc:grpChg chg="del">
+          <ac:chgData name="Hemma Philamore" userId="db50e2f3-17b2-4cc0-b719-fb6254d3e9df" providerId="ADAL" clId="{976AD799-FE43-55CA-A221-11B5AB66B93B}" dt="2026-10-26T14:02:00.479" v="143" actId="478"/>
+          <ac:grpSpMkLst>
+            <pc:docMk/>
+            <pc:sldMk cId="818822214" sldId="258"/>
+            <ac:grpSpMk id="11" creationId="{540E5583-671A-AB53-F7C1-4C8D6385EB20}"/>
+          </ac:grpSpMkLst>
+        </pc:grpChg>
+        <pc:grpChg chg="del">
+          <ac:chgData name="Hemma Philamore" userId="db50e2f3-17b2-4cc0-b719-fb6254d3e9df" providerId="ADAL" clId="{976AD799-FE43-55CA-A221-11B5AB66B93B}" dt="2026-10-26T14:01:52.136" v="141" actId="478"/>
+          <ac:grpSpMkLst>
+            <pc:docMk/>
+            <pc:sldMk cId="818822214" sldId="258"/>
+            <ac:grpSpMk id="14" creationId="{FB3D31BC-71B8-BC20-228C-02224D7FCD47}"/>
+          </ac:grpSpMkLst>
+        </pc:grpChg>
+        <pc:grpChg chg="del">
+          <ac:chgData name="Hemma Philamore" userId="db50e2f3-17b2-4cc0-b719-fb6254d3e9df" providerId="ADAL" clId="{976AD799-FE43-55CA-A221-11B5AB66B93B}" dt="2026-10-26T14:02:02.304" v="144" actId="478"/>
+          <ac:grpSpMkLst>
+            <pc:docMk/>
+            <pc:sldMk cId="818822214" sldId="258"/>
+            <ac:grpSpMk id="17" creationId="{31C4B1DA-162D-55C0-8DC3-72BF4E4F6CB7}"/>
+          </ac:grpSpMkLst>
+        </pc:grpChg>
+        <pc:grpChg chg="del">
+          <ac:chgData name="Hemma Philamore" userId="db50e2f3-17b2-4cc0-b719-fb6254d3e9df" providerId="ADAL" clId="{976AD799-FE43-55CA-A221-11B5AB66B93B}" dt="2026-10-26T14:01:49.624" v="140" actId="478"/>
+          <ac:grpSpMkLst>
+            <pc:docMk/>
+            <pc:sldMk cId="818822214" sldId="258"/>
+            <ac:grpSpMk id="20" creationId="{F317DAEE-B729-0B48-0D93-60B2EDB14E03}"/>
+          </ac:grpSpMkLst>
+        </pc:grpChg>
+        <pc:grpChg chg="del">
+          <ac:chgData name="Hemma Philamore" userId="db50e2f3-17b2-4cc0-b719-fb6254d3e9df" providerId="ADAL" clId="{976AD799-FE43-55CA-A221-11B5AB66B93B}" dt="2026-10-26T14:06:39.283" v="242" actId="478"/>
+          <ac:grpSpMkLst>
+            <pc:docMk/>
+            <pc:sldMk cId="818822214" sldId="258"/>
+            <ac:grpSpMk id="83" creationId="{814F435E-6190-F88F-A253-966894EB682F}"/>
+          </ac:grpSpMkLst>
+        </pc:grpChg>
+        <pc:grpChg chg="add del mod">
+          <ac:chgData name="Hemma Philamore" userId="db50e2f3-17b2-4cc0-b719-fb6254d3e9df" providerId="ADAL" clId="{976AD799-FE43-55CA-A221-11B5AB66B93B}" dt="2026-10-26T14:12:03.493" v="327" actId="165"/>
+          <ac:grpSpMkLst>
+            <pc:docMk/>
+            <pc:sldMk cId="818822214" sldId="258"/>
+            <ac:grpSpMk id="122" creationId="{AEC02C9C-D68C-FCA7-2B3D-1E8961BE3C53}"/>
+          </ac:grpSpMkLst>
+        </pc:grpChg>
+        <pc:grpChg chg="add">
+          <ac:chgData name="Hemma Philamore" userId="db50e2f3-17b2-4cc0-b719-fb6254d3e9df" providerId="ADAL" clId="{976AD799-FE43-55CA-A221-11B5AB66B93B}" dt="2026-10-26T14:29:08.554" v="347" actId="164"/>
+          <ac:grpSpMkLst>
+            <pc:docMk/>
+            <pc:sldMk cId="818822214" sldId="258"/>
+            <ac:grpSpMk id="160" creationId="{4D364052-1EEB-5527-BCED-6D322E3256DD}"/>
+          </ac:grpSpMkLst>
+        </pc:grpChg>
+        <pc:grpChg chg="add">
+          <ac:chgData name="Hemma Philamore" userId="db50e2f3-17b2-4cc0-b719-fb6254d3e9df" providerId="ADAL" clId="{976AD799-FE43-55CA-A221-11B5AB66B93B}" dt="2026-10-26T14:29:15.369" v="348" actId="164"/>
+          <ac:grpSpMkLst>
+            <pc:docMk/>
+            <pc:sldMk cId="818822214" sldId="258"/>
+            <ac:grpSpMk id="161" creationId="{5D5FE7F6-109B-74A6-AA89-B1E5CBDBA62B}"/>
+          </ac:grpSpMkLst>
+        </pc:grpChg>
+        <pc:cxnChg chg="add mod">
+          <ac:chgData name="Hemma Philamore" userId="db50e2f3-17b2-4cc0-b719-fb6254d3e9df" providerId="ADAL" clId="{976AD799-FE43-55CA-A221-11B5AB66B93B}" dt="2026-10-26T14:08:37.504" v="270" actId="692"/>
+          <ac:cxnSpMkLst>
+            <pc:docMk/>
+            <pc:sldMk cId="818822214" sldId="258"/>
+            <ac:cxnSpMk id="28" creationId="{CA1D45DC-2FC8-6888-A955-02E09D868AC1}"/>
+          </ac:cxnSpMkLst>
+        </pc:cxnChg>
+        <pc:cxnChg chg="add del mod">
+          <ac:chgData name="Hemma Philamore" userId="db50e2f3-17b2-4cc0-b719-fb6254d3e9df" providerId="ADAL" clId="{976AD799-FE43-55CA-A221-11B5AB66B93B}" dt="2026-10-26T14:09:10.125" v="280" actId="478"/>
+          <ac:cxnSpMkLst>
+            <pc:docMk/>
+            <pc:sldMk cId="818822214" sldId="258"/>
+            <ac:cxnSpMk id="30" creationId="{09BF18E2-9024-11E2-149E-97E22F00B8A4}"/>
+          </ac:cxnSpMkLst>
+        </pc:cxnChg>
+        <pc:cxnChg chg="add del mod">
+          <ac:chgData name="Hemma Philamore" userId="db50e2f3-17b2-4cc0-b719-fb6254d3e9df" providerId="ADAL" clId="{976AD799-FE43-55CA-A221-11B5AB66B93B}" dt="2026-10-26T14:08:07.553" v="265" actId="478"/>
+          <ac:cxnSpMkLst>
+            <pc:docMk/>
+            <pc:sldMk cId="818822214" sldId="258"/>
+            <ac:cxnSpMk id="36" creationId="{90CE0A25-84B8-79BE-E353-4F6F7105A194}"/>
+          </ac:cxnSpMkLst>
+        </pc:cxnChg>
+        <pc:cxnChg chg="add del mod">
+          <ac:chgData name="Hemma Philamore" userId="db50e2f3-17b2-4cc0-b719-fb6254d3e9df" providerId="ADAL" clId="{976AD799-FE43-55CA-A221-11B5AB66B93B}" dt="2026-10-26T14:09:12.578" v="282" actId="478"/>
+          <ac:cxnSpMkLst>
+            <pc:docMk/>
+            <pc:sldMk cId="818822214" sldId="258"/>
+            <ac:cxnSpMk id="38" creationId="{3A2415BE-8554-E720-F22C-9B68A7D7150C}"/>
+          </ac:cxnSpMkLst>
+        </pc:cxnChg>
+        <pc:cxnChg chg="add del mod">
+          <ac:chgData name="Hemma Philamore" userId="db50e2f3-17b2-4cc0-b719-fb6254d3e9df" providerId="ADAL" clId="{976AD799-FE43-55CA-A221-11B5AB66B93B}" dt="2026-10-26T14:09:13.671" v="283" actId="478"/>
+          <ac:cxnSpMkLst>
+            <pc:docMk/>
+            <pc:sldMk cId="818822214" sldId="258"/>
+            <ac:cxnSpMk id="40" creationId="{3B4CE793-F989-BB95-0D5B-0F1096030130}"/>
+          </ac:cxnSpMkLst>
+        </pc:cxnChg>
+        <pc:cxnChg chg="mod">
+          <ac:chgData name="Hemma Philamore" userId="db50e2f3-17b2-4cc0-b719-fb6254d3e9df" providerId="ADAL" clId="{976AD799-FE43-55CA-A221-11B5AB66B93B}" dt="2026-10-26T14:06:39.283" v="242" actId="478"/>
+          <ac:cxnSpMkLst>
+            <pc:docMk/>
+            <pc:sldMk cId="818822214" sldId="258"/>
+            <ac:cxnSpMk id="57" creationId="{97D9D18C-9E7A-DFA9-FA4F-856527C788E4}"/>
+          </ac:cxnSpMkLst>
+        </pc:cxnChg>
+        <pc:cxnChg chg="mod">
+          <ac:chgData name="Hemma Philamore" userId="db50e2f3-17b2-4cc0-b719-fb6254d3e9df" providerId="ADAL" clId="{976AD799-FE43-55CA-A221-11B5AB66B93B}" dt="2026-10-26T14:06:39.283" v="242" actId="478"/>
+          <ac:cxnSpMkLst>
+            <pc:docMk/>
+            <pc:sldMk cId="818822214" sldId="258"/>
+            <ac:cxnSpMk id="58" creationId="{83B53E58-FA90-943D-D75F-C4C2A31E46DF}"/>
+          </ac:cxnSpMkLst>
+        </pc:cxnChg>
+        <pc:cxnChg chg="mod">
+          <ac:chgData name="Hemma Philamore" userId="db50e2f3-17b2-4cc0-b719-fb6254d3e9df" providerId="ADAL" clId="{976AD799-FE43-55CA-A221-11B5AB66B93B}" dt="2026-10-26T14:06:39.283" v="242" actId="478"/>
+          <ac:cxnSpMkLst>
+            <pc:docMk/>
+            <pc:sldMk cId="818822214" sldId="258"/>
+            <ac:cxnSpMk id="59" creationId="{8F8A3805-842B-0310-37D7-D619880257CE}"/>
+          </ac:cxnSpMkLst>
+        </pc:cxnChg>
+        <pc:cxnChg chg="mod">
+          <ac:chgData name="Hemma Philamore" userId="db50e2f3-17b2-4cc0-b719-fb6254d3e9df" providerId="ADAL" clId="{976AD799-FE43-55CA-A221-11B5AB66B93B}" dt="2026-10-26T14:06:39.283" v="242" actId="478"/>
+          <ac:cxnSpMkLst>
+            <pc:docMk/>
+            <pc:sldMk cId="818822214" sldId="258"/>
+            <ac:cxnSpMk id="60" creationId="{919E8544-4C7E-6947-C932-92AAFD3D8385}"/>
+          </ac:cxnSpMkLst>
+        </pc:cxnChg>
+        <pc:cxnChg chg="mod">
+          <ac:chgData name="Hemma Philamore" userId="db50e2f3-17b2-4cc0-b719-fb6254d3e9df" providerId="ADAL" clId="{976AD799-FE43-55CA-A221-11B5AB66B93B}" dt="2026-10-26T14:06:39.283" v="242" actId="478"/>
+          <ac:cxnSpMkLst>
+            <pc:docMk/>
+            <pc:sldMk cId="818822214" sldId="258"/>
+            <ac:cxnSpMk id="61" creationId="{4315371E-7668-80B7-6984-5D28C9F7BAAF}"/>
+          </ac:cxnSpMkLst>
+        </pc:cxnChg>
+        <pc:cxnChg chg="mod">
+          <ac:chgData name="Hemma Philamore" userId="db50e2f3-17b2-4cc0-b719-fb6254d3e9df" providerId="ADAL" clId="{976AD799-FE43-55CA-A221-11B5AB66B93B}" dt="2026-10-26T14:06:39.283" v="242" actId="478"/>
+          <ac:cxnSpMkLst>
+            <pc:docMk/>
+            <pc:sldMk cId="818822214" sldId="258"/>
+            <ac:cxnSpMk id="62" creationId="{8B948E47-C221-9FC6-41DF-4BD7D802D186}"/>
+          </ac:cxnSpMkLst>
+        </pc:cxnChg>
+        <pc:cxnChg chg="mod">
+          <ac:chgData name="Hemma Philamore" userId="db50e2f3-17b2-4cc0-b719-fb6254d3e9df" providerId="ADAL" clId="{976AD799-FE43-55CA-A221-11B5AB66B93B}" dt="2026-10-26T14:06:39.283" v="242" actId="478"/>
+          <ac:cxnSpMkLst>
+            <pc:docMk/>
+            <pc:sldMk cId="818822214" sldId="258"/>
+            <ac:cxnSpMk id="63" creationId="{88320384-CDE6-5221-6319-04A6E859481C}"/>
+          </ac:cxnSpMkLst>
+        </pc:cxnChg>
+        <pc:cxnChg chg="mod">
+          <ac:chgData name="Hemma Philamore" userId="db50e2f3-17b2-4cc0-b719-fb6254d3e9df" providerId="ADAL" clId="{976AD799-FE43-55CA-A221-11B5AB66B93B}" dt="2026-10-26T14:06:39.283" v="242" actId="478"/>
+          <ac:cxnSpMkLst>
+            <pc:docMk/>
+            <pc:sldMk cId="818822214" sldId="258"/>
+            <ac:cxnSpMk id="64" creationId="{CF0341AF-EC0B-683E-488D-A03B26CCA69D}"/>
+          </ac:cxnSpMkLst>
+        </pc:cxnChg>
+        <pc:cxnChg chg="add mod">
+          <ac:chgData name="Hemma Philamore" userId="db50e2f3-17b2-4cc0-b719-fb6254d3e9df" providerId="ADAL" clId="{976AD799-FE43-55CA-A221-11B5AB66B93B}" dt="2026-10-26T14:08:37.504" v="270" actId="692"/>
+          <ac:cxnSpMkLst>
+            <pc:docMk/>
+            <pc:sldMk cId="818822214" sldId="258"/>
+            <ac:cxnSpMk id="84" creationId="{8953C5E0-1352-304F-E5A4-6E2A0B075BD6}"/>
+          </ac:cxnSpMkLst>
+        </pc:cxnChg>
+        <pc:cxnChg chg="mod topLvl">
+          <ac:chgData name="Hemma Philamore" userId="db50e2f3-17b2-4cc0-b719-fb6254d3e9df" providerId="ADAL" clId="{976AD799-FE43-55CA-A221-11B5AB66B93B}" dt="2026-10-26T14:12:10.632" v="329" actId="14100"/>
+          <ac:cxnSpMkLst>
+            <pc:docMk/>
+            <pc:sldMk cId="818822214" sldId="258"/>
+            <ac:cxnSpMk id="114" creationId="{A773C88E-CD7F-B8F3-11DA-2E159491D435}"/>
+          </ac:cxnSpMkLst>
+        </pc:cxnChg>
+        <pc:cxnChg chg="mod topLvl">
+          <ac:chgData name="Hemma Philamore" userId="db50e2f3-17b2-4cc0-b719-fb6254d3e9df" providerId="ADAL" clId="{976AD799-FE43-55CA-A221-11B5AB66B93B}" dt="2026-10-26T14:12:05.777" v="328" actId="14100"/>
+          <ac:cxnSpMkLst>
+            <pc:docMk/>
+            <pc:sldMk cId="818822214" sldId="258"/>
+            <ac:cxnSpMk id="115" creationId="{229B8435-9CC1-145D-9CB1-AFEE2646401D}"/>
+          </ac:cxnSpMkLst>
+        </pc:cxnChg>
+        <pc:cxnChg chg="mod topLvl">
+          <ac:chgData name="Hemma Philamore" userId="db50e2f3-17b2-4cc0-b719-fb6254d3e9df" providerId="ADAL" clId="{976AD799-FE43-55CA-A221-11B5AB66B93B}" dt="2026-10-26T14:12:05.777" v="328" actId="14100"/>
+          <ac:cxnSpMkLst>
+            <pc:docMk/>
+            <pc:sldMk cId="818822214" sldId="258"/>
+            <ac:cxnSpMk id="116" creationId="{E198A755-DB47-96A1-1380-08FB2A234AA0}"/>
+          </ac:cxnSpMkLst>
+        </pc:cxnChg>
+        <pc:cxnChg chg="mod">
+          <ac:chgData name="Hemma Philamore" userId="db50e2f3-17b2-4cc0-b719-fb6254d3e9df" providerId="ADAL" clId="{976AD799-FE43-55CA-A221-11B5AB66B93B}" dt="2026-10-26T14:15:22.353" v="345" actId="208"/>
+          <ac:cxnSpMkLst>
+            <pc:docMk/>
+            <pc:sldMk cId="818822214" sldId="258"/>
+            <ac:cxnSpMk id="131" creationId="{698A2297-D560-157C-5E72-B14519BA8839}"/>
           </ac:cxnSpMkLst>
         </pc:cxnChg>
       </pc:sldChg>
@@ -5961,6 +6681,3061 @@
 </p:sld>
 </file>
 
+<file path=ppt/slides/slide3.xml><?xml version="1.0" encoding="utf-8"?>
+<p:sld xmlns:a="http://schemas.openxmlformats.org/drawingml/2006/main" xmlns:r="http://schemas.openxmlformats.org/officeDocument/2006/relationships" xmlns:p="http://schemas.openxmlformats.org/presentationml/2006/main">
+  <p:cSld>
+    <p:spTree>
+      <p:nvGrpSpPr>
+        <p:cNvPr id="1" name="">
+          <a:extLst>
+            <a:ext uri="{FF2B5EF4-FFF2-40B4-BE49-F238E27FC236}">
+              <a16:creationId xmlns:a16="http://schemas.microsoft.com/office/drawing/2014/main" id="{A54A6373-43CB-1300-2270-EA23ACB81961}"/>
+            </a:ext>
+          </a:extLst>
+        </p:cNvPr>
+        <p:cNvGrpSpPr/>
+        <p:nvPr/>
+      </p:nvGrpSpPr>
+      <p:grpSpPr>
+        <a:xfrm>
+          <a:off x="0" y="0"/>
+          <a:ext cx="0" cy="0"/>
+          <a:chOff x="0" y="0"/>
+          <a:chExt cx="0" cy="0"/>
+        </a:xfrm>
+      </p:grpSpPr>
+      <p:grpSp>
+        <p:nvGrpSpPr>
+          <p:cNvPr id="160" name="Group 159">
+            <a:extLst>
+              <a:ext uri="{FF2B5EF4-FFF2-40B4-BE49-F238E27FC236}">
+                <a16:creationId xmlns:a16="http://schemas.microsoft.com/office/drawing/2014/main" id="{4D364052-1EEB-5527-BCED-6D322E3256DD}"/>
+              </a:ext>
+            </a:extLst>
+          </p:cNvPr>
+          <p:cNvGrpSpPr/>
+          <p:nvPr/>
+        </p:nvGrpSpPr>
+        <p:grpSpPr>
+          <a:xfrm>
+            <a:off x="340654" y="1547037"/>
+            <a:ext cx="5566118" cy="5061909"/>
+            <a:chOff x="340654" y="1547037"/>
+            <a:chExt cx="5566118" cy="5061909"/>
+          </a:xfrm>
+        </p:grpSpPr>
+        <p:sp>
+          <p:nvSpPr>
+            <p:cNvPr id="2" name="Oval 1">
+              <a:extLst>
+                <a:ext uri="{FF2B5EF4-FFF2-40B4-BE49-F238E27FC236}">
+                  <a16:creationId xmlns:a16="http://schemas.microsoft.com/office/drawing/2014/main" id="{1166DCA7-BE25-075C-C4EB-C3A91B2B4558}"/>
+                </a:ext>
+              </a:extLst>
+            </p:cNvPr>
+            <p:cNvSpPr/>
+            <p:nvPr/>
+          </p:nvSpPr>
+          <p:spPr>
+            <a:xfrm>
+              <a:off x="2329249" y="1547037"/>
+              <a:ext cx="900000" cy="900000"/>
+            </a:xfrm>
+            <a:prstGeom prst="ellipse">
+              <a:avLst/>
+            </a:prstGeom>
+            <a:noFill/>
+            <a:ln w="38100"/>
+          </p:spPr>
+          <p:style>
+            <a:lnRef idx="2">
+              <a:schemeClr val="accent1">
+                <a:shade val="15000"/>
+              </a:schemeClr>
+            </a:lnRef>
+            <a:fillRef idx="1">
+              <a:schemeClr val="accent1"/>
+            </a:fillRef>
+            <a:effectRef idx="0">
+              <a:schemeClr val="accent1"/>
+            </a:effectRef>
+            <a:fontRef idx="minor">
+              <a:schemeClr val="lt1"/>
+            </a:fontRef>
+          </p:style>
+          <p:txBody>
+            <a:bodyPr rtlCol="0" anchor="ctr"/>
+            <a:lstStyle/>
+            <a:p>
+              <a:pPr algn="ctr"/>
+              <a:endParaRPr lang="en-US"/>
+            </a:p>
+          </p:txBody>
+        </p:sp>
+        <p:sp>
+          <p:nvSpPr>
+            <p:cNvPr id="12" name="Oval 11">
+              <a:extLst>
+                <a:ext uri="{FF2B5EF4-FFF2-40B4-BE49-F238E27FC236}">
+                  <a16:creationId xmlns:a16="http://schemas.microsoft.com/office/drawing/2014/main" id="{4D0FB3C7-9C73-BC39-5690-7EFF4A2894AF}"/>
+                </a:ext>
+              </a:extLst>
+            </p:cNvPr>
+            <p:cNvSpPr/>
+            <p:nvPr/>
+          </p:nvSpPr>
+          <p:spPr>
+            <a:xfrm>
+              <a:off x="4813979" y="2149152"/>
+              <a:ext cx="900000" cy="900000"/>
+            </a:xfrm>
+            <a:prstGeom prst="ellipse">
+              <a:avLst/>
+            </a:prstGeom>
+            <a:noFill/>
+            <a:ln w="38100"/>
+          </p:spPr>
+          <p:style>
+            <a:lnRef idx="2">
+              <a:schemeClr val="accent1">
+                <a:shade val="15000"/>
+              </a:schemeClr>
+            </a:lnRef>
+            <a:fillRef idx="1">
+              <a:schemeClr val="accent1"/>
+            </a:fillRef>
+            <a:effectRef idx="0">
+              <a:schemeClr val="accent1"/>
+            </a:effectRef>
+            <a:fontRef idx="minor">
+              <a:schemeClr val="lt1"/>
+            </a:fontRef>
+          </p:style>
+          <p:txBody>
+            <a:bodyPr rtlCol="0" anchor="ctr"/>
+            <a:lstStyle/>
+            <a:p>
+              <a:pPr algn="ctr"/>
+              <a:endParaRPr lang="en-US"/>
+            </a:p>
+          </p:txBody>
+        </p:sp>
+        <p:sp>
+          <p:nvSpPr>
+            <p:cNvPr id="15" name="Oval 14">
+              <a:extLst>
+                <a:ext uri="{FF2B5EF4-FFF2-40B4-BE49-F238E27FC236}">
+                  <a16:creationId xmlns:a16="http://schemas.microsoft.com/office/drawing/2014/main" id="{075391DC-F7E3-F41D-1365-DF93FA2D0B76}"/>
+                </a:ext>
+              </a:extLst>
+            </p:cNvPr>
+            <p:cNvSpPr/>
+            <p:nvPr/>
+          </p:nvSpPr>
+          <p:spPr>
+            <a:xfrm>
+              <a:off x="3008871" y="2856584"/>
+              <a:ext cx="900000" cy="900000"/>
+            </a:xfrm>
+            <a:prstGeom prst="ellipse">
+              <a:avLst/>
+            </a:prstGeom>
+            <a:noFill/>
+            <a:ln w="38100"/>
+          </p:spPr>
+          <p:style>
+            <a:lnRef idx="2">
+              <a:schemeClr val="accent1">
+                <a:shade val="15000"/>
+              </a:schemeClr>
+            </a:lnRef>
+            <a:fillRef idx="1">
+              <a:schemeClr val="accent1"/>
+            </a:fillRef>
+            <a:effectRef idx="0">
+              <a:schemeClr val="accent1"/>
+            </a:effectRef>
+            <a:fontRef idx="minor">
+              <a:schemeClr val="lt1"/>
+            </a:fontRef>
+          </p:style>
+          <p:txBody>
+            <a:bodyPr rtlCol="0" anchor="ctr"/>
+            <a:lstStyle/>
+            <a:p>
+              <a:pPr algn="ctr"/>
+              <a:endParaRPr lang="en-US"/>
+            </a:p>
+          </p:txBody>
+        </p:sp>
+        <p:sp>
+          <p:nvSpPr>
+            <p:cNvPr id="18" name="Oval 17">
+              <a:extLst>
+                <a:ext uri="{FF2B5EF4-FFF2-40B4-BE49-F238E27FC236}">
+                  <a16:creationId xmlns:a16="http://schemas.microsoft.com/office/drawing/2014/main" id="{FB009A0A-1C4C-CCAF-7B85-986E3BB01521}"/>
+                </a:ext>
+              </a:extLst>
+            </p:cNvPr>
+            <p:cNvSpPr/>
+            <p:nvPr/>
+          </p:nvSpPr>
+          <p:spPr>
+            <a:xfrm>
+              <a:off x="2420871" y="4410963"/>
+              <a:ext cx="900000" cy="900000"/>
+            </a:xfrm>
+            <a:prstGeom prst="ellipse">
+              <a:avLst/>
+            </a:prstGeom>
+            <a:noFill/>
+            <a:ln w="38100"/>
+          </p:spPr>
+          <p:style>
+            <a:lnRef idx="2">
+              <a:schemeClr val="accent1">
+                <a:shade val="15000"/>
+              </a:schemeClr>
+            </a:lnRef>
+            <a:fillRef idx="1">
+              <a:schemeClr val="accent1"/>
+            </a:fillRef>
+            <a:effectRef idx="0">
+              <a:schemeClr val="accent1"/>
+            </a:effectRef>
+            <a:fontRef idx="minor">
+              <a:schemeClr val="lt1"/>
+            </a:fontRef>
+          </p:style>
+          <p:txBody>
+            <a:bodyPr rtlCol="0" anchor="ctr"/>
+            <a:lstStyle/>
+            <a:p>
+              <a:pPr algn="ctr"/>
+              <a:endParaRPr lang="en-US"/>
+            </a:p>
+          </p:txBody>
+        </p:sp>
+        <p:sp>
+          <p:nvSpPr>
+            <p:cNvPr id="21" name="Oval 20">
+              <a:extLst>
+                <a:ext uri="{FF2B5EF4-FFF2-40B4-BE49-F238E27FC236}">
+                  <a16:creationId xmlns:a16="http://schemas.microsoft.com/office/drawing/2014/main" id="{62B9B986-9CBD-1052-25FD-39E6133B2A70}"/>
+                </a:ext>
+              </a:extLst>
+            </p:cNvPr>
+            <p:cNvSpPr/>
+            <p:nvPr/>
+          </p:nvSpPr>
+          <p:spPr>
+            <a:xfrm>
+              <a:off x="389238" y="3112980"/>
+              <a:ext cx="900000" cy="900000"/>
+            </a:xfrm>
+            <a:prstGeom prst="ellipse">
+              <a:avLst/>
+            </a:prstGeom>
+            <a:noFill/>
+            <a:ln w="38100"/>
+          </p:spPr>
+          <p:style>
+            <a:lnRef idx="2">
+              <a:schemeClr val="accent1">
+                <a:shade val="15000"/>
+              </a:schemeClr>
+            </a:lnRef>
+            <a:fillRef idx="1">
+              <a:schemeClr val="accent1"/>
+            </a:fillRef>
+            <a:effectRef idx="0">
+              <a:schemeClr val="accent1"/>
+            </a:effectRef>
+            <a:fontRef idx="minor">
+              <a:schemeClr val="lt1"/>
+            </a:fontRef>
+          </p:style>
+          <p:txBody>
+            <a:bodyPr rtlCol="0" anchor="ctr"/>
+            <a:lstStyle/>
+            <a:p>
+              <a:pPr algn="ctr"/>
+              <a:endParaRPr lang="en-US"/>
+            </a:p>
+          </p:txBody>
+        </p:sp>
+        <p:cxnSp>
+          <p:nvCxnSpPr>
+            <p:cNvPr id="26" name="Straight Connector 25">
+              <a:extLst>
+                <a:ext uri="{FF2B5EF4-FFF2-40B4-BE49-F238E27FC236}">
+                  <a16:creationId xmlns:a16="http://schemas.microsoft.com/office/drawing/2014/main" id="{9D4AD028-B45C-7240-B848-03DD6DFFDD15}"/>
+                </a:ext>
+              </a:extLst>
+            </p:cNvPr>
+            <p:cNvCxnSpPr>
+              <a:cxnSpLocks/>
+              <a:stCxn id="2" idx="4"/>
+              <a:endCxn id="15" idx="1"/>
+            </p:cNvCxnSpPr>
+            <p:nvPr/>
+          </p:nvCxnSpPr>
+          <p:spPr>
+            <a:xfrm>
+              <a:off x="2779249" y="2447037"/>
+              <a:ext cx="361424" cy="541349"/>
+            </a:xfrm>
+            <a:prstGeom prst="line">
+              <a:avLst/>
+            </a:prstGeom>
+            <a:ln w="31750">
+              <a:solidFill>
+                <a:schemeClr val="tx1"/>
+              </a:solidFill>
+            </a:ln>
+          </p:spPr>
+          <p:style>
+            <a:lnRef idx="2">
+              <a:schemeClr val="accent1"/>
+            </a:lnRef>
+            <a:fillRef idx="0">
+              <a:schemeClr val="accent1"/>
+            </a:fillRef>
+            <a:effectRef idx="1">
+              <a:schemeClr val="accent1"/>
+            </a:effectRef>
+            <a:fontRef idx="minor">
+              <a:schemeClr val="tx1"/>
+            </a:fontRef>
+          </p:style>
+        </p:cxnSp>
+        <p:cxnSp>
+          <p:nvCxnSpPr>
+            <p:cNvPr id="29" name="Straight Connector 28">
+              <a:extLst>
+                <a:ext uri="{FF2B5EF4-FFF2-40B4-BE49-F238E27FC236}">
+                  <a16:creationId xmlns:a16="http://schemas.microsoft.com/office/drawing/2014/main" id="{B17E67DB-911F-85A9-47F9-376C6FC16C8F}"/>
+                </a:ext>
+              </a:extLst>
+            </p:cNvPr>
+            <p:cNvCxnSpPr>
+              <a:stCxn id="2" idx="3"/>
+              <a:endCxn id="21" idx="7"/>
+            </p:cNvCxnSpPr>
+            <p:nvPr/>
+          </p:nvCxnSpPr>
+          <p:spPr>
+            <a:xfrm flipH="1">
+              <a:off x="1157436" y="2315235"/>
+              <a:ext cx="1303615" cy="929547"/>
+            </a:xfrm>
+            <a:prstGeom prst="line">
+              <a:avLst/>
+            </a:prstGeom>
+            <a:ln w="31750">
+              <a:solidFill>
+                <a:schemeClr val="tx1"/>
+              </a:solidFill>
+            </a:ln>
+          </p:spPr>
+          <p:style>
+            <a:lnRef idx="2">
+              <a:schemeClr val="accent1"/>
+            </a:lnRef>
+            <a:fillRef idx="0">
+              <a:schemeClr val="accent1"/>
+            </a:fillRef>
+            <a:effectRef idx="1">
+              <a:schemeClr val="accent1"/>
+            </a:effectRef>
+            <a:fontRef idx="minor">
+              <a:schemeClr val="tx1"/>
+            </a:fontRef>
+          </p:style>
+        </p:cxnSp>
+        <p:cxnSp>
+          <p:nvCxnSpPr>
+            <p:cNvPr id="31" name="Straight Connector 30">
+              <a:extLst>
+                <a:ext uri="{FF2B5EF4-FFF2-40B4-BE49-F238E27FC236}">
+                  <a16:creationId xmlns:a16="http://schemas.microsoft.com/office/drawing/2014/main" id="{8E023F93-997F-509B-29E8-B21353E65C5D}"/>
+                </a:ext>
+              </a:extLst>
+            </p:cNvPr>
+            <p:cNvCxnSpPr>
+              <a:stCxn id="21" idx="5"/>
+              <a:endCxn id="18" idx="2"/>
+            </p:cNvCxnSpPr>
+            <p:nvPr/>
+          </p:nvCxnSpPr>
+          <p:spPr>
+            <a:xfrm>
+              <a:off x="1157436" y="3881178"/>
+              <a:ext cx="1263435" cy="979785"/>
+            </a:xfrm>
+            <a:prstGeom prst="line">
+              <a:avLst/>
+            </a:prstGeom>
+            <a:ln w="31750">
+              <a:solidFill>
+                <a:schemeClr val="tx1"/>
+              </a:solidFill>
+            </a:ln>
+          </p:spPr>
+          <p:style>
+            <a:lnRef idx="2">
+              <a:schemeClr val="accent1"/>
+            </a:lnRef>
+            <a:fillRef idx="0">
+              <a:schemeClr val="accent1"/>
+            </a:fillRef>
+            <a:effectRef idx="1">
+              <a:schemeClr val="accent1"/>
+            </a:effectRef>
+            <a:fontRef idx="minor">
+              <a:schemeClr val="tx1"/>
+            </a:fontRef>
+          </p:style>
+        </p:cxnSp>
+        <p:cxnSp>
+          <p:nvCxnSpPr>
+            <p:cNvPr id="33" name="Straight Connector 32">
+              <a:extLst>
+                <a:ext uri="{FF2B5EF4-FFF2-40B4-BE49-F238E27FC236}">
+                  <a16:creationId xmlns:a16="http://schemas.microsoft.com/office/drawing/2014/main" id="{BD031B61-CDE5-F452-54EF-DA12162E65B1}"/>
+                </a:ext>
+              </a:extLst>
+            </p:cNvPr>
+            <p:cNvCxnSpPr>
+              <a:stCxn id="21" idx="6"/>
+              <a:endCxn id="15" idx="2"/>
+            </p:cNvCxnSpPr>
+            <p:nvPr/>
+          </p:nvCxnSpPr>
+          <p:spPr>
+            <a:xfrm flipV="1">
+              <a:off x="1289238" y="3306584"/>
+              <a:ext cx="1719633" cy="256396"/>
+            </a:xfrm>
+            <a:prstGeom prst="line">
+              <a:avLst/>
+            </a:prstGeom>
+            <a:ln w="31750">
+              <a:solidFill>
+                <a:schemeClr val="tx1"/>
+              </a:solidFill>
+            </a:ln>
+          </p:spPr>
+          <p:style>
+            <a:lnRef idx="2">
+              <a:schemeClr val="accent1"/>
+            </a:lnRef>
+            <a:fillRef idx="0">
+              <a:schemeClr val="accent1"/>
+            </a:fillRef>
+            <a:effectRef idx="1">
+              <a:schemeClr val="accent1"/>
+            </a:effectRef>
+            <a:fontRef idx="minor">
+              <a:schemeClr val="tx1"/>
+            </a:fontRef>
+          </p:style>
+        </p:cxnSp>
+        <p:cxnSp>
+          <p:nvCxnSpPr>
+            <p:cNvPr id="35" name="Straight Connector 34">
+              <a:extLst>
+                <a:ext uri="{FF2B5EF4-FFF2-40B4-BE49-F238E27FC236}">
+                  <a16:creationId xmlns:a16="http://schemas.microsoft.com/office/drawing/2014/main" id="{B627860C-C4B1-734D-6D60-BF1D0F266A27}"/>
+                </a:ext>
+              </a:extLst>
+            </p:cNvPr>
+            <p:cNvCxnSpPr>
+              <a:stCxn id="18" idx="7"/>
+              <a:endCxn id="15" idx="4"/>
+            </p:cNvCxnSpPr>
+            <p:nvPr/>
+          </p:nvCxnSpPr>
+          <p:spPr>
+            <a:xfrm flipV="1">
+              <a:off x="3189069" y="3756584"/>
+              <a:ext cx="269802" cy="786181"/>
+            </a:xfrm>
+            <a:prstGeom prst="line">
+              <a:avLst/>
+            </a:prstGeom>
+            <a:ln w="31750">
+              <a:solidFill>
+                <a:schemeClr val="tx1"/>
+              </a:solidFill>
+            </a:ln>
+          </p:spPr>
+          <p:style>
+            <a:lnRef idx="2">
+              <a:schemeClr val="accent1"/>
+            </a:lnRef>
+            <a:fillRef idx="0">
+              <a:schemeClr val="accent1"/>
+            </a:fillRef>
+            <a:effectRef idx="1">
+              <a:schemeClr val="accent1"/>
+            </a:effectRef>
+            <a:fontRef idx="minor">
+              <a:schemeClr val="tx1"/>
+            </a:fontRef>
+          </p:style>
+        </p:cxnSp>
+        <p:cxnSp>
+          <p:nvCxnSpPr>
+            <p:cNvPr id="37" name="Straight Connector 36">
+              <a:extLst>
+                <a:ext uri="{FF2B5EF4-FFF2-40B4-BE49-F238E27FC236}">
+                  <a16:creationId xmlns:a16="http://schemas.microsoft.com/office/drawing/2014/main" id="{269DBA2F-D07A-05F2-1FDD-BF5026FBF626}"/>
+                </a:ext>
+              </a:extLst>
+            </p:cNvPr>
+            <p:cNvCxnSpPr>
+              <a:stCxn id="2" idx="6"/>
+              <a:endCxn id="12" idx="2"/>
+            </p:cNvCxnSpPr>
+            <p:nvPr/>
+          </p:nvCxnSpPr>
+          <p:spPr>
+            <a:xfrm>
+              <a:off x="3229249" y="1997037"/>
+              <a:ext cx="1584730" cy="602115"/>
+            </a:xfrm>
+            <a:prstGeom prst="line">
+              <a:avLst/>
+            </a:prstGeom>
+            <a:ln w="31750">
+              <a:solidFill>
+                <a:schemeClr val="tx1"/>
+              </a:solidFill>
+            </a:ln>
+          </p:spPr>
+          <p:style>
+            <a:lnRef idx="2">
+              <a:schemeClr val="accent1"/>
+            </a:lnRef>
+            <a:fillRef idx="0">
+              <a:schemeClr val="accent1"/>
+            </a:fillRef>
+            <a:effectRef idx="1">
+              <a:schemeClr val="accent1"/>
+            </a:effectRef>
+            <a:fontRef idx="minor">
+              <a:schemeClr val="tx1"/>
+            </a:fontRef>
+          </p:style>
+        </p:cxnSp>
+        <p:cxnSp>
+          <p:nvCxnSpPr>
+            <p:cNvPr id="39" name="Straight Connector 38">
+              <a:extLst>
+                <a:ext uri="{FF2B5EF4-FFF2-40B4-BE49-F238E27FC236}">
+                  <a16:creationId xmlns:a16="http://schemas.microsoft.com/office/drawing/2014/main" id="{21786D18-D8D7-BB75-8A0B-4D00C6F21888}"/>
+                </a:ext>
+              </a:extLst>
+            </p:cNvPr>
+            <p:cNvCxnSpPr>
+              <a:stCxn id="15" idx="6"/>
+              <a:endCxn id="12" idx="3"/>
+            </p:cNvCxnSpPr>
+            <p:nvPr/>
+          </p:nvCxnSpPr>
+          <p:spPr>
+            <a:xfrm flipV="1">
+              <a:off x="3908871" y="2917350"/>
+              <a:ext cx="1036910" cy="389234"/>
+            </a:xfrm>
+            <a:prstGeom prst="line">
+              <a:avLst/>
+            </a:prstGeom>
+            <a:ln w="31750">
+              <a:solidFill>
+                <a:schemeClr val="tx1"/>
+              </a:solidFill>
+            </a:ln>
+          </p:spPr>
+          <p:style>
+            <a:lnRef idx="2">
+              <a:schemeClr val="accent1"/>
+            </a:lnRef>
+            <a:fillRef idx="0">
+              <a:schemeClr val="accent1"/>
+            </a:fillRef>
+            <a:effectRef idx="1">
+              <a:schemeClr val="accent1"/>
+            </a:effectRef>
+            <a:fontRef idx="minor">
+              <a:schemeClr val="tx1"/>
+            </a:fontRef>
+          </p:style>
+        </p:cxnSp>
+        <p:cxnSp>
+          <p:nvCxnSpPr>
+            <p:cNvPr id="41" name="Straight Connector 40">
+              <a:extLst>
+                <a:ext uri="{FF2B5EF4-FFF2-40B4-BE49-F238E27FC236}">
+                  <a16:creationId xmlns:a16="http://schemas.microsoft.com/office/drawing/2014/main" id="{DFF6FED4-331C-D24F-28E0-687D757C026E}"/>
+                </a:ext>
+              </a:extLst>
+            </p:cNvPr>
+            <p:cNvCxnSpPr>
+              <a:stCxn id="18" idx="6"/>
+              <a:endCxn id="12" idx="4"/>
+            </p:cNvCxnSpPr>
+            <p:nvPr/>
+          </p:nvCxnSpPr>
+          <p:spPr>
+            <a:xfrm flipV="1">
+              <a:off x="3320871" y="3049152"/>
+              <a:ext cx="1943108" cy="1811811"/>
+            </a:xfrm>
+            <a:prstGeom prst="line">
+              <a:avLst/>
+            </a:prstGeom>
+            <a:ln w="31750">
+              <a:solidFill>
+                <a:schemeClr val="tx1"/>
+              </a:solidFill>
+            </a:ln>
+          </p:spPr>
+          <p:style>
+            <a:lnRef idx="2">
+              <a:schemeClr val="accent1"/>
+            </a:lnRef>
+            <a:fillRef idx="0">
+              <a:schemeClr val="accent1"/>
+            </a:fillRef>
+            <a:effectRef idx="1">
+              <a:schemeClr val="accent1"/>
+            </a:effectRef>
+            <a:fontRef idx="minor">
+              <a:schemeClr val="tx1"/>
+            </a:fontRef>
+          </p:style>
+        </p:cxnSp>
+        <p:sp>
+          <p:nvSpPr>
+            <p:cNvPr id="42" name="TextBox 41">
+              <a:extLst>
+                <a:ext uri="{FF2B5EF4-FFF2-40B4-BE49-F238E27FC236}">
+                  <a16:creationId xmlns:a16="http://schemas.microsoft.com/office/drawing/2014/main" id="{DF004EF6-E142-1614-EE3B-1100C1965C40}"/>
+                </a:ext>
+              </a:extLst>
+            </p:cNvPr>
+            <p:cNvSpPr txBox="1"/>
+            <p:nvPr/>
+          </p:nvSpPr>
+          <p:spPr>
+            <a:xfrm>
+              <a:off x="1236698" y="2373652"/>
+              <a:ext cx="654908" cy="461665"/>
+            </a:xfrm>
+            <a:prstGeom prst="rect">
+              <a:avLst/>
+            </a:prstGeom>
+            <a:noFill/>
+          </p:spPr>
+          <p:txBody>
+            <a:bodyPr wrap="square" rtlCol="0">
+              <a:spAutoFit/>
+            </a:bodyPr>
+            <a:lstStyle/>
+            <a:p>
+              <a:pPr algn="ctr"/>
+              <a:r>
+                <a:rPr lang="en-US" sz="2400" dirty="0"/>
+                <a:t>12</a:t>
+              </a:r>
+            </a:p>
+          </p:txBody>
+        </p:sp>
+        <p:sp>
+          <p:nvSpPr>
+            <p:cNvPr id="43" name="TextBox 42">
+              <a:extLst>
+                <a:ext uri="{FF2B5EF4-FFF2-40B4-BE49-F238E27FC236}">
+                  <a16:creationId xmlns:a16="http://schemas.microsoft.com/office/drawing/2014/main" id="{4A06994E-FB0B-7B1B-7212-5CABC63777CF}"/>
+                </a:ext>
+              </a:extLst>
+            </p:cNvPr>
+            <p:cNvSpPr txBox="1"/>
+            <p:nvPr/>
+          </p:nvSpPr>
+          <p:spPr>
+            <a:xfrm>
+              <a:off x="2861615" y="2415145"/>
+              <a:ext cx="654908" cy="461665"/>
+            </a:xfrm>
+            <a:prstGeom prst="rect">
+              <a:avLst/>
+            </a:prstGeom>
+            <a:noFill/>
+          </p:spPr>
+          <p:txBody>
+            <a:bodyPr wrap="square" rtlCol="0">
+              <a:spAutoFit/>
+            </a:bodyPr>
+            <a:lstStyle/>
+            <a:p>
+              <a:pPr algn="ctr"/>
+              <a:r>
+                <a:rPr lang="en-US" sz="2400" dirty="0"/>
+                <a:t>8</a:t>
+              </a:r>
+            </a:p>
+          </p:txBody>
+        </p:sp>
+        <p:sp>
+          <p:nvSpPr>
+            <p:cNvPr id="44" name="TextBox 43">
+              <a:extLst>
+                <a:ext uri="{FF2B5EF4-FFF2-40B4-BE49-F238E27FC236}">
+                  <a16:creationId xmlns:a16="http://schemas.microsoft.com/office/drawing/2014/main" id="{1426A36C-9368-D130-7B58-77E95C4566DD}"/>
+                </a:ext>
+              </a:extLst>
+            </p:cNvPr>
+            <p:cNvSpPr txBox="1"/>
+            <p:nvPr/>
+          </p:nvSpPr>
+          <p:spPr>
+            <a:xfrm>
+              <a:off x="2751426" y="3852691"/>
+              <a:ext cx="654908" cy="461665"/>
+            </a:xfrm>
+            <a:prstGeom prst="rect">
+              <a:avLst/>
+            </a:prstGeom>
+            <a:noFill/>
+          </p:spPr>
+          <p:txBody>
+            <a:bodyPr wrap="square" rtlCol="0">
+              <a:spAutoFit/>
+            </a:bodyPr>
+            <a:lstStyle/>
+            <a:p>
+              <a:pPr algn="ctr"/>
+              <a:r>
+                <a:rPr lang="en-US" sz="2400" dirty="0"/>
+                <a:t>6</a:t>
+              </a:r>
+            </a:p>
+          </p:txBody>
+        </p:sp>
+        <p:sp>
+          <p:nvSpPr>
+            <p:cNvPr id="46" name="TextBox 45">
+              <a:extLst>
+                <a:ext uri="{FF2B5EF4-FFF2-40B4-BE49-F238E27FC236}">
+                  <a16:creationId xmlns:a16="http://schemas.microsoft.com/office/drawing/2014/main" id="{FA7B7597-0100-DB49-F5FD-4C8F209EF168}"/>
+                </a:ext>
+              </a:extLst>
+            </p:cNvPr>
+            <p:cNvSpPr txBox="1"/>
+            <p:nvPr/>
+          </p:nvSpPr>
+          <p:spPr>
+            <a:xfrm>
+              <a:off x="1803589" y="2978204"/>
+              <a:ext cx="654908" cy="461665"/>
+            </a:xfrm>
+            <a:prstGeom prst="rect">
+              <a:avLst/>
+            </a:prstGeom>
+            <a:noFill/>
+          </p:spPr>
+          <p:txBody>
+            <a:bodyPr wrap="square" rtlCol="0">
+              <a:spAutoFit/>
+            </a:bodyPr>
+            <a:lstStyle/>
+            <a:p>
+              <a:pPr algn="ctr"/>
+              <a:r>
+                <a:rPr lang="en-US" sz="2400" dirty="0"/>
+                <a:t>10</a:t>
+              </a:r>
+            </a:p>
+          </p:txBody>
+        </p:sp>
+        <p:sp>
+          <p:nvSpPr>
+            <p:cNvPr id="47" name="TextBox 46">
+              <a:extLst>
+                <a:ext uri="{FF2B5EF4-FFF2-40B4-BE49-F238E27FC236}">
+                  <a16:creationId xmlns:a16="http://schemas.microsoft.com/office/drawing/2014/main" id="{985ED467-F9D2-E3D8-486F-C5B73DE24BEC}"/>
+                </a:ext>
+              </a:extLst>
+            </p:cNvPr>
+            <p:cNvSpPr txBox="1"/>
+            <p:nvPr/>
+          </p:nvSpPr>
+          <p:spPr>
+            <a:xfrm>
+              <a:off x="3793507" y="1836429"/>
+              <a:ext cx="654908" cy="461665"/>
+            </a:xfrm>
+            <a:prstGeom prst="rect">
+              <a:avLst/>
+            </a:prstGeom>
+            <a:noFill/>
+          </p:spPr>
+          <p:txBody>
+            <a:bodyPr wrap="square" rtlCol="0">
+              <a:spAutoFit/>
+            </a:bodyPr>
+            <a:lstStyle/>
+            <a:p>
+              <a:pPr algn="ctr"/>
+              <a:r>
+                <a:rPr lang="en-US" sz="2400" dirty="0"/>
+                <a:t>20</a:t>
+              </a:r>
+            </a:p>
+          </p:txBody>
+        </p:sp>
+        <p:sp>
+          <p:nvSpPr>
+            <p:cNvPr id="49" name="TextBox 48">
+              <a:extLst>
+                <a:ext uri="{FF2B5EF4-FFF2-40B4-BE49-F238E27FC236}">
+                  <a16:creationId xmlns:a16="http://schemas.microsoft.com/office/drawing/2014/main" id="{2696082F-1587-CBC0-D621-0D22E15B2350}"/>
+                </a:ext>
+              </a:extLst>
+            </p:cNvPr>
+            <p:cNvSpPr txBox="1"/>
+            <p:nvPr/>
+          </p:nvSpPr>
+          <p:spPr>
+            <a:xfrm>
+              <a:off x="3976289" y="2712565"/>
+              <a:ext cx="654908" cy="461665"/>
+            </a:xfrm>
+            <a:prstGeom prst="rect">
+              <a:avLst/>
+            </a:prstGeom>
+            <a:noFill/>
+          </p:spPr>
+          <p:txBody>
+            <a:bodyPr wrap="square" rtlCol="0">
+              <a:spAutoFit/>
+            </a:bodyPr>
+            <a:lstStyle/>
+            <a:p>
+              <a:pPr algn="ctr"/>
+              <a:r>
+                <a:rPr lang="en-US" sz="2400" dirty="0"/>
+                <a:t>15</a:t>
+              </a:r>
+            </a:p>
+          </p:txBody>
+        </p:sp>
+        <p:sp>
+          <p:nvSpPr>
+            <p:cNvPr id="5" name="TextBox 4">
+              <a:extLst>
+                <a:ext uri="{FF2B5EF4-FFF2-40B4-BE49-F238E27FC236}">
+                  <a16:creationId xmlns:a16="http://schemas.microsoft.com/office/drawing/2014/main" id="{A8068F53-98F4-86A2-1022-96C32A264124}"/>
+                </a:ext>
+              </a:extLst>
+            </p:cNvPr>
+            <p:cNvSpPr txBox="1"/>
+            <p:nvPr/>
+          </p:nvSpPr>
+          <p:spPr>
+            <a:xfrm>
+              <a:off x="2405110" y="1806488"/>
+              <a:ext cx="778107" cy="369332"/>
+            </a:xfrm>
+            <a:prstGeom prst="rect">
+              <a:avLst/>
+            </a:prstGeom>
+            <a:noFill/>
+          </p:spPr>
+          <p:txBody>
+            <a:bodyPr wrap="square" rtlCol="0">
+              <a:spAutoFit/>
+            </a:bodyPr>
+            <a:lstStyle/>
+            <a:p>
+              <a:r>
+                <a:rPr lang="en-US" dirty="0"/>
+                <a:t>Alden</a:t>
+              </a:r>
+            </a:p>
+          </p:txBody>
+        </p:sp>
+        <p:sp>
+          <p:nvSpPr>
+            <p:cNvPr id="6" name="TextBox 5">
+              <a:extLst>
+                <a:ext uri="{FF2B5EF4-FFF2-40B4-BE49-F238E27FC236}">
+                  <a16:creationId xmlns:a16="http://schemas.microsoft.com/office/drawing/2014/main" id="{8E0F47BF-4885-964F-0D60-B4639C8A9BE6}"/>
+                </a:ext>
+              </a:extLst>
+            </p:cNvPr>
+            <p:cNvSpPr txBox="1"/>
+            <p:nvPr/>
+          </p:nvSpPr>
+          <p:spPr>
+            <a:xfrm>
+              <a:off x="4791118" y="2414486"/>
+              <a:ext cx="1115654" cy="369332"/>
+            </a:xfrm>
+            <a:prstGeom prst="rect">
+              <a:avLst/>
+            </a:prstGeom>
+            <a:noFill/>
+          </p:spPr>
+          <p:txBody>
+            <a:bodyPr wrap="square" rtlCol="0">
+              <a:spAutoFit/>
+            </a:bodyPr>
+            <a:lstStyle/>
+            <a:p>
+              <a:r>
+                <a:rPr lang="en-US" dirty="0" err="1"/>
+                <a:t>Brinford</a:t>
+              </a:r>
+              <a:endParaRPr lang="en-US" dirty="0"/>
+            </a:p>
+          </p:txBody>
+        </p:sp>
+        <p:sp>
+          <p:nvSpPr>
+            <p:cNvPr id="7" name="TextBox 6">
+              <a:extLst>
+                <a:ext uri="{FF2B5EF4-FFF2-40B4-BE49-F238E27FC236}">
+                  <a16:creationId xmlns:a16="http://schemas.microsoft.com/office/drawing/2014/main" id="{91D8E25D-1B4C-F9BC-6D09-A03B452EEF3D}"/>
+                </a:ext>
+              </a:extLst>
+            </p:cNvPr>
+            <p:cNvSpPr txBox="1"/>
+            <p:nvPr/>
+          </p:nvSpPr>
+          <p:spPr>
+            <a:xfrm>
+              <a:off x="2438398" y="4703218"/>
+              <a:ext cx="1115654" cy="369332"/>
+            </a:xfrm>
+            <a:prstGeom prst="rect">
+              <a:avLst/>
+            </a:prstGeom>
+            <a:noFill/>
+          </p:spPr>
+          <p:txBody>
+            <a:bodyPr wrap="square" rtlCol="0">
+              <a:spAutoFit/>
+            </a:bodyPr>
+            <a:lstStyle/>
+            <a:p>
+              <a:r>
+                <a:rPr lang="en-US" dirty="0"/>
+                <a:t>Caster</a:t>
+              </a:r>
+            </a:p>
+          </p:txBody>
+        </p:sp>
+        <p:sp>
+          <p:nvSpPr>
+            <p:cNvPr id="8" name="TextBox 7">
+              <a:extLst>
+                <a:ext uri="{FF2B5EF4-FFF2-40B4-BE49-F238E27FC236}">
+                  <a16:creationId xmlns:a16="http://schemas.microsoft.com/office/drawing/2014/main" id="{E0633738-F0B1-A4FD-DA17-78FA70ED5802}"/>
+                </a:ext>
+              </a:extLst>
+            </p:cNvPr>
+            <p:cNvSpPr txBox="1"/>
+            <p:nvPr/>
+          </p:nvSpPr>
+          <p:spPr>
+            <a:xfrm>
+              <a:off x="3016860" y="3152566"/>
+              <a:ext cx="1115654" cy="369332"/>
+            </a:xfrm>
+            <a:prstGeom prst="rect">
+              <a:avLst/>
+            </a:prstGeom>
+            <a:noFill/>
+          </p:spPr>
+          <p:txBody>
+            <a:bodyPr wrap="square" rtlCol="0">
+              <a:spAutoFit/>
+            </a:bodyPr>
+            <a:lstStyle/>
+            <a:p>
+              <a:r>
+                <a:rPr lang="en-US" dirty="0" err="1"/>
+                <a:t>Dunvor</a:t>
+              </a:r>
+              <a:endParaRPr lang="en-US" dirty="0"/>
+            </a:p>
+          </p:txBody>
+        </p:sp>
+        <p:sp>
+          <p:nvSpPr>
+            <p:cNvPr id="9" name="TextBox 8">
+              <a:extLst>
+                <a:ext uri="{FF2B5EF4-FFF2-40B4-BE49-F238E27FC236}">
+                  <a16:creationId xmlns:a16="http://schemas.microsoft.com/office/drawing/2014/main" id="{63FA04A2-A263-3D7E-6B3B-5A206D134AA4}"/>
+                </a:ext>
+              </a:extLst>
+            </p:cNvPr>
+            <p:cNvSpPr txBox="1"/>
+            <p:nvPr/>
+          </p:nvSpPr>
+          <p:spPr>
+            <a:xfrm>
+              <a:off x="340654" y="3365565"/>
+              <a:ext cx="1115654" cy="369332"/>
+            </a:xfrm>
+            <a:prstGeom prst="rect">
+              <a:avLst/>
+            </a:prstGeom>
+            <a:noFill/>
+          </p:spPr>
+          <p:txBody>
+            <a:bodyPr wrap="square" rtlCol="0">
+              <a:spAutoFit/>
+            </a:bodyPr>
+            <a:lstStyle/>
+            <a:p>
+              <a:r>
+                <a:rPr lang="en-US" dirty="0"/>
+                <a:t>Fenwick</a:t>
+              </a:r>
+            </a:p>
+          </p:txBody>
+        </p:sp>
+        <p:sp>
+          <p:nvSpPr>
+            <p:cNvPr id="10" name="Oval 9">
+              <a:extLst>
+                <a:ext uri="{FF2B5EF4-FFF2-40B4-BE49-F238E27FC236}">
+                  <a16:creationId xmlns:a16="http://schemas.microsoft.com/office/drawing/2014/main" id="{711322C6-5D34-34D5-158F-F28376BB0BAC}"/>
+                </a:ext>
+              </a:extLst>
+            </p:cNvPr>
+            <p:cNvSpPr/>
+            <p:nvPr/>
+          </p:nvSpPr>
+          <p:spPr>
+            <a:xfrm>
+              <a:off x="2294772" y="5708946"/>
+              <a:ext cx="900000" cy="900000"/>
+            </a:xfrm>
+            <a:prstGeom prst="ellipse">
+              <a:avLst/>
+            </a:prstGeom>
+            <a:noFill/>
+            <a:ln w="38100"/>
+          </p:spPr>
+          <p:style>
+            <a:lnRef idx="2">
+              <a:schemeClr val="accent1">
+                <a:shade val="15000"/>
+              </a:schemeClr>
+            </a:lnRef>
+            <a:fillRef idx="1">
+              <a:schemeClr val="accent1"/>
+            </a:fillRef>
+            <a:effectRef idx="0">
+              <a:schemeClr val="accent1"/>
+            </a:effectRef>
+            <a:fontRef idx="minor">
+              <a:schemeClr val="lt1"/>
+            </a:fontRef>
+          </p:style>
+          <p:txBody>
+            <a:bodyPr rtlCol="0" anchor="ctr"/>
+            <a:lstStyle/>
+            <a:p>
+              <a:pPr algn="ctr"/>
+              <a:endParaRPr lang="en-US"/>
+            </a:p>
+          </p:txBody>
+        </p:sp>
+        <p:sp>
+          <p:nvSpPr>
+            <p:cNvPr id="23" name="TextBox 22">
+              <a:extLst>
+                <a:ext uri="{FF2B5EF4-FFF2-40B4-BE49-F238E27FC236}">
+                  <a16:creationId xmlns:a16="http://schemas.microsoft.com/office/drawing/2014/main" id="{446A178C-C437-313B-ED62-CE951E3F45F1}"/>
+                </a:ext>
+              </a:extLst>
+            </p:cNvPr>
+            <p:cNvSpPr txBox="1"/>
+            <p:nvPr/>
+          </p:nvSpPr>
+          <p:spPr>
+            <a:xfrm>
+              <a:off x="2361665" y="5999514"/>
+              <a:ext cx="959206" cy="369332"/>
+            </a:xfrm>
+            <a:prstGeom prst="rect">
+              <a:avLst/>
+            </a:prstGeom>
+            <a:noFill/>
+          </p:spPr>
+          <p:txBody>
+            <a:bodyPr wrap="square" rtlCol="0">
+              <a:spAutoFit/>
+            </a:bodyPr>
+            <a:lstStyle/>
+            <a:p>
+              <a:r>
+                <a:rPr lang="en-US" dirty="0" err="1"/>
+                <a:t>Elwick</a:t>
+              </a:r>
+              <a:endParaRPr lang="en-US" dirty="0"/>
+            </a:p>
+          </p:txBody>
+        </p:sp>
+        <p:cxnSp>
+          <p:nvCxnSpPr>
+            <p:cNvPr id="28" name="Straight Connector 27">
+              <a:extLst>
+                <a:ext uri="{FF2B5EF4-FFF2-40B4-BE49-F238E27FC236}">
+                  <a16:creationId xmlns:a16="http://schemas.microsoft.com/office/drawing/2014/main" id="{CA1D45DC-2FC8-6888-A955-02E09D868AC1}"/>
+                </a:ext>
+              </a:extLst>
+            </p:cNvPr>
+            <p:cNvCxnSpPr>
+              <a:stCxn id="21" idx="4"/>
+              <a:endCxn id="10" idx="1"/>
+            </p:cNvCxnSpPr>
+            <p:nvPr/>
+          </p:nvCxnSpPr>
+          <p:spPr>
+            <a:xfrm>
+              <a:off x="839238" y="4012980"/>
+              <a:ext cx="1587336" cy="1827768"/>
+            </a:xfrm>
+            <a:prstGeom prst="line">
+              <a:avLst/>
+            </a:prstGeom>
+            <a:ln w="31750">
+              <a:solidFill>
+                <a:schemeClr val="tx1"/>
+              </a:solidFill>
+            </a:ln>
+          </p:spPr>
+          <p:style>
+            <a:lnRef idx="2">
+              <a:schemeClr val="accent1"/>
+            </a:lnRef>
+            <a:fillRef idx="0">
+              <a:schemeClr val="accent1"/>
+            </a:fillRef>
+            <a:effectRef idx="1">
+              <a:schemeClr val="accent1"/>
+            </a:effectRef>
+            <a:fontRef idx="minor">
+              <a:schemeClr val="tx1"/>
+            </a:fontRef>
+          </p:style>
+        </p:cxnSp>
+        <p:cxnSp>
+          <p:nvCxnSpPr>
+            <p:cNvPr id="84" name="Straight Connector 83">
+              <a:extLst>
+                <a:ext uri="{FF2B5EF4-FFF2-40B4-BE49-F238E27FC236}">
+                  <a16:creationId xmlns:a16="http://schemas.microsoft.com/office/drawing/2014/main" id="{8953C5E0-1352-304F-E5A4-6E2A0B075BD6}"/>
+                </a:ext>
+              </a:extLst>
+            </p:cNvPr>
+            <p:cNvCxnSpPr>
+              <a:stCxn id="10" idx="0"/>
+              <a:endCxn id="18" idx="4"/>
+            </p:cNvCxnSpPr>
+            <p:nvPr/>
+          </p:nvCxnSpPr>
+          <p:spPr>
+            <a:xfrm flipV="1">
+              <a:off x="2744772" y="5310963"/>
+              <a:ext cx="126099" cy="397983"/>
+            </a:xfrm>
+            <a:prstGeom prst="line">
+              <a:avLst/>
+            </a:prstGeom>
+            <a:ln w="31750">
+              <a:solidFill>
+                <a:schemeClr val="tx1"/>
+              </a:solidFill>
+            </a:ln>
+          </p:spPr>
+          <p:style>
+            <a:lnRef idx="2">
+              <a:schemeClr val="accent1"/>
+            </a:lnRef>
+            <a:fillRef idx="0">
+              <a:schemeClr val="accent1"/>
+            </a:fillRef>
+            <a:effectRef idx="1">
+              <a:schemeClr val="accent1"/>
+            </a:effectRef>
+            <a:fontRef idx="minor">
+              <a:schemeClr val="tx1"/>
+            </a:fontRef>
+          </p:style>
+        </p:cxnSp>
+        <p:sp>
+          <p:nvSpPr>
+            <p:cNvPr id="118" name="TextBox 117">
+              <a:extLst>
+                <a:ext uri="{FF2B5EF4-FFF2-40B4-BE49-F238E27FC236}">
+                  <a16:creationId xmlns:a16="http://schemas.microsoft.com/office/drawing/2014/main" id="{43132931-2181-0358-9025-FE93DECC5822}"/>
+                </a:ext>
+              </a:extLst>
+            </p:cNvPr>
+            <p:cNvSpPr txBox="1"/>
+            <p:nvPr/>
+          </p:nvSpPr>
+          <p:spPr>
+            <a:xfrm>
+              <a:off x="4002504" y="4069211"/>
+              <a:ext cx="654908" cy="461665"/>
+            </a:xfrm>
+            <a:prstGeom prst="rect">
+              <a:avLst/>
+            </a:prstGeom>
+            <a:noFill/>
+          </p:spPr>
+          <p:txBody>
+            <a:bodyPr wrap="square" rtlCol="0">
+              <a:spAutoFit/>
+            </a:bodyPr>
+            <a:lstStyle/>
+            <a:p>
+              <a:pPr algn="ctr"/>
+              <a:r>
+                <a:rPr lang="en-US" sz="2400" dirty="0"/>
+                <a:t>32</a:t>
+              </a:r>
+            </a:p>
+          </p:txBody>
+        </p:sp>
+        <p:sp>
+          <p:nvSpPr>
+            <p:cNvPr id="119" name="TextBox 118">
+              <a:extLst>
+                <a:ext uri="{FF2B5EF4-FFF2-40B4-BE49-F238E27FC236}">
+                  <a16:creationId xmlns:a16="http://schemas.microsoft.com/office/drawing/2014/main" id="{318F769D-6D75-FEF3-8629-50C3B3EEB1A8}"/>
+                </a:ext>
+              </a:extLst>
+            </p:cNvPr>
+            <p:cNvSpPr txBox="1"/>
+            <p:nvPr/>
+          </p:nvSpPr>
+          <p:spPr>
+            <a:xfrm>
+              <a:off x="1675864" y="4012980"/>
+              <a:ext cx="654908" cy="461665"/>
+            </a:xfrm>
+            <a:prstGeom prst="rect">
+              <a:avLst/>
+            </a:prstGeom>
+            <a:noFill/>
+          </p:spPr>
+          <p:txBody>
+            <a:bodyPr wrap="square" rtlCol="0">
+              <a:spAutoFit/>
+            </a:bodyPr>
+            <a:lstStyle/>
+            <a:p>
+              <a:pPr algn="ctr"/>
+              <a:r>
+                <a:rPr lang="en-US" sz="2400" dirty="0"/>
+                <a:t>24</a:t>
+              </a:r>
+            </a:p>
+          </p:txBody>
+        </p:sp>
+        <p:sp>
+          <p:nvSpPr>
+            <p:cNvPr id="120" name="TextBox 119">
+              <a:extLst>
+                <a:ext uri="{FF2B5EF4-FFF2-40B4-BE49-F238E27FC236}">
+                  <a16:creationId xmlns:a16="http://schemas.microsoft.com/office/drawing/2014/main" id="{73BA9F1C-4011-3116-9BC8-7808AB74D149}"/>
+                </a:ext>
+              </a:extLst>
+            </p:cNvPr>
+            <p:cNvSpPr txBox="1"/>
+            <p:nvPr/>
+          </p:nvSpPr>
+          <p:spPr>
+            <a:xfrm>
+              <a:off x="1054410" y="4810725"/>
+              <a:ext cx="654908" cy="461665"/>
+            </a:xfrm>
+            <a:prstGeom prst="rect">
+              <a:avLst/>
+            </a:prstGeom>
+            <a:noFill/>
+          </p:spPr>
+          <p:txBody>
+            <a:bodyPr wrap="square" rtlCol="0">
+              <a:spAutoFit/>
+            </a:bodyPr>
+            <a:lstStyle/>
+            <a:p>
+              <a:pPr algn="ctr"/>
+              <a:r>
+                <a:rPr lang="en-US" sz="2400" dirty="0"/>
+                <a:t>41</a:t>
+              </a:r>
+            </a:p>
+          </p:txBody>
+        </p:sp>
+        <p:sp>
+          <p:nvSpPr>
+            <p:cNvPr id="121" name="TextBox 120">
+              <a:extLst>
+                <a:ext uri="{FF2B5EF4-FFF2-40B4-BE49-F238E27FC236}">
+                  <a16:creationId xmlns:a16="http://schemas.microsoft.com/office/drawing/2014/main" id="{DC4ACEFF-F814-4908-3FEC-A05988081730}"/>
+                </a:ext>
+              </a:extLst>
+            </p:cNvPr>
+            <p:cNvSpPr txBox="1"/>
+            <p:nvPr/>
+          </p:nvSpPr>
+          <p:spPr>
+            <a:xfrm>
+              <a:off x="2719756" y="5332563"/>
+              <a:ext cx="654908" cy="461665"/>
+            </a:xfrm>
+            <a:prstGeom prst="rect">
+              <a:avLst/>
+            </a:prstGeom>
+            <a:noFill/>
+          </p:spPr>
+          <p:txBody>
+            <a:bodyPr wrap="square" rtlCol="0">
+              <a:spAutoFit/>
+            </a:bodyPr>
+            <a:lstStyle/>
+            <a:p>
+              <a:pPr algn="ctr"/>
+              <a:r>
+                <a:rPr lang="en-US" sz="2400" dirty="0"/>
+                <a:t>5</a:t>
+              </a:r>
+            </a:p>
+          </p:txBody>
+        </p:sp>
+      </p:grpSp>
+      <p:sp>
+        <p:nvSpPr>
+          <p:cNvPr id="146" name="TextBox 145">
+            <a:extLst>
+              <a:ext uri="{FF2B5EF4-FFF2-40B4-BE49-F238E27FC236}">
+                <a16:creationId xmlns:a16="http://schemas.microsoft.com/office/drawing/2014/main" id="{1DE3FE3B-4B7F-9012-3351-08A6C2E2D45D}"/>
+              </a:ext>
+            </a:extLst>
+          </p:cNvPr>
+          <p:cNvSpPr txBox="1"/>
+          <p:nvPr/>
+        </p:nvSpPr>
+        <p:spPr>
+          <a:xfrm>
+            <a:off x="6570805" y="3356801"/>
+            <a:ext cx="1115654" cy="369332"/>
+          </a:xfrm>
+          <a:prstGeom prst="rect">
+            <a:avLst/>
+          </a:prstGeom>
+          <a:noFill/>
+        </p:spPr>
+        <p:txBody>
+          <a:bodyPr wrap="square" rtlCol="0">
+            <a:spAutoFit/>
+          </a:bodyPr>
+          <a:lstStyle/>
+          <a:p>
+            <a:r>
+              <a:rPr lang="en-US" dirty="0"/>
+              <a:t>Fenwick</a:t>
+            </a:r>
+          </a:p>
+        </p:txBody>
+      </p:sp>
+      <p:grpSp>
+        <p:nvGrpSpPr>
+          <p:cNvPr id="161" name="Group 160">
+            <a:extLst>
+              <a:ext uri="{FF2B5EF4-FFF2-40B4-BE49-F238E27FC236}">
+                <a16:creationId xmlns:a16="http://schemas.microsoft.com/office/drawing/2014/main" id="{5D5FE7F6-109B-74A6-AA89-B1E5CBDBA62B}"/>
+              </a:ext>
+            </a:extLst>
+          </p:cNvPr>
+          <p:cNvGrpSpPr/>
+          <p:nvPr/>
+        </p:nvGrpSpPr>
+        <p:grpSpPr>
+          <a:xfrm>
+            <a:off x="6619389" y="241176"/>
+            <a:ext cx="5517534" cy="6359006"/>
+            <a:chOff x="6619389" y="241176"/>
+            <a:chExt cx="5517534" cy="6359006"/>
+          </a:xfrm>
+        </p:grpSpPr>
+        <p:sp>
+          <p:nvSpPr>
+            <p:cNvPr id="111" name="Oval 110">
+              <a:extLst>
+                <a:ext uri="{FF2B5EF4-FFF2-40B4-BE49-F238E27FC236}">
+                  <a16:creationId xmlns:a16="http://schemas.microsoft.com/office/drawing/2014/main" id="{C63B4B8F-493B-2448-8664-868D2B4C7003}"/>
+                </a:ext>
+              </a:extLst>
+            </p:cNvPr>
+            <p:cNvSpPr/>
+            <p:nvPr/>
+          </p:nvSpPr>
+          <p:spPr>
+            <a:xfrm>
+              <a:off x="8455414" y="241176"/>
+              <a:ext cx="900000" cy="900000"/>
+            </a:xfrm>
+            <a:prstGeom prst="ellipse">
+              <a:avLst/>
+            </a:prstGeom>
+            <a:noFill/>
+            <a:ln w="38100">
+              <a:solidFill>
+                <a:schemeClr val="accent1">
+                  <a:lumMod val="60000"/>
+                  <a:lumOff val="40000"/>
+                </a:schemeClr>
+              </a:solidFill>
+            </a:ln>
+          </p:spPr>
+          <p:style>
+            <a:lnRef idx="2">
+              <a:schemeClr val="accent1">
+                <a:shade val="15000"/>
+              </a:schemeClr>
+            </a:lnRef>
+            <a:fillRef idx="1">
+              <a:schemeClr val="accent1"/>
+            </a:fillRef>
+            <a:effectRef idx="0">
+              <a:schemeClr val="accent1"/>
+            </a:effectRef>
+            <a:fontRef idx="minor">
+              <a:schemeClr val="lt1"/>
+            </a:fontRef>
+          </p:style>
+          <p:txBody>
+            <a:bodyPr rtlCol="0" anchor="ctr"/>
+            <a:lstStyle/>
+            <a:p>
+              <a:pPr algn="ctr"/>
+              <a:endParaRPr lang="en-US"/>
+            </a:p>
+          </p:txBody>
+        </p:sp>
+        <p:sp>
+          <p:nvSpPr>
+            <p:cNvPr id="112" name="TextBox 111">
+              <a:extLst>
+                <a:ext uri="{FF2B5EF4-FFF2-40B4-BE49-F238E27FC236}">
+                  <a16:creationId xmlns:a16="http://schemas.microsoft.com/office/drawing/2014/main" id="{7EE30EA5-128D-9698-1BEA-DA7102282D15}"/>
+                </a:ext>
+              </a:extLst>
+            </p:cNvPr>
+            <p:cNvSpPr txBox="1"/>
+            <p:nvPr/>
+          </p:nvSpPr>
+          <p:spPr>
+            <a:xfrm>
+              <a:off x="8486816" y="506510"/>
+              <a:ext cx="1115654" cy="369332"/>
+            </a:xfrm>
+            <a:prstGeom prst="rect">
+              <a:avLst/>
+            </a:prstGeom>
+            <a:noFill/>
+          </p:spPr>
+          <p:txBody>
+            <a:bodyPr wrap="square" rtlCol="0">
+              <a:spAutoFit/>
+            </a:bodyPr>
+            <a:lstStyle/>
+            <a:p>
+              <a:r>
+                <a:rPr lang="en-US" dirty="0">
+                  <a:solidFill>
+                    <a:schemeClr val="accent1">
+                      <a:lumMod val="60000"/>
+                      <a:lumOff val="40000"/>
+                    </a:schemeClr>
+                  </a:solidFill>
+                </a:rPr>
+                <a:t>Glenby</a:t>
+              </a:r>
+            </a:p>
+          </p:txBody>
+        </p:sp>
+        <p:cxnSp>
+          <p:nvCxnSpPr>
+            <p:cNvPr id="114" name="Straight Connector 113">
+              <a:extLst>
+                <a:ext uri="{FF2B5EF4-FFF2-40B4-BE49-F238E27FC236}">
+                  <a16:creationId xmlns:a16="http://schemas.microsoft.com/office/drawing/2014/main" id="{A773C88E-CD7F-B8F3-11DA-2E159491D435}"/>
+                </a:ext>
+              </a:extLst>
+            </p:cNvPr>
+            <p:cNvCxnSpPr>
+              <a:cxnSpLocks/>
+              <a:stCxn id="111" idx="2"/>
+              <a:endCxn id="127" idx="0"/>
+            </p:cNvCxnSpPr>
+            <p:nvPr/>
+          </p:nvCxnSpPr>
+          <p:spPr>
+            <a:xfrm flipH="1">
+              <a:off x="7069389" y="691176"/>
+              <a:ext cx="1386025" cy="2413040"/>
+            </a:xfrm>
+            <a:prstGeom prst="line">
+              <a:avLst/>
+            </a:prstGeom>
+            <a:ln w="31750">
+              <a:solidFill>
+                <a:schemeClr val="accent1">
+                  <a:lumMod val="60000"/>
+                  <a:lumOff val="40000"/>
+                </a:schemeClr>
+              </a:solidFill>
+            </a:ln>
+          </p:spPr>
+          <p:style>
+            <a:lnRef idx="2">
+              <a:schemeClr val="accent1"/>
+            </a:lnRef>
+            <a:fillRef idx="0">
+              <a:schemeClr val="accent1"/>
+            </a:fillRef>
+            <a:effectRef idx="1">
+              <a:schemeClr val="accent1"/>
+            </a:effectRef>
+            <a:fontRef idx="minor">
+              <a:schemeClr val="tx1"/>
+            </a:fontRef>
+          </p:style>
+        </p:cxnSp>
+        <p:cxnSp>
+          <p:nvCxnSpPr>
+            <p:cNvPr id="115" name="Straight Connector 114">
+              <a:extLst>
+                <a:ext uri="{FF2B5EF4-FFF2-40B4-BE49-F238E27FC236}">
+                  <a16:creationId xmlns:a16="http://schemas.microsoft.com/office/drawing/2014/main" id="{229B8435-9CC1-145D-9CB1-AFEE2646401D}"/>
+                </a:ext>
+              </a:extLst>
+            </p:cNvPr>
+            <p:cNvCxnSpPr>
+              <a:cxnSpLocks/>
+              <a:stCxn id="111" idx="5"/>
+              <a:endCxn id="124" idx="1"/>
+            </p:cNvCxnSpPr>
+            <p:nvPr/>
+          </p:nvCxnSpPr>
+          <p:spPr>
+            <a:xfrm>
+              <a:off x="9223612" y="1009374"/>
+              <a:ext cx="1952320" cy="1262816"/>
+            </a:xfrm>
+            <a:prstGeom prst="line">
+              <a:avLst/>
+            </a:prstGeom>
+            <a:ln w="31750">
+              <a:solidFill>
+                <a:schemeClr val="accent1">
+                  <a:lumMod val="60000"/>
+                  <a:lumOff val="40000"/>
+                </a:schemeClr>
+              </a:solidFill>
+            </a:ln>
+          </p:spPr>
+          <p:style>
+            <a:lnRef idx="2">
+              <a:schemeClr val="accent1"/>
+            </a:lnRef>
+            <a:fillRef idx="0">
+              <a:schemeClr val="accent1"/>
+            </a:fillRef>
+            <a:effectRef idx="1">
+              <a:schemeClr val="accent1"/>
+            </a:effectRef>
+            <a:fontRef idx="minor">
+              <a:schemeClr val="tx1"/>
+            </a:fontRef>
+          </p:style>
+        </p:cxnSp>
+        <p:cxnSp>
+          <p:nvCxnSpPr>
+            <p:cNvPr id="116" name="Straight Connector 115">
+              <a:extLst>
+                <a:ext uri="{FF2B5EF4-FFF2-40B4-BE49-F238E27FC236}">
+                  <a16:creationId xmlns:a16="http://schemas.microsoft.com/office/drawing/2014/main" id="{E198A755-DB47-96A1-1380-08FB2A234AA0}"/>
+                </a:ext>
+              </a:extLst>
+            </p:cNvPr>
+            <p:cNvCxnSpPr>
+              <a:cxnSpLocks/>
+              <a:endCxn id="111" idx="4"/>
+            </p:cNvCxnSpPr>
+            <p:nvPr/>
+          </p:nvCxnSpPr>
+          <p:spPr>
+            <a:xfrm flipH="1" flipV="1">
+              <a:off x="8905414" y="1141176"/>
+              <a:ext cx="46032" cy="384099"/>
+            </a:xfrm>
+            <a:prstGeom prst="line">
+              <a:avLst/>
+            </a:prstGeom>
+            <a:ln w="31750">
+              <a:solidFill>
+                <a:schemeClr val="accent1">
+                  <a:lumMod val="60000"/>
+                  <a:lumOff val="40000"/>
+                </a:schemeClr>
+              </a:solidFill>
+            </a:ln>
+          </p:spPr>
+          <p:style>
+            <a:lnRef idx="2">
+              <a:schemeClr val="accent1"/>
+            </a:lnRef>
+            <a:fillRef idx="0">
+              <a:schemeClr val="accent1"/>
+            </a:fillRef>
+            <a:effectRef idx="1">
+              <a:schemeClr val="accent1"/>
+            </a:effectRef>
+            <a:fontRef idx="minor">
+              <a:schemeClr val="tx1"/>
+            </a:fontRef>
+          </p:style>
+        </p:cxnSp>
+        <p:sp>
+          <p:nvSpPr>
+            <p:cNvPr id="123" name="Oval 122">
+              <a:extLst>
+                <a:ext uri="{FF2B5EF4-FFF2-40B4-BE49-F238E27FC236}">
+                  <a16:creationId xmlns:a16="http://schemas.microsoft.com/office/drawing/2014/main" id="{4365B91A-6F0A-7165-93D9-A7BAA77C22B9}"/>
+                </a:ext>
+              </a:extLst>
+            </p:cNvPr>
+            <p:cNvSpPr/>
+            <p:nvPr/>
+          </p:nvSpPr>
+          <p:spPr>
+            <a:xfrm>
+              <a:off x="8559400" y="1538273"/>
+              <a:ext cx="900000" cy="900000"/>
+            </a:xfrm>
+            <a:prstGeom prst="ellipse">
+              <a:avLst/>
+            </a:prstGeom>
+            <a:noFill/>
+            <a:ln w="38100"/>
+          </p:spPr>
+          <p:style>
+            <a:lnRef idx="2">
+              <a:schemeClr val="accent1">
+                <a:shade val="15000"/>
+              </a:schemeClr>
+            </a:lnRef>
+            <a:fillRef idx="1">
+              <a:schemeClr val="accent1"/>
+            </a:fillRef>
+            <a:effectRef idx="0">
+              <a:schemeClr val="accent1"/>
+            </a:effectRef>
+            <a:fontRef idx="minor">
+              <a:schemeClr val="lt1"/>
+            </a:fontRef>
+          </p:style>
+          <p:txBody>
+            <a:bodyPr rtlCol="0" anchor="ctr"/>
+            <a:lstStyle/>
+            <a:p>
+              <a:pPr algn="ctr"/>
+              <a:endParaRPr lang="en-US"/>
+            </a:p>
+          </p:txBody>
+        </p:sp>
+        <p:sp>
+          <p:nvSpPr>
+            <p:cNvPr id="124" name="Oval 123">
+              <a:extLst>
+                <a:ext uri="{FF2B5EF4-FFF2-40B4-BE49-F238E27FC236}">
+                  <a16:creationId xmlns:a16="http://schemas.microsoft.com/office/drawing/2014/main" id="{A13F0B98-D814-9718-9925-D2611AAF5D33}"/>
+                </a:ext>
+              </a:extLst>
+            </p:cNvPr>
+            <p:cNvSpPr/>
+            <p:nvPr/>
+          </p:nvSpPr>
+          <p:spPr>
+            <a:xfrm>
+              <a:off x="11044130" y="2140388"/>
+              <a:ext cx="900000" cy="900000"/>
+            </a:xfrm>
+            <a:prstGeom prst="ellipse">
+              <a:avLst/>
+            </a:prstGeom>
+            <a:noFill/>
+            <a:ln w="38100"/>
+          </p:spPr>
+          <p:style>
+            <a:lnRef idx="2">
+              <a:schemeClr val="accent1">
+                <a:shade val="15000"/>
+              </a:schemeClr>
+            </a:lnRef>
+            <a:fillRef idx="1">
+              <a:schemeClr val="accent1"/>
+            </a:fillRef>
+            <a:effectRef idx="0">
+              <a:schemeClr val="accent1"/>
+            </a:effectRef>
+            <a:fontRef idx="minor">
+              <a:schemeClr val="lt1"/>
+            </a:fontRef>
+          </p:style>
+          <p:txBody>
+            <a:bodyPr rtlCol="0" anchor="ctr"/>
+            <a:lstStyle/>
+            <a:p>
+              <a:pPr algn="ctr"/>
+              <a:endParaRPr lang="en-US"/>
+            </a:p>
+          </p:txBody>
+        </p:sp>
+        <p:sp>
+          <p:nvSpPr>
+            <p:cNvPr id="125" name="Oval 124">
+              <a:extLst>
+                <a:ext uri="{FF2B5EF4-FFF2-40B4-BE49-F238E27FC236}">
+                  <a16:creationId xmlns:a16="http://schemas.microsoft.com/office/drawing/2014/main" id="{1DA5C821-403F-D821-2B0A-AE1E8AC72B3E}"/>
+                </a:ext>
+              </a:extLst>
+            </p:cNvPr>
+            <p:cNvSpPr/>
+            <p:nvPr/>
+          </p:nvSpPr>
+          <p:spPr>
+            <a:xfrm>
+              <a:off x="9239022" y="2847820"/>
+              <a:ext cx="900000" cy="900000"/>
+            </a:xfrm>
+            <a:prstGeom prst="ellipse">
+              <a:avLst/>
+            </a:prstGeom>
+            <a:noFill/>
+            <a:ln w="38100"/>
+          </p:spPr>
+          <p:style>
+            <a:lnRef idx="2">
+              <a:schemeClr val="accent1">
+                <a:shade val="15000"/>
+              </a:schemeClr>
+            </a:lnRef>
+            <a:fillRef idx="1">
+              <a:schemeClr val="accent1"/>
+            </a:fillRef>
+            <a:effectRef idx="0">
+              <a:schemeClr val="accent1"/>
+            </a:effectRef>
+            <a:fontRef idx="minor">
+              <a:schemeClr val="lt1"/>
+            </a:fontRef>
+          </p:style>
+          <p:txBody>
+            <a:bodyPr rtlCol="0" anchor="ctr"/>
+            <a:lstStyle/>
+            <a:p>
+              <a:pPr algn="ctr"/>
+              <a:endParaRPr lang="en-US"/>
+            </a:p>
+          </p:txBody>
+        </p:sp>
+        <p:sp>
+          <p:nvSpPr>
+            <p:cNvPr id="126" name="Oval 125">
+              <a:extLst>
+                <a:ext uri="{FF2B5EF4-FFF2-40B4-BE49-F238E27FC236}">
+                  <a16:creationId xmlns:a16="http://schemas.microsoft.com/office/drawing/2014/main" id="{D4843A57-934C-3A1F-0951-0A55E54A53F6}"/>
+                </a:ext>
+              </a:extLst>
+            </p:cNvPr>
+            <p:cNvSpPr/>
+            <p:nvPr/>
+          </p:nvSpPr>
+          <p:spPr>
+            <a:xfrm>
+              <a:off x="8651022" y="4402199"/>
+              <a:ext cx="900000" cy="900000"/>
+            </a:xfrm>
+            <a:prstGeom prst="ellipse">
+              <a:avLst/>
+            </a:prstGeom>
+            <a:noFill/>
+            <a:ln w="38100"/>
+          </p:spPr>
+          <p:style>
+            <a:lnRef idx="2">
+              <a:schemeClr val="accent1">
+                <a:shade val="15000"/>
+              </a:schemeClr>
+            </a:lnRef>
+            <a:fillRef idx="1">
+              <a:schemeClr val="accent1"/>
+            </a:fillRef>
+            <a:effectRef idx="0">
+              <a:schemeClr val="accent1"/>
+            </a:effectRef>
+            <a:fontRef idx="minor">
+              <a:schemeClr val="lt1"/>
+            </a:fontRef>
+          </p:style>
+          <p:txBody>
+            <a:bodyPr rtlCol="0" anchor="ctr"/>
+            <a:lstStyle/>
+            <a:p>
+              <a:pPr algn="ctr"/>
+              <a:endParaRPr lang="en-US"/>
+            </a:p>
+          </p:txBody>
+        </p:sp>
+        <p:sp>
+          <p:nvSpPr>
+            <p:cNvPr id="127" name="Oval 126">
+              <a:extLst>
+                <a:ext uri="{FF2B5EF4-FFF2-40B4-BE49-F238E27FC236}">
+                  <a16:creationId xmlns:a16="http://schemas.microsoft.com/office/drawing/2014/main" id="{FA0EAEB6-933C-0344-DB08-6E57355F2543}"/>
+                </a:ext>
+              </a:extLst>
+            </p:cNvPr>
+            <p:cNvSpPr/>
+            <p:nvPr/>
+          </p:nvSpPr>
+          <p:spPr>
+            <a:xfrm>
+              <a:off x="6619389" y="3104216"/>
+              <a:ext cx="900000" cy="900000"/>
+            </a:xfrm>
+            <a:prstGeom prst="ellipse">
+              <a:avLst/>
+            </a:prstGeom>
+            <a:noFill/>
+            <a:ln w="38100"/>
+          </p:spPr>
+          <p:style>
+            <a:lnRef idx="2">
+              <a:schemeClr val="accent1">
+                <a:shade val="15000"/>
+              </a:schemeClr>
+            </a:lnRef>
+            <a:fillRef idx="1">
+              <a:schemeClr val="accent1"/>
+            </a:fillRef>
+            <a:effectRef idx="0">
+              <a:schemeClr val="accent1"/>
+            </a:effectRef>
+            <a:fontRef idx="minor">
+              <a:schemeClr val="lt1"/>
+            </a:fontRef>
+          </p:style>
+          <p:txBody>
+            <a:bodyPr rtlCol="0" anchor="ctr"/>
+            <a:lstStyle/>
+            <a:p>
+              <a:pPr algn="ctr"/>
+              <a:endParaRPr lang="en-US"/>
+            </a:p>
+          </p:txBody>
+        </p:sp>
+        <p:cxnSp>
+          <p:nvCxnSpPr>
+            <p:cNvPr id="128" name="Straight Connector 127">
+              <a:extLst>
+                <a:ext uri="{FF2B5EF4-FFF2-40B4-BE49-F238E27FC236}">
+                  <a16:creationId xmlns:a16="http://schemas.microsoft.com/office/drawing/2014/main" id="{93FA48F9-71C2-9120-04B5-92B03A894FBB}"/>
+                </a:ext>
+              </a:extLst>
+            </p:cNvPr>
+            <p:cNvCxnSpPr>
+              <a:cxnSpLocks/>
+              <a:stCxn id="123" idx="4"/>
+              <a:endCxn id="125" idx="1"/>
+            </p:cNvCxnSpPr>
+            <p:nvPr/>
+          </p:nvCxnSpPr>
+          <p:spPr>
+            <a:xfrm>
+              <a:off x="9009400" y="2438273"/>
+              <a:ext cx="361424" cy="541349"/>
+            </a:xfrm>
+            <a:prstGeom prst="line">
+              <a:avLst/>
+            </a:prstGeom>
+            <a:ln w="31750">
+              <a:solidFill>
+                <a:schemeClr val="tx1"/>
+              </a:solidFill>
+            </a:ln>
+          </p:spPr>
+          <p:style>
+            <a:lnRef idx="2">
+              <a:schemeClr val="accent1"/>
+            </a:lnRef>
+            <a:fillRef idx="0">
+              <a:schemeClr val="accent1"/>
+            </a:fillRef>
+            <a:effectRef idx="1">
+              <a:schemeClr val="accent1"/>
+            </a:effectRef>
+            <a:fontRef idx="minor">
+              <a:schemeClr val="tx1"/>
+            </a:fontRef>
+          </p:style>
+        </p:cxnSp>
+        <p:cxnSp>
+          <p:nvCxnSpPr>
+            <p:cNvPr id="129" name="Straight Connector 128">
+              <a:extLst>
+                <a:ext uri="{FF2B5EF4-FFF2-40B4-BE49-F238E27FC236}">
+                  <a16:creationId xmlns:a16="http://schemas.microsoft.com/office/drawing/2014/main" id="{3DFCCE19-5A7E-8716-3E1C-4DB01E1B5384}"/>
+                </a:ext>
+              </a:extLst>
+            </p:cNvPr>
+            <p:cNvCxnSpPr>
+              <a:stCxn id="123" idx="3"/>
+              <a:endCxn id="127" idx="7"/>
+            </p:cNvCxnSpPr>
+            <p:nvPr/>
+          </p:nvCxnSpPr>
+          <p:spPr>
+            <a:xfrm flipH="1">
+              <a:off x="7387587" y="2306471"/>
+              <a:ext cx="1303615" cy="929547"/>
+            </a:xfrm>
+            <a:prstGeom prst="line">
+              <a:avLst/>
+            </a:prstGeom>
+            <a:ln w="31750">
+              <a:solidFill>
+                <a:schemeClr val="tx1"/>
+              </a:solidFill>
+            </a:ln>
+          </p:spPr>
+          <p:style>
+            <a:lnRef idx="2">
+              <a:schemeClr val="accent1"/>
+            </a:lnRef>
+            <a:fillRef idx="0">
+              <a:schemeClr val="accent1"/>
+            </a:fillRef>
+            <a:effectRef idx="1">
+              <a:schemeClr val="accent1"/>
+            </a:effectRef>
+            <a:fontRef idx="minor">
+              <a:schemeClr val="tx1"/>
+            </a:fontRef>
+          </p:style>
+        </p:cxnSp>
+        <p:cxnSp>
+          <p:nvCxnSpPr>
+            <p:cNvPr id="130" name="Straight Connector 129">
+              <a:extLst>
+                <a:ext uri="{FF2B5EF4-FFF2-40B4-BE49-F238E27FC236}">
+                  <a16:creationId xmlns:a16="http://schemas.microsoft.com/office/drawing/2014/main" id="{30817B24-7AAA-538F-1942-884C5054C71D}"/>
+                </a:ext>
+              </a:extLst>
+            </p:cNvPr>
+            <p:cNvCxnSpPr>
+              <a:stCxn id="127" idx="5"/>
+              <a:endCxn id="126" idx="2"/>
+            </p:cNvCxnSpPr>
+            <p:nvPr/>
+          </p:nvCxnSpPr>
+          <p:spPr>
+            <a:xfrm>
+              <a:off x="7387587" y="3872414"/>
+              <a:ext cx="1263435" cy="979785"/>
+            </a:xfrm>
+            <a:prstGeom prst="line">
+              <a:avLst/>
+            </a:prstGeom>
+            <a:ln w="31750">
+              <a:solidFill>
+                <a:schemeClr val="tx1"/>
+              </a:solidFill>
+            </a:ln>
+          </p:spPr>
+          <p:style>
+            <a:lnRef idx="2">
+              <a:schemeClr val="accent1"/>
+            </a:lnRef>
+            <a:fillRef idx="0">
+              <a:schemeClr val="accent1"/>
+            </a:fillRef>
+            <a:effectRef idx="1">
+              <a:schemeClr val="accent1"/>
+            </a:effectRef>
+            <a:fontRef idx="minor">
+              <a:schemeClr val="tx1"/>
+            </a:fontRef>
+          </p:style>
+        </p:cxnSp>
+        <p:cxnSp>
+          <p:nvCxnSpPr>
+            <p:cNvPr id="131" name="Straight Connector 130">
+              <a:extLst>
+                <a:ext uri="{FF2B5EF4-FFF2-40B4-BE49-F238E27FC236}">
+                  <a16:creationId xmlns:a16="http://schemas.microsoft.com/office/drawing/2014/main" id="{698A2297-D560-157C-5E72-B14519BA8839}"/>
+                </a:ext>
+              </a:extLst>
+            </p:cNvPr>
+            <p:cNvCxnSpPr>
+              <a:stCxn id="127" idx="6"/>
+              <a:endCxn id="125" idx="2"/>
+            </p:cNvCxnSpPr>
+            <p:nvPr/>
+          </p:nvCxnSpPr>
+          <p:spPr>
+            <a:xfrm flipV="1">
+              <a:off x="7519389" y="3297820"/>
+              <a:ext cx="1719633" cy="256396"/>
+            </a:xfrm>
+            <a:prstGeom prst="line">
+              <a:avLst/>
+            </a:prstGeom>
+            <a:ln w="31750">
+              <a:solidFill>
+                <a:srgbClr val="FF0000"/>
+              </a:solidFill>
+            </a:ln>
+          </p:spPr>
+          <p:style>
+            <a:lnRef idx="2">
+              <a:schemeClr val="accent1"/>
+            </a:lnRef>
+            <a:fillRef idx="0">
+              <a:schemeClr val="accent1"/>
+            </a:fillRef>
+            <a:effectRef idx="1">
+              <a:schemeClr val="accent1"/>
+            </a:effectRef>
+            <a:fontRef idx="minor">
+              <a:schemeClr val="tx1"/>
+            </a:fontRef>
+          </p:style>
+        </p:cxnSp>
+        <p:cxnSp>
+          <p:nvCxnSpPr>
+            <p:cNvPr id="132" name="Straight Connector 131">
+              <a:extLst>
+                <a:ext uri="{FF2B5EF4-FFF2-40B4-BE49-F238E27FC236}">
+                  <a16:creationId xmlns:a16="http://schemas.microsoft.com/office/drawing/2014/main" id="{7DC3E761-80DA-4C87-F209-D4482C580FCC}"/>
+                </a:ext>
+              </a:extLst>
+            </p:cNvPr>
+            <p:cNvCxnSpPr>
+              <a:stCxn id="126" idx="7"/>
+              <a:endCxn id="125" idx="4"/>
+            </p:cNvCxnSpPr>
+            <p:nvPr/>
+          </p:nvCxnSpPr>
+          <p:spPr>
+            <a:xfrm flipV="1">
+              <a:off x="9419220" y="3747820"/>
+              <a:ext cx="269802" cy="786181"/>
+            </a:xfrm>
+            <a:prstGeom prst="line">
+              <a:avLst/>
+            </a:prstGeom>
+            <a:ln w="31750">
+              <a:solidFill>
+                <a:schemeClr val="tx1"/>
+              </a:solidFill>
+            </a:ln>
+          </p:spPr>
+          <p:style>
+            <a:lnRef idx="2">
+              <a:schemeClr val="accent1"/>
+            </a:lnRef>
+            <a:fillRef idx="0">
+              <a:schemeClr val="accent1"/>
+            </a:fillRef>
+            <a:effectRef idx="1">
+              <a:schemeClr val="accent1"/>
+            </a:effectRef>
+            <a:fontRef idx="minor">
+              <a:schemeClr val="tx1"/>
+            </a:fontRef>
+          </p:style>
+        </p:cxnSp>
+        <p:cxnSp>
+          <p:nvCxnSpPr>
+            <p:cNvPr id="133" name="Straight Connector 132">
+              <a:extLst>
+                <a:ext uri="{FF2B5EF4-FFF2-40B4-BE49-F238E27FC236}">
+                  <a16:creationId xmlns:a16="http://schemas.microsoft.com/office/drawing/2014/main" id="{72913842-4EBC-B4EC-6E90-D6F7683223BF}"/>
+                </a:ext>
+              </a:extLst>
+            </p:cNvPr>
+            <p:cNvCxnSpPr>
+              <a:stCxn id="123" idx="6"/>
+              <a:endCxn id="124" idx="2"/>
+            </p:cNvCxnSpPr>
+            <p:nvPr/>
+          </p:nvCxnSpPr>
+          <p:spPr>
+            <a:xfrm>
+              <a:off x="9459400" y="1988273"/>
+              <a:ext cx="1584730" cy="602115"/>
+            </a:xfrm>
+            <a:prstGeom prst="line">
+              <a:avLst/>
+            </a:prstGeom>
+            <a:ln w="31750">
+              <a:solidFill>
+                <a:schemeClr val="tx1"/>
+              </a:solidFill>
+            </a:ln>
+          </p:spPr>
+          <p:style>
+            <a:lnRef idx="2">
+              <a:schemeClr val="accent1"/>
+            </a:lnRef>
+            <a:fillRef idx="0">
+              <a:schemeClr val="accent1"/>
+            </a:fillRef>
+            <a:effectRef idx="1">
+              <a:schemeClr val="accent1"/>
+            </a:effectRef>
+            <a:fontRef idx="minor">
+              <a:schemeClr val="tx1"/>
+            </a:fontRef>
+          </p:style>
+        </p:cxnSp>
+        <p:cxnSp>
+          <p:nvCxnSpPr>
+            <p:cNvPr id="134" name="Straight Connector 133">
+              <a:extLst>
+                <a:ext uri="{FF2B5EF4-FFF2-40B4-BE49-F238E27FC236}">
+                  <a16:creationId xmlns:a16="http://schemas.microsoft.com/office/drawing/2014/main" id="{13E0193B-2D0C-349E-DCD1-A7CF5DBF665F}"/>
+                </a:ext>
+              </a:extLst>
+            </p:cNvPr>
+            <p:cNvCxnSpPr>
+              <a:stCxn id="125" idx="6"/>
+              <a:endCxn id="124" idx="3"/>
+            </p:cNvCxnSpPr>
+            <p:nvPr/>
+          </p:nvCxnSpPr>
+          <p:spPr>
+            <a:xfrm flipV="1">
+              <a:off x="10139022" y="2908586"/>
+              <a:ext cx="1036910" cy="389234"/>
+            </a:xfrm>
+            <a:prstGeom prst="line">
+              <a:avLst/>
+            </a:prstGeom>
+            <a:ln w="31750">
+              <a:solidFill>
+                <a:schemeClr val="tx1"/>
+              </a:solidFill>
+            </a:ln>
+          </p:spPr>
+          <p:style>
+            <a:lnRef idx="2">
+              <a:schemeClr val="accent1"/>
+            </a:lnRef>
+            <a:fillRef idx="0">
+              <a:schemeClr val="accent1"/>
+            </a:fillRef>
+            <a:effectRef idx="1">
+              <a:schemeClr val="accent1"/>
+            </a:effectRef>
+            <a:fontRef idx="minor">
+              <a:schemeClr val="tx1"/>
+            </a:fontRef>
+          </p:style>
+        </p:cxnSp>
+        <p:cxnSp>
+          <p:nvCxnSpPr>
+            <p:cNvPr id="135" name="Straight Connector 134">
+              <a:extLst>
+                <a:ext uri="{FF2B5EF4-FFF2-40B4-BE49-F238E27FC236}">
+                  <a16:creationId xmlns:a16="http://schemas.microsoft.com/office/drawing/2014/main" id="{AAE12599-E5EB-E67A-8166-0EE4346D419C}"/>
+                </a:ext>
+              </a:extLst>
+            </p:cNvPr>
+            <p:cNvCxnSpPr>
+              <a:stCxn id="126" idx="6"/>
+              <a:endCxn id="124" idx="4"/>
+            </p:cNvCxnSpPr>
+            <p:nvPr/>
+          </p:nvCxnSpPr>
+          <p:spPr>
+            <a:xfrm flipV="1">
+              <a:off x="9551022" y="3040388"/>
+              <a:ext cx="1943108" cy="1811811"/>
+            </a:xfrm>
+            <a:prstGeom prst="line">
+              <a:avLst/>
+            </a:prstGeom>
+            <a:ln w="31750">
+              <a:solidFill>
+                <a:schemeClr val="tx1"/>
+              </a:solidFill>
+            </a:ln>
+          </p:spPr>
+          <p:style>
+            <a:lnRef idx="2">
+              <a:schemeClr val="accent1"/>
+            </a:lnRef>
+            <a:fillRef idx="0">
+              <a:schemeClr val="accent1"/>
+            </a:fillRef>
+            <a:effectRef idx="1">
+              <a:schemeClr val="accent1"/>
+            </a:effectRef>
+            <a:fontRef idx="minor">
+              <a:schemeClr val="tx1"/>
+            </a:fontRef>
+          </p:style>
+        </p:cxnSp>
+        <p:sp>
+          <p:nvSpPr>
+            <p:cNvPr id="136" name="TextBox 135">
+              <a:extLst>
+                <a:ext uri="{FF2B5EF4-FFF2-40B4-BE49-F238E27FC236}">
+                  <a16:creationId xmlns:a16="http://schemas.microsoft.com/office/drawing/2014/main" id="{40925F2C-3F02-51B7-F32A-7B2C595EA570}"/>
+                </a:ext>
+              </a:extLst>
+            </p:cNvPr>
+            <p:cNvSpPr txBox="1"/>
+            <p:nvPr/>
+          </p:nvSpPr>
+          <p:spPr>
+            <a:xfrm>
+              <a:off x="7520393" y="2441874"/>
+              <a:ext cx="654908" cy="461665"/>
+            </a:xfrm>
+            <a:prstGeom prst="rect">
+              <a:avLst/>
+            </a:prstGeom>
+            <a:noFill/>
+          </p:spPr>
+          <p:txBody>
+            <a:bodyPr wrap="square" rtlCol="0">
+              <a:spAutoFit/>
+            </a:bodyPr>
+            <a:lstStyle/>
+            <a:p>
+              <a:pPr algn="ctr"/>
+              <a:r>
+                <a:rPr lang="en-US" sz="2400" dirty="0"/>
+                <a:t>12</a:t>
+              </a:r>
+            </a:p>
+          </p:txBody>
+        </p:sp>
+        <p:sp>
+          <p:nvSpPr>
+            <p:cNvPr id="137" name="TextBox 136">
+              <a:extLst>
+                <a:ext uri="{FF2B5EF4-FFF2-40B4-BE49-F238E27FC236}">
+                  <a16:creationId xmlns:a16="http://schemas.microsoft.com/office/drawing/2014/main" id="{689C637E-4DD6-DEC8-7294-CE2B309EA958}"/>
+                </a:ext>
+              </a:extLst>
+            </p:cNvPr>
+            <p:cNvSpPr txBox="1"/>
+            <p:nvPr/>
+          </p:nvSpPr>
+          <p:spPr>
+            <a:xfrm>
+              <a:off x="9091766" y="2406381"/>
+              <a:ext cx="654908" cy="461665"/>
+            </a:xfrm>
+            <a:prstGeom prst="rect">
+              <a:avLst/>
+            </a:prstGeom>
+            <a:noFill/>
+          </p:spPr>
+          <p:txBody>
+            <a:bodyPr wrap="square" rtlCol="0">
+              <a:spAutoFit/>
+            </a:bodyPr>
+            <a:lstStyle/>
+            <a:p>
+              <a:pPr algn="ctr"/>
+              <a:r>
+                <a:rPr lang="en-US" sz="2400" dirty="0"/>
+                <a:t>8</a:t>
+              </a:r>
+            </a:p>
+          </p:txBody>
+        </p:sp>
+        <p:sp>
+          <p:nvSpPr>
+            <p:cNvPr id="138" name="TextBox 137">
+              <a:extLst>
+                <a:ext uri="{FF2B5EF4-FFF2-40B4-BE49-F238E27FC236}">
+                  <a16:creationId xmlns:a16="http://schemas.microsoft.com/office/drawing/2014/main" id="{6BDBCF13-8BD8-8619-F8B6-8F1959B8F78C}"/>
+                </a:ext>
+              </a:extLst>
+            </p:cNvPr>
+            <p:cNvSpPr txBox="1"/>
+            <p:nvPr/>
+          </p:nvSpPr>
+          <p:spPr>
+            <a:xfrm>
+              <a:off x="8981577" y="3843927"/>
+              <a:ext cx="654908" cy="461665"/>
+            </a:xfrm>
+            <a:prstGeom prst="rect">
+              <a:avLst/>
+            </a:prstGeom>
+            <a:noFill/>
+          </p:spPr>
+          <p:txBody>
+            <a:bodyPr wrap="square" rtlCol="0">
+              <a:spAutoFit/>
+            </a:bodyPr>
+            <a:lstStyle/>
+            <a:p>
+              <a:pPr algn="ctr"/>
+              <a:r>
+                <a:rPr lang="en-US" sz="2400" dirty="0"/>
+                <a:t>6</a:t>
+              </a:r>
+            </a:p>
+          </p:txBody>
+        </p:sp>
+        <p:sp>
+          <p:nvSpPr>
+            <p:cNvPr id="139" name="TextBox 138">
+              <a:extLst>
+                <a:ext uri="{FF2B5EF4-FFF2-40B4-BE49-F238E27FC236}">
+                  <a16:creationId xmlns:a16="http://schemas.microsoft.com/office/drawing/2014/main" id="{B43BD31F-F83A-5776-2940-6634DB822B8F}"/>
+                </a:ext>
+              </a:extLst>
+            </p:cNvPr>
+            <p:cNvSpPr txBox="1"/>
+            <p:nvPr/>
+          </p:nvSpPr>
+          <p:spPr>
+            <a:xfrm>
+              <a:off x="8033740" y="2969440"/>
+              <a:ext cx="654908" cy="461665"/>
+            </a:xfrm>
+            <a:prstGeom prst="rect">
+              <a:avLst/>
+            </a:prstGeom>
+            <a:noFill/>
+          </p:spPr>
+          <p:txBody>
+            <a:bodyPr wrap="square" rtlCol="0">
+              <a:spAutoFit/>
+            </a:bodyPr>
+            <a:lstStyle/>
+            <a:p>
+              <a:pPr algn="ctr"/>
+              <a:r>
+                <a:rPr lang="en-US" sz="2400" dirty="0">
+                  <a:solidFill>
+                    <a:srgbClr val="FF0000"/>
+                  </a:solidFill>
+                </a:rPr>
+                <a:t>10</a:t>
+              </a:r>
+            </a:p>
+          </p:txBody>
+        </p:sp>
+        <p:sp>
+          <p:nvSpPr>
+            <p:cNvPr id="140" name="TextBox 139">
+              <a:extLst>
+                <a:ext uri="{FF2B5EF4-FFF2-40B4-BE49-F238E27FC236}">
+                  <a16:creationId xmlns:a16="http://schemas.microsoft.com/office/drawing/2014/main" id="{BBFF215E-564A-F5E9-A9AC-1B9BED88CEAD}"/>
+                </a:ext>
+              </a:extLst>
+            </p:cNvPr>
+            <p:cNvSpPr txBox="1"/>
+            <p:nvPr/>
+          </p:nvSpPr>
+          <p:spPr>
+            <a:xfrm>
+              <a:off x="10023658" y="1827665"/>
+              <a:ext cx="654908" cy="461665"/>
+            </a:xfrm>
+            <a:prstGeom prst="rect">
+              <a:avLst/>
+            </a:prstGeom>
+            <a:noFill/>
+          </p:spPr>
+          <p:txBody>
+            <a:bodyPr wrap="square" rtlCol="0">
+              <a:spAutoFit/>
+            </a:bodyPr>
+            <a:lstStyle/>
+            <a:p>
+              <a:pPr algn="ctr"/>
+              <a:r>
+                <a:rPr lang="en-US" sz="2400" dirty="0"/>
+                <a:t>20</a:t>
+              </a:r>
+            </a:p>
+          </p:txBody>
+        </p:sp>
+        <p:sp>
+          <p:nvSpPr>
+            <p:cNvPr id="141" name="TextBox 140">
+              <a:extLst>
+                <a:ext uri="{FF2B5EF4-FFF2-40B4-BE49-F238E27FC236}">
+                  <a16:creationId xmlns:a16="http://schemas.microsoft.com/office/drawing/2014/main" id="{F144E1CC-D36A-DEA3-5C93-D21FC0674635}"/>
+                </a:ext>
+              </a:extLst>
+            </p:cNvPr>
+            <p:cNvSpPr txBox="1"/>
+            <p:nvPr/>
+          </p:nvSpPr>
+          <p:spPr>
+            <a:xfrm>
+              <a:off x="10206440" y="2703801"/>
+              <a:ext cx="654908" cy="461665"/>
+            </a:xfrm>
+            <a:prstGeom prst="rect">
+              <a:avLst/>
+            </a:prstGeom>
+            <a:noFill/>
+          </p:spPr>
+          <p:txBody>
+            <a:bodyPr wrap="square" rtlCol="0">
+              <a:spAutoFit/>
+            </a:bodyPr>
+            <a:lstStyle/>
+            <a:p>
+              <a:pPr algn="ctr"/>
+              <a:r>
+                <a:rPr lang="en-US" sz="2400" dirty="0"/>
+                <a:t>15</a:t>
+              </a:r>
+            </a:p>
+          </p:txBody>
+        </p:sp>
+        <p:sp>
+          <p:nvSpPr>
+            <p:cNvPr id="142" name="TextBox 141">
+              <a:extLst>
+                <a:ext uri="{FF2B5EF4-FFF2-40B4-BE49-F238E27FC236}">
+                  <a16:creationId xmlns:a16="http://schemas.microsoft.com/office/drawing/2014/main" id="{CEAF4C90-AE2C-7827-DCF3-2A271ECD185B}"/>
+                </a:ext>
+              </a:extLst>
+            </p:cNvPr>
+            <p:cNvSpPr txBox="1"/>
+            <p:nvPr/>
+          </p:nvSpPr>
+          <p:spPr>
+            <a:xfrm>
+              <a:off x="8635261" y="1797724"/>
+              <a:ext cx="778107" cy="369332"/>
+            </a:xfrm>
+            <a:prstGeom prst="rect">
+              <a:avLst/>
+            </a:prstGeom>
+            <a:noFill/>
+          </p:spPr>
+          <p:txBody>
+            <a:bodyPr wrap="square" rtlCol="0">
+              <a:spAutoFit/>
+            </a:bodyPr>
+            <a:lstStyle/>
+            <a:p>
+              <a:r>
+                <a:rPr lang="en-US" dirty="0"/>
+                <a:t>Alden</a:t>
+              </a:r>
+            </a:p>
+          </p:txBody>
+        </p:sp>
+        <p:sp>
+          <p:nvSpPr>
+            <p:cNvPr id="143" name="TextBox 142">
+              <a:extLst>
+                <a:ext uri="{FF2B5EF4-FFF2-40B4-BE49-F238E27FC236}">
+                  <a16:creationId xmlns:a16="http://schemas.microsoft.com/office/drawing/2014/main" id="{A13BB8CC-11D2-8E6B-E02E-86FA62612A81}"/>
+                </a:ext>
+              </a:extLst>
+            </p:cNvPr>
+            <p:cNvSpPr txBox="1"/>
+            <p:nvPr/>
+          </p:nvSpPr>
+          <p:spPr>
+            <a:xfrm>
+              <a:off x="11021269" y="2405722"/>
+              <a:ext cx="1115654" cy="369332"/>
+            </a:xfrm>
+            <a:prstGeom prst="rect">
+              <a:avLst/>
+            </a:prstGeom>
+            <a:noFill/>
+          </p:spPr>
+          <p:txBody>
+            <a:bodyPr wrap="square" rtlCol="0">
+              <a:spAutoFit/>
+            </a:bodyPr>
+            <a:lstStyle/>
+            <a:p>
+              <a:r>
+                <a:rPr lang="en-US" dirty="0" err="1"/>
+                <a:t>Brinford</a:t>
+              </a:r>
+              <a:endParaRPr lang="en-US" dirty="0"/>
+            </a:p>
+          </p:txBody>
+        </p:sp>
+        <p:sp>
+          <p:nvSpPr>
+            <p:cNvPr id="144" name="TextBox 143">
+              <a:extLst>
+                <a:ext uri="{FF2B5EF4-FFF2-40B4-BE49-F238E27FC236}">
+                  <a16:creationId xmlns:a16="http://schemas.microsoft.com/office/drawing/2014/main" id="{EBFAB6CE-45C4-BD24-108C-F395F700BD8A}"/>
+                </a:ext>
+              </a:extLst>
+            </p:cNvPr>
+            <p:cNvSpPr txBox="1"/>
+            <p:nvPr/>
+          </p:nvSpPr>
+          <p:spPr>
+            <a:xfrm>
+              <a:off x="8668549" y="4694454"/>
+              <a:ext cx="1115654" cy="369332"/>
+            </a:xfrm>
+            <a:prstGeom prst="rect">
+              <a:avLst/>
+            </a:prstGeom>
+            <a:noFill/>
+          </p:spPr>
+          <p:txBody>
+            <a:bodyPr wrap="square" rtlCol="0">
+              <a:spAutoFit/>
+            </a:bodyPr>
+            <a:lstStyle/>
+            <a:p>
+              <a:r>
+                <a:rPr lang="en-US" dirty="0"/>
+                <a:t>Caster</a:t>
+              </a:r>
+            </a:p>
+          </p:txBody>
+        </p:sp>
+        <p:sp>
+          <p:nvSpPr>
+            <p:cNvPr id="145" name="TextBox 144">
+              <a:extLst>
+                <a:ext uri="{FF2B5EF4-FFF2-40B4-BE49-F238E27FC236}">
+                  <a16:creationId xmlns:a16="http://schemas.microsoft.com/office/drawing/2014/main" id="{682D751E-1538-A972-A34E-222CAC8E8C43}"/>
+                </a:ext>
+              </a:extLst>
+            </p:cNvPr>
+            <p:cNvSpPr txBox="1"/>
+            <p:nvPr/>
+          </p:nvSpPr>
+          <p:spPr>
+            <a:xfrm>
+              <a:off x="9247011" y="3143802"/>
+              <a:ext cx="1115654" cy="369332"/>
+            </a:xfrm>
+            <a:prstGeom prst="rect">
+              <a:avLst/>
+            </a:prstGeom>
+            <a:noFill/>
+          </p:spPr>
+          <p:txBody>
+            <a:bodyPr wrap="square" rtlCol="0">
+              <a:spAutoFit/>
+            </a:bodyPr>
+            <a:lstStyle/>
+            <a:p>
+              <a:r>
+                <a:rPr lang="en-US" dirty="0" err="1"/>
+                <a:t>Dunvor</a:t>
+              </a:r>
+              <a:endParaRPr lang="en-US" dirty="0"/>
+            </a:p>
+          </p:txBody>
+        </p:sp>
+        <p:sp>
+          <p:nvSpPr>
+            <p:cNvPr id="147" name="Oval 146">
+              <a:extLst>
+                <a:ext uri="{FF2B5EF4-FFF2-40B4-BE49-F238E27FC236}">
+                  <a16:creationId xmlns:a16="http://schemas.microsoft.com/office/drawing/2014/main" id="{7236C944-3E04-C958-3E18-0DA0EA763104}"/>
+                </a:ext>
+              </a:extLst>
+            </p:cNvPr>
+            <p:cNvSpPr/>
+            <p:nvPr/>
+          </p:nvSpPr>
+          <p:spPr>
+            <a:xfrm>
+              <a:off x="8524923" y="5700182"/>
+              <a:ext cx="900000" cy="900000"/>
+            </a:xfrm>
+            <a:prstGeom prst="ellipse">
+              <a:avLst/>
+            </a:prstGeom>
+            <a:noFill/>
+            <a:ln w="38100"/>
+          </p:spPr>
+          <p:style>
+            <a:lnRef idx="2">
+              <a:schemeClr val="accent1">
+                <a:shade val="15000"/>
+              </a:schemeClr>
+            </a:lnRef>
+            <a:fillRef idx="1">
+              <a:schemeClr val="accent1"/>
+            </a:fillRef>
+            <a:effectRef idx="0">
+              <a:schemeClr val="accent1"/>
+            </a:effectRef>
+            <a:fontRef idx="minor">
+              <a:schemeClr val="lt1"/>
+            </a:fontRef>
+          </p:style>
+          <p:txBody>
+            <a:bodyPr rtlCol="0" anchor="ctr"/>
+            <a:lstStyle/>
+            <a:p>
+              <a:pPr algn="ctr"/>
+              <a:endParaRPr lang="en-US"/>
+            </a:p>
+          </p:txBody>
+        </p:sp>
+        <p:sp>
+          <p:nvSpPr>
+            <p:cNvPr id="148" name="TextBox 147">
+              <a:extLst>
+                <a:ext uri="{FF2B5EF4-FFF2-40B4-BE49-F238E27FC236}">
+                  <a16:creationId xmlns:a16="http://schemas.microsoft.com/office/drawing/2014/main" id="{FB687C8D-F8B7-55E4-00D4-FCF77A06E4F2}"/>
+                </a:ext>
+              </a:extLst>
+            </p:cNvPr>
+            <p:cNvSpPr txBox="1"/>
+            <p:nvPr/>
+          </p:nvSpPr>
+          <p:spPr>
+            <a:xfrm>
+              <a:off x="8591816" y="5990750"/>
+              <a:ext cx="959206" cy="369332"/>
+            </a:xfrm>
+            <a:prstGeom prst="rect">
+              <a:avLst/>
+            </a:prstGeom>
+            <a:noFill/>
+          </p:spPr>
+          <p:txBody>
+            <a:bodyPr wrap="square" rtlCol="0">
+              <a:spAutoFit/>
+            </a:bodyPr>
+            <a:lstStyle/>
+            <a:p>
+              <a:r>
+                <a:rPr lang="en-US" dirty="0" err="1"/>
+                <a:t>Elwick</a:t>
+              </a:r>
+              <a:endParaRPr lang="en-US" dirty="0"/>
+            </a:p>
+          </p:txBody>
+        </p:sp>
+        <p:cxnSp>
+          <p:nvCxnSpPr>
+            <p:cNvPr id="149" name="Straight Connector 148">
+              <a:extLst>
+                <a:ext uri="{FF2B5EF4-FFF2-40B4-BE49-F238E27FC236}">
+                  <a16:creationId xmlns:a16="http://schemas.microsoft.com/office/drawing/2014/main" id="{2C33D758-1C23-41A5-9456-B61787FCBB2F}"/>
+                </a:ext>
+              </a:extLst>
+            </p:cNvPr>
+            <p:cNvCxnSpPr>
+              <a:stCxn id="127" idx="4"/>
+              <a:endCxn id="147" idx="1"/>
+            </p:cNvCxnSpPr>
+            <p:nvPr/>
+          </p:nvCxnSpPr>
+          <p:spPr>
+            <a:xfrm>
+              <a:off x="7069389" y="4004216"/>
+              <a:ext cx="1587336" cy="1827768"/>
+            </a:xfrm>
+            <a:prstGeom prst="line">
+              <a:avLst/>
+            </a:prstGeom>
+            <a:ln w="31750">
+              <a:solidFill>
+                <a:schemeClr val="tx1"/>
+              </a:solidFill>
+            </a:ln>
+          </p:spPr>
+          <p:style>
+            <a:lnRef idx="2">
+              <a:schemeClr val="accent1"/>
+            </a:lnRef>
+            <a:fillRef idx="0">
+              <a:schemeClr val="accent1"/>
+            </a:fillRef>
+            <a:effectRef idx="1">
+              <a:schemeClr val="accent1"/>
+            </a:effectRef>
+            <a:fontRef idx="minor">
+              <a:schemeClr val="tx1"/>
+            </a:fontRef>
+          </p:style>
+        </p:cxnSp>
+        <p:cxnSp>
+          <p:nvCxnSpPr>
+            <p:cNvPr id="150" name="Straight Connector 149">
+              <a:extLst>
+                <a:ext uri="{FF2B5EF4-FFF2-40B4-BE49-F238E27FC236}">
+                  <a16:creationId xmlns:a16="http://schemas.microsoft.com/office/drawing/2014/main" id="{89E130D5-873A-605A-DF74-A99838AC16BA}"/>
+                </a:ext>
+              </a:extLst>
+            </p:cNvPr>
+            <p:cNvCxnSpPr>
+              <a:stCxn id="147" idx="0"/>
+              <a:endCxn id="126" idx="4"/>
+            </p:cNvCxnSpPr>
+            <p:nvPr/>
+          </p:nvCxnSpPr>
+          <p:spPr>
+            <a:xfrm flipV="1">
+              <a:off x="8974923" y="5302199"/>
+              <a:ext cx="126099" cy="397983"/>
+            </a:xfrm>
+            <a:prstGeom prst="line">
+              <a:avLst/>
+            </a:prstGeom>
+            <a:ln w="31750">
+              <a:solidFill>
+                <a:schemeClr val="tx1"/>
+              </a:solidFill>
+            </a:ln>
+          </p:spPr>
+          <p:style>
+            <a:lnRef idx="2">
+              <a:schemeClr val="accent1"/>
+            </a:lnRef>
+            <a:fillRef idx="0">
+              <a:schemeClr val="accent1"/>
+            </a:fillRef>
+            <a:effectRef idx="1">
+              <a:schemeClr val="accent1"/>
+            </a:effectRef>
+            <a:fontRef idx="minor">
+              <a:schemeClr val="tx1"/>
+            </a:fontRef>
+          </p:style>
+        </p:cxnSp>
+        <p:sp>
+          <p:nvSpPr>
+            <p:cNvPr id="151" name="TextBox 150">
+              <a:extLst>
+                <a:ext uri="{FF2B5EF4-FFF2-40B4-BE49-F238E27FC236}">
+                  <a16:creationId xmlns:a16="http://schemas.microsoft.com/office/drawing/2014/main" id="{9EA62054-7215-EA59-42B3-FDBBCB76E24F}"/>
+                </a:ext>
+              </a:extLst>
+            </p:cNvPr>
+            <p:cNvSpPr txBox="1"/>
+            <p:nvPr/>
+          </p:nvSpPr>
+          <p:spPr>
+            <a:xfrm>
+              <a:off x="10232655" y="4060447"/>
+              <a:ext cx="654908" cy="461665"/>
+            </a:xfrm>
+            <a:prstGeom prst="rect">
+              <a:avLst/>
+            </a:prstGeom>
+            <a:noFill/>
+          </p:spPr>
+          <p:txBody>
+            <a:bodyPr wrap="square" rtlCol="0">
+              <a:spAutoFit/>
+            </a:bodyPr>
+            <a:lstStyle/>
+            <a:p>
+              <a:pPr algn="ctr"/>
+              <a:r>
+                <a:rPr lang="en-US" sz="2400" dirty="0"/>
+                <a:t>32</a:t>
+              </a:r>
+            </a:p>
+          </p:txBody>
+        </p:sp>
+        <p:sp>
+          <p:nvSpPr>
+            <p:cNvPr id="152" name="TextBox 151">
+              <a:extLst>
+                <a:ext uri="{FF2B5EF4-FFF2-40B4-BE49-F238E27FC236}">
+                  <a16:creationId xmlns:a16="http://schemas.microsoft.com/office/drawing/2014/main" id="{E5624463-9495-5D64-59CE-1B5C9ABBD0E3}"/>
+                </a:ext>
+              </a:extLst>
+            </p:cNvPr>
+            <p:cNvSpPr txBox="1"/>
+            <p:nvPr/>
+          </p:nvSpPr>
+          <p:spPr>
+            <a:xfrm>
+              <a:off x="7906015" y="4004216"/>
+              <a:ext cx="654908" cy="461665"/>
+            </a:xfrm>
+            <a:prstGeom prst="rect">
+              <a:avLst/>
+            </a:prstGeom>
+            <a:noFill/>
+          </p:spPr>
+          <p:txBody>
+            <a:bodyPr wrap="square" rtlCol="0">
+              <a:spAutoFit/>
+            </a:bodyPr>
+            <a:lstStyle/>
+            <a:p>
+              <a:pPr algn="ctr"/>
+              <a:r>
+                <a:rPr lang="en-US" sz="2400" dirty="0"/>
+                <a:t>24</a:t>
+              </a:r>
+            </a:p>
+          </p:txBody>
+        </p:sp>
+        <p:sp>
+          <p:nvSpPr>
+            <p:cNvPr id="153" name="TextBox 152">
+              <a:extLst>
+                <a:ext uri="{FF2B5EF4-FFF2-40B4-BE49-F238E27FC236}">
+                  <a16:creationId xmlns:a16="http://schemas.microsoft.com/office/drawing/2014/main" id="{34D013CB-DB02-4605-84C3-37CF024F87BF}"/>
+                </a:ext>
+              </a:extLst>
+            </p:cNvPr>
+            <p:cNvSpPr txBox="1"/>
+            <p:nvPr/>
+          </p:nvSpPr>
+          <p:spPr>
+            <a:xfrm>
+              <a:off x="7284561" y="4801961"/>
+              <a:ext cx="654908" cy="461665"/>
+            </a:xfrm>
+            <a:prstGeom prst="rect">
+              <a:avLst/>
+            </a:prstGeom>
+            <a:noFill/>
+          </p:spPr>
+          <p:txBody>
+            <a:bodyPr wrap="square" rtlCol="0">
+              <a:spAutoFit/>
+            </a:bodyPr>
+            <a:lstStyle/>
+            <a:p>
+              <a:pPr algn="ctr"/>
+              <a:r>
+                <a:rPr lang="en-US" sz="2400" dirty="0"/>
+                <a:t>41</a:t>
+              </a:r>
+            </a:p>
+          </p:txBody>
+        </p:sp>
+        <p:sp>
+          <p:nvSpPr>
+            <p:cNvPr id="154" name="TextBox 153">
+              <a:extLst>
+                <a:ext uri="{FF2B5EF4-FFF2-40B4-BE49-F238E27FC236}">
+                  <a16:creationId xmlns:a16="http://schemas.microsoft.com/office/drawing/2014/main" id="{D94AEBCF-43E1-DC16-2798-C6F633CF38D6}"/>
+                </a:ext>
+              </a:extLst>
+            </p:cNvPr>
+            <p:cNvSpPr txBox="1"/>
+            <p:nvPr/>
+          </p:nvSpPr>
+          <p:spPr>
+            <a:xfrm>
+              <a:off x="8949907" y="5323799"/>
+              <a:ext cx="654908" cy="461665"/>
+            </a:xfrm>
+            <a:prstGeom prst="rect">
+              <a:avLst/>
+            </a:prstGeom>
+            <a:noFill/>
+          </p:spPr>
+          <p:txBody>
+            <a:bodyPr wrap="square" rtlCol="0">
+              <a:spAutoFit/>
+            </a:bodyPr>
+            <a:lstStyle/>
+            <a:p>
+              <a:pPr algn="ctr"/>
+              <a:r>
+                <a:rPr lang="en-US" sz="2400" dirty="0"/>
+                <a:t>5</a:t>
+              </a:r>
+            </a:p>
+          </p:txBody>
+        </p:sp>
+        <p:sp>
+          <p:nvSpPr>
+            <p:cNvPr id="157" name="TextBox 156">
+              <a:extLst>
+                <a:ext uri="{FF2B5EF4-FFF2-40B4-BE49-F238E27FC236}">
+                  <a16:creationId xmlns:a16="http://schemas.microsoft.com/office/drawing/2014/main" id="{0502A777-EFA5-D949-964E-161252600201}"/>
+                </a:ext>
+              </a:extLst>
+            </p:cNvPr>
+            <p:cNvSpPr txBox="1"/>
+            <p:nvPr/>
+          </p:nvSpPr>
+          <p:spPr>
+            <a:xfrm>
+              <a:off x="7209219" y="1507280"/>
+              <a:ext cx="654908" cy="461665"/>
+            </a:xfrm>
+            <a:prstGeom prst="rect">
+              <a:avLst/>
+            </a:prstGeom>
+            <a:noFill/>
+          </p:spPr>
+          <p:txBody>
+            <a:bodyPr wrap="square" rtlCol="0">
+              <a:spAutoFit/>
+            </a:bodyPr>
+            <a:lstStyle/>
+            <a:p>
+              <a:pPr algn="ctr"/>
+              <a:r>
+                <a:rPr lang="en-US" sz="2400" dirty="0">
+                  <a:solidFill>
+                    <a:schemeClr val="accent1">
+                      <a:lumMod val="60000"/>
+                      <a:lumOff val="40000"/>
+                    </a:schemeClr>
+                  </a:solidFill>
+                </a:rPr>
+                <a:t>35</a:t>
+              </a:r>
+            </a:p>
+          </p:txBody>
+        </p:sp>
+        <p:sp>
+          <p:nvSpPr>
+            <p:cNvPr id="158" name="TextBox 157">
+              <a:extLst>
+                <a:ext uri="{FF2B5EF4-FFF2-40B4-BE49-F238E27FC236}">
+                  <a16:creationId xmlns:a16="http://schemas.microsoft.com/office/drawing/2014/main" id="{7B05C46F-4A21-E57B-EF67-C89DE45F63EC}"/>
+                </a:ext>
+              </a:extLst>
+            </p:cNvPr>
+            <p:cNvSpPr txBox="1"/>
+            <p:nvPr/>
+          </p:nvSpPr>
+          <p:spPr>
+            <a:xfrm>
+              <a:off x="10051478" y="1250142"/>
+              <a:ext cx="654908" cy="461665"/>
+            </a:xfrm>
+            <a:prstGeom prst="rect">
+              <a:avLst/>
+            </a:prstGeom>
+            <a:noFill/>
+          </p:spPr>
+          <p:txBody>
+            <a:bodyPr wrap="square" rtlCol="0">
+              <a:spAutoFit/>
+            </a:bodyPr>
+            <a:lstStyle/>
+            <a:p>
+              <a:pPr algn="ctr"/>
+              <a:r>
+                <a:rPr lang="en-US" sz="2400" dirty="0">
+                  <a:solidFill>
+                    <a:schemeClr val="accent1">
+                      <a:lumMod val="60000"/>
+                      <a:lumOff val="40000"/>
+                    </a:schemeClr>
+                  </a:solidFill>
+                </a:rPr>
+                <a:t>27</a:t>
+              </a:r>
+            </a:p>
+          </p:txBody>
+        </p:sp>
+        <p:sp>
+          <p:nvSpPr>
+            <p:cNvPr id="159" name="TextBox 158">
+              <a:extLst>
+                <a:ext uri="{FF2B5EF4-FFF2-40B4-BE49-F238E27FC236}">
+                  <a16:creationId xmlns:a16="http://schemas.microsoft.com/office/drawing/2014/main" id="{427A000A-9BA2-4FF6-1BB1-EC4FAF0F5DCA}"/>
+                </a:ext>
+              </a:extLst>
+            </p:cNvPr>
+            <p:cNvSpPr txBox="1"/>
+            <p:nvPr/>
+          </p:nvSpPr>
+          <p:spPr>
+            <a:xfrm>
+              <a:off x="8824034" y="1068931"/>
+              <a:ext cx="654908" cy="461665"/>
+            </a:xfrm>
+            <a:prstGeom prst="rect">
+              <a:avLst/>
+            </a:prstGeom>
+            <a:noFill/>
+          </p:spPr>
+          <p:txBody>
+            <a:bodyPr wrap="square" rtlCol="0">
+              <a:spAutoFit/>
+            </a:bodyPr>
+            <a:lstStyle/>
+            <a:p>
+              <a:pPr algn="ctr"/>
+              <a:r>
+                <a:rPr lang="en-US" sz="2400" dirty="0">
+                  <a:solidFill>
+                    <a:schemeClr val="accent1">
+                      <a:lumMod val="60000"/>
+                      <a:lumOff val="40000"/>
+                    </a:schemeClr>
+                  </a:solidFill>
+                </a:rPr>
+                <a:t>5</a:t>
+              </a:r>
+            </a:p>
+          </p:txBody>
+        </p:sp>
+      </p:grpSp>
+    </p:spTree>
+    <p:extLst>
+      <p:ext uri="{BB962C8B-B14F-4D97-AF65-F5344CB8AC3E}">
+        <p14:creationId xmlns:p14="http://schemas.microsoft.com/office/powerpoint/2010/main" val="818822214"/>
+      </p:ext>
+    </p:extLst>
+  </p:cSld>
+  <p:clrMapOvr>
+    <a:masterClrMapping/>
+  </p:clrMapOvr>
+</p:sld>
+</file>
+
 <file path=ppt/theme/theme1.xml><?xml version="1.0" encoding="utf-8"?>
 <a:theme xmlns:a="http://schemas.openxmlformats.org/drawingml/2006/main" name="Office Theme">
   <a:themeElements>

</xml_diff>

<commit_message>
HP updated week 8
</commit_message>
<xml_diff>
--- a/media/week_8/diagrams_dicts_tuples.pptx
+++ b/media/week_8/diagrams_dicts_tuples.pptx
@@ -8,6 +8,8 @@
     <p:sldId id="256" r:id="rId2"/>
     <p:sldId id="257" r:id="rId3"/>
     <p:sldId id="258" r:id="rId4"/>
+    <p:sldId id="259" r:id="rId5"/>
+    <p:sldId id="260" r:id="rId6"/>
   </p:sldIdLst>
   <p:sldSz cx="12192000" cy="6858000"/>
   <p:notesSz cx="6858000" cy="9144000"/>
@@ -106,7 +108,20 @@
       </a:defRPr>
     </a:lvl9pPr>
   </p:defaultTextStyle>
+  <p:extLst>
+    <p:ext uri="{EFAFB233-063F-42B5-8137-9DF3F51BA10A}">
+      <p15:sldGuideLst xmlns:p15="http://schemas.microsoft.com/office/powerpoint/2012/main"/>
+    </p:ext>
+  </p:extLst>
 </p:presentation>
+</file>
+
+<file path=ppt/revisionInfo.xml><?xml version="1.0" encoding="utf-8"?>
+<p1510:revInfo xmlns:a="http://schemas.openxmlformats.org/drawingml/2006/main" xmlns:r="http://schemas.openxmlformats.org/officeDocument/2006/relationships" xmlns:p1510="http://schemas.microsoft.com/office/powerpoint/2015/10/main">
+  <p1510:revLst>
+    <p1510:client id="{3DC55E8D-F384-8748-BD76-03BB5D3EA7AB}" v="235" dt="2026-10-28T00:48:50.562"/>
+  </p1510:revLst>
+</p1510:revInfo>
 </file>
 
 <file path=ppt/changesInfos/changesInfo1.xml><?xml version="1.0" encoding="utf-8"?>
@@ -1297,6 +1312,253 @@
             <pc:docMk/>
             <pc:sldMk cId="818822214" sldId="258"/>
             <ac:cxnSpMk id="131" creationId="{698A2297-D560-157C-5E72-B14519BA8839}"/>
+          </ac:cxnSpMkLst>
+        </pc:cxnChg>
+      </pc:sldChg>
+    </pc:docChg>
+  </pc:docChgLst>
+  <pc:docChgLst>
+    <pc:chgData name="Hemma Philamore" userId="db50e2f3-17b2-4cc0-b719-fb6254d3e9df" providerId="ADAL" clId="{B5D85944-D90A-5912-90C6-4C26E424D3D6}"/>
+    <pc:docChg chg="undo custSel addSld modSld">
+      <pc:chgData name="Hemma Philamore" userId="db50e2f3-17b2-4cc0-b719-fb6254d3e9df" providerId="ADAL" clId="{B5D85944-D90A-5912-90C6-4C26E424D3D6}" dt="2026-10-28T00:48:50.562" v="234" actId="164"/>
+      <pc:docMkLst>
+        <pc:docMk/>
+      </pc:docMkLst>
+      <pc:sldChg chg="addSp modSp new mod">
+        <pc:chgData name="Hemma Philamore" userId="db50e2f3-17b2-4cc0-b719-fb6254d3e9df" providerId="ADAL" clId="{B5D85944-D90A-5912-90C6-4C26E424D3D6}" dt="2026-10-28T00:34:51.193" v="12" actId="1076"/>
+        <pc:sldMkLst>
+          <pc:docMk/>
+          <pc:sldMk cId="110236372" sldId="259"/>
+        </pc:sldMkLst>
+        <pc:picChg chg="add mod">
+          <ac:chgData name="Hemma Philamore" userId="db50e2f3-17b2-4cc0-b719-fb6254d3e9df" providerId="ADAL" clId="{B5D85944-D90A-5912-90C6-4C26E424D3D6}" dt="2026-10-28T00:33:53.392" v="2" actId="1076"/>
+          <ac:picMkLst>
+            <pc:docMk/>
+            <pc:sldMk cId="110236372" sldId="259"/>
+            <ac:picMk id="2" creationId="{5DF3E9AD-B7C5-4363-4252-6DBB0BCE50BA}"/>
+          </ac:picMkLst>
+        </pc:picChg>
+        <pc:picChg chg="add mod modCrop">
+          <ac:chgData name="Hemma Philamore" userId="db50e2f3-17b2-4cc0-b719-fb6254d3e9df" providerId="ADAL" clId="{B5D85944-D90A-5912-90C6-4C26E424D3D6}" dt="2026-10-28T00:34:32.384" v="7" actId="1076"/>
+          <ac:picMkLst>
+            <pc:docMk/>
+            <pc:sldMk cId="110236372" sldId="259"/>
+            <ac:picMk id="3" creationId="{D1F1AEB5-8EDA-45BA-5272-84BEF8C3DAD9}"/>
+          </ac:picMkLst>
+        </pc:picChg>
+        <pc:picChg chg="add mod modCrop">
+          <ac:chgData name="Hemma Philamore" userId="db50e2f3-17b2-4cc0-b719-fb6254d3e9df" providerId="ADAL" clId="{B5D85944-D90A-5912-90C6-4C26E424D3D6}" dt="2026-10-28T00:34:51.193" v="12" actId="1076"/>
+          <ac:picMkLst>
+            <pc:docMk/>
+            <pc:sldMk cId="110236372" sldId="259"/>
+            <ac:picMk id="4" creationId="{9E083881-4318-55B1-31BA-0820174BB903}"/>
+          </ac:picMkLst>
+        </pc:picChg>
+      </pc:sldChg>
+      <pc:sldChg chg="addSp delSp modSp new mod">
+        <pc:chgData name="Hemma Philamore" userId="db50e2f3-17b2-4cc0-b719-fb6254d3e9df" providerId="ADAL" clId="{B5D85944-D90A-5912-90C6-4C26E424D3D6}" dt="2026-10-28T00:48:50.562" v="234" actId="164"/>
+        <pc:sldMkLst>
+          <pc:docMk/>
+          <pc:sldMk cId="1492292829" sldId="260"/>
+        </pc:sldMkLst>
+        <pc:spChg chg="add del mod">
+          <ac:chgData name="Hemma Philamore" userId="db50e2f3-17b2-4cc0-b719-fb6254d3e9df" providerId="ADAL" clId="{B5D85944-D90A-5912-90C6-4C26E424D3D6}" dt="2026-10-28T00:45:02.969" v="108" actId="478"/>
+          <ac:spMkLst>
+            <pc:docMk/>
+            <pc:sldMk cId="1492292829" sldId="260"/>
+            <ac:spMk id="3" creationId="{F2953987-6EB9-A5D4-2FCA-03F1E3A9C443}"/>
+          </ac:spMkLst>
+        </pc:spChg>
+        <pc:spChg chg="add mod">
+          <ac:chgData name="Hemma Philamore" userId="db50e2f3-17b2-4cc0-b719-fb6254d3e9df" providerId="ADAL" clId="{B5D85944-D90A-5912-90C6-4C26E424D3D6}" dt="2026-10-28T00:48:50.562" v="234" actId="164"/>
+          <ac:spMkLst>
+            <pc:docMk/>
+            <pc:sldMk cId="1492292829" sldId="260"/>
+            <ac:spMk id="4" creationId="{B168EDA8-3898-FB45-B24C-8D3DB86F56B6}"/>
+          </ac:spMkLst>
+        </pc:spChg>
+        <pc:spChg chg="add del mod">
+          <ac:chgData name="Hemma Philamore" userId="db50e2f3-17b2-4cc0-b719-fb6254d3e9df" providerId="ADAL" clId="{B5D85944-D90A-5912-90C6-4C26E424D3D6}" dt="2026-10-28T00:45:27.177" v="115" actId="478"/>
+          <ac:spMkLst>
+            <pc:docMk/>
+            <pc:sldMk cId="1492292829" sldId="260"/>
+            <ac:spMk id="5" creationId="{574BF8CF-129A-AC08-1B1A-AB6BB7F5FA5C}"/>
+          </ac:spMkLst>
+        </pc:spChg>
+        <pc:spChg chg="add mod">
+          <ac:chgData name="Hemma Philamore" userId="db50e2f3-17b2-4cc0-b719-fb6254d3e9df" providerId="ADAL" clId="{B5D85944-D90A-5912-90C6-4C26E424D3D6}" dt="2026-10-28T00:48:50.562" v="234" actId="164"/>
+          <ac:spMkLst>
+            <pc:docMk/>
+            <pc:sldMk cId="1492292829" sldId="260"/>
+            <ac:spMk id="6" creationId="{DA5D2A77-6CFB-F254-7FDF-26F5955669F9}"/>
+          </ac:spMkLst>
+        </pc:spChg>
+        <pc:spChg chg="add del mod">
+          <ac:chgData name="Hemma Philamore" userId="db50e2f3-17b2-4cc0-b719-fb6254d3e9df" providerId="ADAL" clId="{B5D85944-D90A-5912-90C6-4C26E424D3D6}" dt="2026-10-28T00:45:32.659" v="117" actId="478"/>
+          <ac:spMkLst>
+            <pc:docMk/>
+            <pc:sldMk cId="1492292829" sldId="260"/>
+            <ac:spMk id="7" creationId="{935B3AFE-4AC6-70E7-4A5F-1DE8086A4173}"/>
+          </ac:spMkLst>
+        </pc:spChg>
+        <pc:spChg chg="add mod">
+          <ac:chgData name="Hemma Philamore" userId="db50e2f3-17b2-4cc0-b719-fb6254d3e9df" providerId="ADAL" clId="{B5D85944-D90A-5912-90C6-4C26E424D3D6}" dt="2026-10-28T00:48:50.562" v="234" actId="164"/>
+          <ac:spMkLst>
+            <pc:docMk/>
+            <pc:sldMk cId="1492292829" sldId="260"/>
+            <ac:spMk id="8" creationId="{615A982A-7A8C-1816-E98F-9E3B30B56E4B}"/>
+          </ac:spMkLst>
+        </pc:spChg>
+        <pc:spChg chg="add del mod">
+          <ac:chgData name="Hemma Philamore" userId="db50e2f3-17b2-4cc0-b719-fb6254d3e9df" providerId="ADAL" clId="{B5D85944-D90A-5912-90C6-4C26E424D3D6}" dt="2026-10-28T00:46:05.565" v="129" actId="478"/>
+          <ac:spMkLst>
+            <pc:docMk/>
+            <pc:sldMk cId="1492292829" sldId="260"/>
+            <ac:spMk id="9" creationId="{A1A0615F-00C2-6BC5-9B8D-BF935762A5ED}"/>
+          </ac:spMkLst>
+        </pc:spChg>
+        <pc:spChg chg="add mod">
+          <ac:chgData name="Hemma Philamore" userId="db50e2f3-17b2-4cc0-b719-fb6254d3e9df" providerId="ADAL" clId="{B5D85944-D90A-5912-90C6-4C26E424D3D6}" dt="2026-10-28T00:48:50.562" v="234" actId="164"/>
+          <ac:spMkLst>
+            <pc:docMk/>
+            <pc:sldMk cId="1492292829" sldId="260"/>
+            <ac:spMk id="10" creationId="{60EFC832-8D13-7839-FC6F-2BB66549F911}"/>
+          </ac:spMkLst>
+        </pc:spChg>
+        <pc:spChg chg="add del mod">
+          <ac:chgData name="Hemma Philamore" userId="db50e2f3-17b2-4cc0-b719-fb6254d3e9df" providerId="ADAL" clId="{B5D85944-D90A-5912-90C6-4C26E424D3D6}" dt="2026-10-28T00:46:13.081" v="131" actId="478"/>
+          <ac:spMkLst>
+            <pc:docMk/>
+            <pc:sldMk cId="1492292829" sldId="260"/>
+            <ac:spMk id="11" creationId="{42772F8D-F9A3-5B7D-A1BA-F2A088869BD1}"/>
+          </ac:spMkLst>
+        </pc:spChg>
+        <pc:spChg chg="add mod">
+          <ac:chgData name="Hemma Philamore" userId="db50e2f3-17b2-4cc0-b719-fb6254d3e9df" providerId="ADAL" clId="{B5D85944-D90A-5912-90C6-4C26E424D3D6}" dt="2026-10-28T00:48:50.562" v="234" actId="164"/>
+          <ac:spMkLst>
+            <pc:docMk/>
+            <pc:sldMk cId="1492292829" sldId="260"/>
+            <ac:spMk id="12" creationId="{EEE0CA48-27ED-0938-0EF4-21B9A5F446CC}"/>
+          </ac:spMkLst>
+        </pc:spChg>
+        <pc:spChg chg="add del mod">
+          <ac:chgData name="Hemma Philamore" userId="db50e2f3-17b2-4cc0-b719-fb6254d3e9df" providerId="ADAL" clId="{B5D85944-D90A-5912-90C6-4C26E424D3D6}" dt="2026-10-28T00:46:14.127" v="132" actId="478"/>
+          <ac:spMkLst>
+            <pc:docMk/>
+            <pc:sldMk cId="1492292829" sldId="260"/>
+            <ac:spMk id="13" creationId="{1DD1FAB3-E705-53D9-32F8-B91752943710}"/>
+          </ac:spMkLst>
+        </pc:spChg>
+        <pc:spChg chg="add mod">
+          <ac:chgData name="Hemma Philamore" userId="db50e2f3-17b2-4cc0-b719-fb6254d3e9df" providerId="ADAL" clId="{B5D85944-D90A-5912-90C6-4C26E424D3D6}" dt="2026-10-28T00:48:50.562" v="234" actId="164"/>
+          <ac:spMkLst>
+            <pc:docMk/>
+            <pc:sldMk cId="1492292829" sldId="260"/>
+            <ac:spMk id="14" creationId="{763C79F9-CCD8-96B0-CFEB-FB4D858742FB}"/>
+          </ac:spMkLst>
+        </pc:spChg>
+        <pc:spChg chg="add del mod">
+          <ac:chgData name="Hemma Philamore" userId="db50e2f3-17b2-4cc0-b719-fb6254d3e9df" providerId="ADAL" clId="{B5D85944-D90A-5912-90C6-4C26E424D3D6}" dt="2026-10-28T00:47:41.443" v="205" actId="478"/>
+          <ac:spMkLst>
+            <pc:docMk/>
+            <pc:sldMk cId="1492292829" sldId="260"/>
+            <ac:spMk id="15" creationId="{C694F3A6-FF4B-FE9B-9026-DD8E5DA15C65}"/>
+          </ac:spMkLst>
+        </pc:spChg>
+        <pc:spChg chg="add mod">
+          <ac:chgData name="Hemma Philamore" userId="db50e2f3-17b2-4cc0-b719-fb6254d3e9df" providerId="ADAL" clId="{B5D85944-D90A-5912-90C6-4C26E424D3D6}" dt="2026-10-28T00:48:50.562" v="234" actId="164"/>
+          <ac:spMkLst>
+            <pc:docMk/>
+            <pc:sldMk cId="1492292829" sldId="260"/>
+            <ac:spMk id="16" creationId="{85F6C4D9-B933-346B-07D8-97BFAA1EAE37}"/>
+          </ac:spMkLst>
+        </pc:spChg>
+        <pc:spChg chg="add del mod">
+          <ac:chgData name="Hemma Philamore" userId="db50e2f3-17b2-4cc0-b719-fb6254d3e9df" providerId="ADAL" clId="{B5D85944-D90A-5912-90C6-4C26E424D3D6}" dt="2026-10-28T00:47:43.224" v="206" actId="478"/>
+          <ac:spMkLst>
+            <pc:docMk/>
+            <pc:sldMk cId="1492292829" sldId="260"/>
+            <ac:spMk id="17" creationId="{4ABE832C-3F4A-8908-E934-DD993134F0A9}"/>
+          </ac:spMkLst>
+        </pc:spChg>
+        <pc:spChg chg="add mod">
+          <ac:chgData name="Hemma Philamore" userId="db50e2f3-17b2-4cc0-b719-fb6254d3e9df" providerId="ADAL" clId="{B5D85944-D90A-5912-90C6-4C26E424D3D6}" dt="2026-10-28T00:48:50.562" v="234" actId="164"/>
+          <ac:spMkLst>
+            <pc:docMk/>
+            <pc:sldMk cId="1492292829" sldId="260"/>
+            <ac:spMk id="18" creationId="{77331A54-6494-FB96-A505-A7379F15EAE1}"/>
+          </ac:spMkLst>
+        </pc:spChg>
+        <pc:grpChg chg="add mod">
+          <ac:chgData name="Hemma Philamore" userId="db50e2f3-17b2-4cc0-b719-fb6254d3e9df" providerId="ADAL" clId="{B5D85944-D90A-5912-90C6-4C26E424D3D6}" dt="2026-10-28T00:48:50.562" v="234" actId="164"/>
+          <ac:grpSpMkLst>
+            <pc:docMk/>
+            <pc:sldMk cId="1492292829" sldId="260"/>
+            <ac:grpSpMk id="39" creationId="{F3CCA625-13C1-13D1-081D-D8C10CA4A315}"/>
+          </ac:grpSpMkLst>
+        </pc:grpChg>
+        <pc:picChg chg="add mod">
+          <ac:chgData name="Hemma Philamore" userId="db50e2f3-17b2-4cc0-b719-fb6254d3e9df" providerId="ADAL" clId="{B5D85944-D90A-5912-90C6-4C26E424D3D6}" dt="2026-10-28T00:48:45.255" v="233" actId="1076"/>
+          <ac:picMkLst>
+            <pc:docMk/>
+            <pc:sldMk cId="1492292829" sldId="260"/>
+            <ac:picMk id="2" creationId="{B55D73CB-2E9D-0856-4F55-EAB9F1CA5BC5}"/>
+          </ac:picMkLst>
+        </pc:picChg>
+        <pc:cxnChg chg="add">
+          <ac:chgData name="Hemma Philamore" userId="db50e2f3-17b2-4cc0-b719-fb6254d3e9df" providerId="ADAL" clId="{B5D85944-D90A-5912-90C6-4C26E424D3D6}" dt="2026-10-28T00:47:51.660" v="207" actId="11529"/>
+          <ac:cxnSpMkLst>
+            <pc:docMk/>
+            <pc:sldMk cId="1492292829" sldId="260"/>
+            <ac:cxnSpMk id="20" creationId="{066601BF-16D2-960B-D5DB-3D109FACF512}"/>
+          </ac:cxnSpMkLst>
+        </pc:cxnChg>
+        <pc:cxnChg chg="add mod">
+          <ac:chgData name="Hemma Philamore" userId="db50e2f3-17b2-4cc0-b719-fb6254d3e9df" providerId="ADAL" clId="{B5D85944-D90A-5912-90C6-4C26E424D3D6}" dt="2026-10-28T00:48:50.562" v="234" actId="164"/>
+          <ac:cxnSpMkLst>
+            <pc:docMk/>
+            <pc:sldMk cId="1492292829" sldId="260"/>
+            <ac:cxnSpMk id="21" creationId="{1EBCE35E-89F1-9E8C-3F73-ACD8AC4E1150}"/>
+          </ac:cxnSpMkLst>
+        </pc:cxnChg>
+        <pc:cxnChg chg="add mod">
+          <ac:chgData name="Hemma Philamore" userId="db50e2f3-17b2-4cc0-b719-fb6254d3e9df" providerId="ADAL" clId="{B5D85944-D90A-5912-90C6-4C26E424D3D6}" dt="2026-10-28T00:48:07.820" v="215" actId="14100"/>
+          <ac:cxnSpMkLst>
+            <pc:docMk/>
+            <pc:sldMk cId="1492292829" sldId="260"/>
+            <ac:cxnSpMk id="24" creationId="{0C9B2F68-4B7F-D4F0-9993-1D421F9CCE53}"/>
+          </ac:cxnSpMkLst>
+        </pc:cxnChg>
+        <pc:cxnChg chg="add mod">
+          <ac:chgData name="Hemma Philamore" userId="db50e2f3-17b2-4cc0-b719-fb6254d3e9df" providerId="ADAL" clId="{B5D85944-D90A-5912-90C6-4C26E424D3D6}" dt="2026-10-28T00:48:15.655" v="219" actId="14100"/>
+          <ac:cxnSpMkLst>
+            <pc:docMk/>
+            <pc:sldMk cId="1492292829" sldId="260"/>
+            <ac:cxnSpMk id="27" creationId="{30AB3E62-E587-47BC-B65C-6562AC60E87E}"/>
+          </ac:cxnSpMkLst>
+        </pc:cxnChg>
+        <pc:cxnChg chg="add mod">
+          <ac:chgData name="Hemma Philamore" userId="db50e2f3-17b2-4cc0-b719-fb6254d3e9df" providerId="ADAL" clId="{B5D85944-D90A-5912-90C6-4C26E424D3D6}" dt="2026-10-28T00:48:23.791" v="223" actId="14100"/>
+          <ac:cxnSpMkLst>
+            <pc:docMk/>
+            <pc:sldMk cId="1492292829" sldId="260"/>
+            <ac:cxnSpMk id="30" creationId="{E52AE403-A3A6-7F2C-53B9-CC81B6BB7E03}"/>
+          </ac:cxnSpMkLst>
+        </pc:cxnChg>
+        <pc:cxnChg chg="add mod">
+          <ac:chgData name="Hemma Philamore" userId="db50e2f3-17b2-4cc0-b719-fb6254d3e9df" providerId="ADAL" clId="{B5D85944-D90A-5912-90C6-4C26E424D3D6}" dt="2026-10-28T00:48:31.163" v="227" actId="14100"/>
+          <ac:cxnSpMkLst>
+            <pc:docMk/>
+            <pc:sldMk cId="1492292829" sldId="260"/>
+            <ac:cxnSpMk id="33" creationId="{32549293-27F8-A575-E242-4CDE74C6585D}"/>
+          </ac:cxnSpMkLst>
+        </pc:cxnChg>
+        <pc:cxnChg chg="add mod">
+          <ac:chgData name="Hemma Philamore" userId="db50e2f3-17b2-4cc0-b719-fb6254d3e9df" providerId="ADAL" clId="{B5D85944-D90A-5912-90C6-4C26E424D3D6}" dt="2026-10-28T00:48:39.081" v="231" actId="14100"/>
+          <ac:cxnSpMkLst>
+            <pc:docMk/>
+            <pc:sldMk cId="1492292829" sldId="260"/>
+            <ac:cxnSpMk id="36" creationId="{CD0B4E94-8AAD-65EE-8B9F-44708BE1A474}"/>
           </ac:cxnSpMkLst>
         </pc:cxnChg>
       </pc:sldChg>
@@ -1454,7 +1716,7 @@
           <a:p>
             <a:fld id="{2D85AF9A-95AE-7742-927B-08340FD5233B}" type="datetimeFigureOut">
               <a:rPr lang="en-US" smtClean="0"/>
-              <a:t>10/23/26</a:t>
+              <a:t>10/28/26</a:t>
             </a:fld>
             <a:endParaRPr lang="en-US"/>
           </a:p>
@@ -1654,7 +1916,7 @@
           <a:p>
             <a:fld id="{2D85AF9A-95AE-7742-927B-08340FD5233B}" type="datetimeFigureOut">
               <a:rPr lang="en-US" smtClean="0"/>
-              <a:t>10/23/26</a:t>
+              <a:t>10/28/26</a:t>
             </a:fld>
             <a:endParaRPr lang="en-US"/>
           </a:p>
@@ -1864,7 +2126,7 @@
           <a:p>
             <a:fld id="{2D85AF9A-95AE-7742-927B-08340FD5233B}" type="datetimeFigureOut">
               <a:rPr lang="en-US" smtClean="0"/>
-              <a:t>10/23/26</a:t>
+              <a:t>10/28/26</a:t>
             </a:fld>
             <a:endParaRPr lang="en-US"/>
           </a:p>
@@ -2064,7 +2326,7 @@
           <a:p>
             <a:fld id="{2D85AF9A-95AE-7742-927B-08340FD5233B}" type="datetimeFigureOut">
               <a:rPr lang="en-US" smtClean="0"/>
-              <a:t>10/23/26</a:t>
+              <a:t>10/28/26</a:t>
             </a:fld>
             <a:endParaRPr lang="en-US"/>
           </a:p>
@@ -2340,7 +2602,7 @@
           <a:p>
             <a:fld id="{2D85AF9A-95AE-7742-927B-08340FD5233B}" type="datetimeFigureOut">
               <a:rPr lang="en-US" smtClean="0"/>
-              <a:t>10/23/26</a:t>
+              <a:t>10/28/26</a:t>
             </a:fld>
             <a:endParaRPr lang="en-US"/>
           </a:p>
@@ -2608,7 +2870,7 @@
           <a:p>
             <a:fld id="{2D85AF9A-95AE-7742-927B-08340FD5233B}" type="datetimeFigureOut">
               <a:rPr lang="en-US" smtClean="0"/>
-              <a:t>10/23/26</a:t>
+              <a:t>10/28/26</a:t>
             </a:fld>
             <a:endParaRPr lang="en-US"/>
           </a:p>
@@ -3023,7 +3285,7 @@
           <a:p>
             <a:fld id="{2D85AF9A-95AE-7742-927B-08340FD5233B}" type="datetimeFigureOut">
               <a:rPr lang="en-US" smtClean="0"/>
-              <a:t>10/23/26</a:t>
+              <a:t>10/28/26</a:t>
             </a:fld>
             <a:endParaRPr lang="en-US"/>
           </a:p>
@@ -3165,7 +3427,7 @@
           <a:p>
             <a:fld id="{2D85AF9A-95AE-7742-927B-08340FD5233B}" type="datetimeFigureOut">
               <a:rPr lang="en-US" smtClean="0"/>
-              <a:t>10/23/26</a:t>
+              <a:t>10/28/26</a:t>
             </a:fld>
             <a:endParaRPr lang="en-US"/>
           </a:p>
@@ -3278,7 +3540,7 @@
           <a:p>
             <a:fld id="{2D85AF9A-95AE-7742-927B-08340FD5233B}" type="datetimeFigureOut">
               <a:rPr lang="en-US" smtClean="0"/>
-              <a:t>10/23/26</a:t>
+              <a:t>10/28/26</a:t>
             </a:fld>
             <a:endParaRPr lang="en-US"/>
           </a:p>
@@ -3591,7 +3853,7 @@
           <a:p>
             <a:fld id="{2D85AF9A-95AE-7742-927B-08340FD5233B}" type="datetimeFigureOut">
               <a:rPr lang="en-US" smtClean="0"/>
-              <a:t>10/23/26</a:t>
+              <a:t>10/28/26</a:t>
             </a:fld>
             <a:endParaRPr lang="en-US"/>
           </a:p>
@@ -3880,7 +4142,7 @@
           <a:p>
             <a:fld id="{2D85AF9A-95AE-7742-927B-08340FD5233B}" type="datetimeFigureOut">
               <a:rPr lang="en-US" smtClean="0"/>
-              <a:t>10/23/26</a:t>
+              <a:t>10/28/26</a:t>
             </a:fld>
             <a:endParaRPr lang="en-US"/>
           </a:p>
@@ -4123,7 +4385,7 @@
           <a:p>
             <a:fld id="{2D85AF9A-95AE-7742-927B-08340FD5233B}" type="datetimeFigureOut">
               <a:rPr lang="en-US" smtClean="0"/>
-              <a:t>10/23/26</a:t>
+              <a:t>10/28/26</a:t>
             </a:fld>
             <a:endParaRPr lang="en-US"/>
           </a:p>
@@ -9765,6 +10027,818 @@
 </p:sld>
 </file>
 
+<file path=ppt/slides/slide4.xml><?xml version="1.0" encoding="utf-8"?>
+<p:sld xmlns:a="http://schemas.openxmlformats.org/drawingml/2006/main" xmlns:r="http://schemas.openxmlformats.org/officeDocument/2006/relationships" xmlns:p="http://schemas.openxmlformats.org/presentationml/2006/main">
+  <p:cSld>
+    <p:spTree>
+      <p:nvGrpSpPr>
+        <p:cNvPr id="1" name=""/>
+        <p:cNvGrpSpPr/>
+        <p:nvPr/>
+      </p:nvGrpSpPr>
+      <p:grpSpPr>
+        <a:xfrm>
+          <a:off x="0" y="0"/>
+          <a:ext cx="0" cy="0"/>
+          <a:chOff x="0" y="0"/>
+          <a:chExt cx="0" cy="0"/>
+        </a:xfrm>
+      </p:grpSpPr>
+      <p:pic>
+        <p:nvPicPr>
+          <p:cNvPr id="2" name="Picture 1">
+            <a:extLst>
+              <a:ext uri="{FF2B5EF4-FFF2-40B4-BE49-F238E27FC236}">
+                <a16:creationId xmlns:a16="http://schemas.microsoft.com/office/drawing/2014/main" id="{5DF3E9AD-B7C5-4363-4252-6DBB0BCE50BA}"/>
+              </a:ext>
+            </a:extLst>
+          </p:cNvPr>
+          <p:cNvPicPr>
+            <a:picLocks noChangeAspect="1"/>
+          </p:cNvPicPr>
+          <p:nvPr/>
+        </p:nvPicPr>
+        <p:blipFill>
+          <a:blip r:embed="rId2"/>
+          <a:stretch>
+            <a:fillRect/>
+          </a:stretch>
+        </p:blipFill>
+        <p:spPr>
+          <a:xfrm>
+            <a:off x="2209800" y="253515"/>
+            <a:ext cx="7772400" cy="2665659"/>
+          </a:xfrm>
+          <a:prstGeom prst="rect">
+            <a:avLst/>
+          </a:prstGeom>
+        </p:spPr>
+      </p:pic>
+      <p:pic>
+        <p:nvPicPr>
+          <p:cNvPr id="3" name="Picture 2">
+            <a:extLst>
+              <a:ext uri="{FF2B5EF4-FFF2-40B4-BE49-F238E27FC236}">
+                <a16:creationId xmlns:a16="http://schemas.microsoft.com/office/drawing/2014/main" id="{D1F1AEB5-8EDA-45BA-5272-84BEF8C3DAD9}"/>
+              </a:ext>
+            </a:extLst>
+          </p:cNvPr>
+          <p:cNvPicPr>
+            <a:picLocks noChangeAspect="1"/>
+          </p:cNvPicPr>
+          <p:nvPr/>
+        </p:nvPicPr>
+        <p:blipFill>
+          <a:blip r:embed="rId2"/>
+          <a:srcRect l="7576" t="28326" r="58378" b="17621"/>
+          <a:stretch>
+            <a:fillRect/>
+          </a:stretch>
+        </p:blipFill>
+        <p:spPr>
+          <a:xfrm>
+            <a:off x="1080655" y="4087091"/>
+            <a:ext cx="2646218" cy="1440872"/>
+          </a:xfrm>
+          <a:prstGeom prst="rect">
+            <a:avLst/>
+          </a:prstGeom>
+        </p:spPr>
+      </p:pic>
+      <p:pic>
+        <p:nvPicPr>
+          <p:cNvPr id="4" name="Picture 3">
+            <a:extLst>
+              <a:ext uri="{FF2B5EF4-FFF2-40B4-BE49-F238E27FC236}">
+                <a16:creationId xmlns:a16="http://schemas.microsoft.com/office/drawing/2014/main" id="{9E083881-4318-55B1-31BA-0820174BB903}"/>
+              </a:ext>
+            </a:extLst>
+          </p:cNvPr>
+          <p:cNvPicPr>
+            <a:picLocks noChangeAspect="1"/>
+          </p:cNvPicPr>
+          <p:nvPr/>
+        </p:nvPicPr>
+        <p:blipFill>
+          <a:blip r:embed="rId2"/>
+          <a:srcRect l="50000" t="28846" r="3119" b="51404"/>
+          <a:stretch>
+            <a:fillRect/>
+          </a:stretch>
+        </p:blipFill>
+        <p:spPr>
+          <a:xfrm>
+            <a:off x="4274127" y="4530436"/>
+            <a:ext cx="3643745" cy="526474"/>
+          </a:xfrm>
+          <a:prstGeom prst="rect">
+            <a:avLst/>
+          </a:prstGeom>
+        </p:spPr>
+      </p:pic>
+    </p:spTree>
+    <p:extLst>
+      <p:ext uri="{BB962C8B-B14F-4D97-AF65-F5344CB8AC3E}">
+        <p14:creationId xmlns:p14="http://schemas.microsoft.com/office/powerpoint/2010/main" val="110236372"/>
+      </p:ext>
+    </p:extLst>
+  </p:cSld>
+  <p:clrMapOvr>
+    <a:masterClrMapping/>
+  </p:clrMapOvr>
+</p:sld>
+</file>
+
+<file path=ppt/slides/slide5.xml><?xml version="1.0" encoding="utf-8"?>
+<p:sld xmlns:a="http://schemas.openxmlformats.org/drawingml/2006/main" xmlns:r="http://schemas.openxmlformats.org/officeDocument/2006/relationships" xmlns:p="http://schemas.openxmlformats.org/presentationml/2006/main">
+  <p:cSld>
+    <p:spTree>
+      <p:nvGrpSpPr>
+        <p:cNvPr id="1" name=""/>
+        <p:cNvGrpSpPr/>
+        <p:nvPr/>
+      </p:nvGrpSpPr>
+      <p:grpSpPr>
+        <a:xfrm>
+          <a:off x="0" y="0"/>
+          <a:ext cx="0" cy="0"/>
+          <a:chOff x="0" y="0"/>
+          <a:chExt cx="0" cy="0"/>
+        </a:xfrm>
+      </p:grpSpPr>
+      <p:pic>
+        <p:nvPicPr>
+          <p:cNvPr id="2" name="Picture 1">
+            <a:extLst>
+              <a:ext uri="{FF2B5EF4-FFF2-40B4-BE49-F238E27FC236}">
+                <a16:creationId xmlns:a16="http://schemas.microsoft.com/office/drawing/2014/main" id="{B55D73CB-2E9D-0856-4F55-EAB9F1CA5BC5}"/>
+              </a:ext>
+            </a:extLst>
+          </p:cNvPr>
+          <p:cNvPicPr>
+            <a:picLocks noChangeAspect="1"/>
+          </p:cNvPicPr>
+          <p:nvPr/>
+        </p:nvPicPr>
+        <p:blipFill>
+          <a:blip r:embed="rId2"/>
+          <a:stretch>
+            <a:fillRect/>
+          </a:stretch>
+        </p:blipFill>
+        <p:spPr>
+          <a:xfrm>
+            <a:off x="271624" y="576678"/>
+            <a:ext cx="2540000" cy="2209800"/>
+          </a:xfrm>
+          <a:prstGeom prst="rect">
+            <a:avLst/>
+          </a:prstGeom>
+        </p:spPr>
+      </p:pic>
+      <p:grpSp>
+        <p:nvGrpSpPr>
+          <p:cNvPr id="39" name="Group 38">
+            <a:extLst>
+              <a:ext uri="{FF2B5EF4-FFF2-40B4-BE49-F238E27FC236}">
+                <a16:creationId xmlns:a16="http://schemas.microsoft.com/office/drawing/2014/main" id="{F3CCA625-13C1-13D1-081D-D8C10CA4A315}"/>
+              </a:ext>
+            </a:extLst>
+          </p:cNvPr>
+          <p:cNvGrpSpPr/>
+          <p:nvPr/>
+        </p:nvGrpSpPr>
+        <p:grpSpPr>
+          <a:xfrm>
+            <a:off x="3211747" y="953852"/>
+            <a:ext cx="6049030" cy="1731724"/>
+            <a:chOff x="3211747" y="953852"/>
+            <a:chExt cx="6049030" cy="1731724"/>
+          </a:xfrm>
+        </p:grpSpPr>
+        <p:sp>
+          <p:nvSpPr>
+            <p:cNvPr id="4" name="TextBox 3">
+              <a:extLst>
+                <a:ext uri="{FF2B5EF4-FFF2-40B4-BE49-F238E27FC236}">
+                  <a16:creationId xmlns:a16="http://schemas.microsoft.com/office/drawing/2014/main" id="{B168EDA8-3898-FB45-B24C-8D3DB86F56B6}"/>
+                </a:ext>
+              </a:extLst>
+            </p:cNvPr>
+            <p:cNvSpPr txBox="1"/>
+            <p:nvPr/>
+          </p:nvSpPr>
+          <p:spPr>
+            <a:xfrm>
+              <a:off x="5875640" y="953852"/>
+              <a:ext cx="796364" cy="369332"/>
+            </a:xfrm>
+            <a:prstGeom prst="rect">
+              <a:avLst/>
+            </a:prstGeom>
+            <a:noFill/>
+            <a:ln>
+              <a:solidFill>
+                <a:schemeClr val="accent1"/>
+              </a:solidFill>
+            </a:ln>
+          </p:spPr>
+          <p:txBody>
+            <a:bodyPr wrap="square" rtlCol="0">
+              <a:spAutoFit/>
+            </a:bodyPr>
+            <a:lstStyle/>
+            <a:p>
+              <a:pPr algn="ctr"/>
+              <a:r>
+                <a:rPr lang="en-US" dirty="0"/>
+                <a:t>home</a:t>
+              </a:r>
+            </a:p>
+          </p:txBody>
+        </p:sp>
+        <p:sp>
+          <p:nvSpPr>
+            <p:cNvPr id="6" name="TextBox 5">
+              <a:extLst>
+                <a:ext uri="{FF2B5EF4-FFF2-40B4-BE49-F238E27FC236}">
+                  <a16:creationId xmlns:a16="http://schemas.microsoft.com/office/drawing/2014/main" id="{DA5D2A77-6CFB-F254-7FDF-26F5955669F9}"/>
+                </a:ext>
+              </a:extLst>
+            </p:cNvPr>
+            <p:cNvSpPr txBox="1"/>
+            <p:nvPr/>
+          </p:nvSpPr>
+          <p:spPr>
+            <a:xfrm>
+              <a:off x="4177119" y="1666189"/>
+              <a:ext cx="1326044" cy="369332"/>
+            </a:xfrm>
+            <a:prstGeom prst="rect">
+              <a:avLst/>
+            </a:prstGeom>
+            <a:noFill/>
+            <a:ln>
+              <a:solidFill>
+                <a:schemeClr val="accent1"/>
+              </a:solidFill>
+            </a:ln>
+          </p:spPr>
+          <p:txBody>
+            <a:bodyPr wrap="square" rtlCol="0">
+              <a:spAutoFit/>
+            </a:bodyPr>
+            <a:lstStyle/>
+            <a:p>
+              <a:r>
+                <a:rPr lang="en-US" dirty="0"/>
+                <a:t>documents</a:t>
+              </a:r>
+            </a:p>
+          </p:txBody>
+        </p:sp>
+        <p:sp>
+          <p:nvSpPr>
+            <p:cNvPr id="8" name="TextBox 7">
+              <a:extLst>
+                <a:ext uri="{FF2B5EF4-FFF2-40B4-BE49-F238E27FC236}">
+                  <a16:creationId xmlns:a16="http://schemas.microsoft.com/office/drawing/2014/main" id="{615A982A-7A8C-1816-E98F-9E3B30B56E4B}"/>
+                </a:ext>
+              </a:extLst>
+            </p:cNvPr>
+            <p:cNvSpPr txBox="1"/>
+            <p:nvPr/>
+          </p:nvSpPr>
+          <p:spPr>
+            <a:xfrm>
+              <a:off x="5758345" y="1681578"/>
+              <a:ext cx="1030955" cy="369332"/>
+            </a:xfrm>
+            <a:prstGeom prst="rect">
+              <a:avLst/>
+            </a:prstGeom>
+            <a:noFill/>
+            <a:ln>
+              <a:solidFill>
+                <a:schemeClr val="accent1"/>
+              </a:solidFill>
+            </a:ln>
+          </p:spPr>
+          <p:txBody>
+            <a:bodyPr wrap="square" rtlCol="0">
+              <a:spAutoFit/>
+            </a:bodyPr>
+            <a:lstStyle/>
+            <a:p>
+              <a:pPr algn="ctr"/>
+              <a:r>
+                <a:rPr lang="en-US" dirty="0"/>
+                <a:t>photos</a:t>
+              </a:r>
+            </a:p>
+          </p:txBody>
+        </p:sp>
+        <p:sp>
+          <p:nvSpPr>
+            <p:cNvPr id="10" name="TextBox 9">
+              <a:extLst>
+                <a:ext uri="{FF2B5EF4-FFF2-40B4-BE49-F238E27FC236}">
+                  <a16:creationId xmlns:a16="http://schemas.microsoft.com/office/drawing/2014/main" id="{60EFC832-8D13-7839-FC6F-2BB66549F911}"/>
+                </a:ext>
+              </a:extLst>
+            </p:cNvPr>
+            <p:cNvSpPr txBox="1"/>
+            <p:nvPr/>
+          </p:nvSpPr>
+          <p:spPr>
+            <a:xfrm>
+              <a:off x="7074070" y="1666189"/>
+              <a:ext cx="1296456" cy="369332"/>
+            </a:xfrm>
+            <a:prstGeom prst="rect">
+              <a:avLst/>
+            </a:prstGeom>
+            <a:noFill/>
+            <a:ln>
+              <a:solidFill>
+                <a:schemeClr val="accent1"/>
+              </a:solidFill>
+            </a:ln>
+          </p:spPr>
+          <p:txBody>
+            <a:bodyPr wrap="square" rtlCol="0">
+              <a:spAutoFit/>
+            </a:bodyPr>
+            <a:lstStyle/>
+            <a:p>
+              <a:r>
+                <a:rPr lang="en-US" dirty="0"/>
+                <a:t>downloads</a:t>
+              </a:r>
+            </a:p>
+          </p:txBody>
+        </p:sp>
+        <p:sp>
+          <p:nvSpPr>
+            <p:cNvPr id="12" name="TextBox 11">
+              <a:extLst>
+                <a:ext uri="{FF2B5EF4-FFF2-40B4-BE49-F238E27FC236}">
+                  <a16:creationId xmlns:a16="http://schemas.microsoft.com/office/drawing/2014/main" id="{EEE0CA48-27ED-0938-0EF4-21B9A5F446CC}"/>
+                </a:ext>
+              </a:extLst>
+            </p:cNvPr>
+            <p:cNvSpPr txBox="1"/>
+            <p:nvPr/>
+          </p:nvSpPr>
+          <p:spPr>
+            <a:xfrm>
+              <a:off x="6255459" y="2316244"/>
+              <a:ext cx="1424233" cy="369332"/>
+            </a:xfrm>
+            <a:prstGeom prst="rect">
+              <a:avLst/>
+            </a:prstGeom>
+            <a:noFill/>
+            <a:ln>
+              <a:solidFill>
+                <a:schemeClr val="accent1"/>
+              </a:solidFill>
+            </a:ln>
+          </p:spPr>
+          <p:txBody>
+            <a:bodyPr wrap="square" rtlCol="0">
+              <a:spAutoFit/>
+            </a:bodyPr>
+            <a:lstStyle/>
+            <a:p>
+              <a:pPr algn="ctr"/>
+              <a:r>
+                <a:rPr lang="en-US" dirty="0" err="1"/>
+                <a:t>holiday.jpg</a:t>
+              </a:r>
+              <a:endParaRPr lang="en-US" dirty="0"/>
+            </a:p>
+          </p:txBody>
+        </p:sp>
+        <p:sp>
+          <p:nvSpPr>
+            <p:cNvPr id="14" name="TextBox 13">
+              <a:extLst>
+                <a:ext uri="{FF2B5EF4-FFF2-40B4-BE49-F238E27FC236}">
+                  <a16:creationId xmlns:a16="http://schemas.microsoft.com/office/drawing/2014/main" id="{763C79F9-CCD8-96B0-CFEB-FB4D858742FB}"/>
+                </a:ext>
+              </a:extLst>
+            </p:cNvPr>
+            <p:cNvSpPr txBox="1"/>
+            <p:nvPr/>
+          </p:nvSpPr>
+          <p:spPr>
+            <a:xfrm>
+              <a:off x="8071430" y="2316244"/>
+              <a:ext cx="1189347" cy="369332"/>
+            </a:xfrm>
+            <a:prstGeom prst="rect">
+              <a:avLst/>
+            </a:prstGeom>
+            <a:noFill/>
+            <a:ln>
+              <a:solidFill>
+                <a:schemeClr val="accent1"/>
+              </a:solidFill>
+            </a:ln>
+          </p:spPr>
+          <p:txBody>
+            <a:bodyPr wrap="square" rtlCol="0">
+              <a:spAutoFit/>
+            </a:bodyPr>
+            <a:lstStyle/>
+            <a:p>
+              <a:pPr algn="ctr"/>
+              <a:r>
+                <a:rPr lang="en-US" dirty="0" err="1"/>
+                <a:t>report.pdf</a:t>
+              </a:r>
+              <a:endParaRPr lang="en-US" dirty="0"/>
+            </a:p>
+          </p:txBody>
+        </p:sp>
+        <p:sp>
+          <p:nvSpPr>
+            <p:cNvPr id="16" name="TextBox 15">
+              <a:extLst>
+                <a:ext uri="{FF2B5EF4-FFF2-40B4-BE49-F238E27FC236}">
+                  <a16:creationId xmlns:a16="http://schemas.microsoft.com/office/drawing/2014/main" id="{85F6C4D9-B933-346B-07D8-97BFAA1EAE37}"/>
+                </a:ext>
+              </a:extLst>
+            </p:cNvPr>
+            <p:cNvSpPr txBox="1"/>
+            <p:nvPr/>
+          </p:nvSpPr>
+          <p:spPr>
+            <a:xfrm>
+              <a:off x="4757332" y="2316244"/>
+              <a:ext cx="1177362" cy="369332"/>
+            </a:xfrm>
+            <a:prstGeom prst="rect">
+              <a:avLst/>
+            </a:prstGeom>
+            <a:noFill/>
+            <a:ln>
+              <a:solidFill>
+                <a:schemeClr val="accent1"/>
+              </a:solidFill>
+            </a:ln>
+          </p:spPr>
+          <p:txBody>
+            <a:bodyPr wrap="square" rtlCol="0">
+              <a:spAutoFit/>
+            </a:bodyPr>
+            <a:lstStyle/>
+            <a:p>
+              <a:pPr algn="ctr"/>
+              <a:r>
+                <a:rPr lang="en-US" dirty="0" err="1"/>
+                <a:t>essay.txt</a:t>
+              </a:r>
+              <a:endParaRPr lang="en-US" dirty="0"/>
+            </a:p>
+          </p:txBody>
+        </p:sp>
+        <p:sp>
+          <p:nvSpPr>
+            <p:cNvPr id="18" name="TextBox 17">
+              <a:extLst>
+                <a:ext uri="{FF2B5EF4-FFF2-40B4-BE49-F238E27FC236}">
+                  <a16:creationId xmlns:a16="http://schemas.microsoft.com/office/drawing/2014/main" id="{77331A54-6494-FB96-A505-A7379F15EAE1}"/>
+                </a:ext>
+              </a:extLst>
+            </p:cNvPr>
+            <p:cNvSpPr txBox="1"/>
+            <p:nvPr/>
+          </p:nvSpPr>
+          <p:spPr>
+            <a:xfrm>
+              <a:off x="3211747" y="2316244"/>
+              <a:ext cx="1057099" cy="369332"/>
+            </a:xfrm>
+            <a:prstGeom prst="rect">
+              <a:avLst/>
+            </a:prstGeom>
+            <a:noFill/>
+            <a:ln>
+              <a:solidFill>
+                <a:schemeClr val="accent1"/>
+              </a:solidFill>
+            </a:ln>
+          </p:spPr>
+          <p:txBody>
+            <a:bodyPr wrap="square" rtlCol="0">
+              <a:spAutoFit/>
+            </a:bodyPr>
+            <a:lstStyle/>
+            <a:p>
+              <a:pPr algn="ctr"/>
+              <a:r>
+                <a:rPr lang="en-US" dirty="0" err="1"/>
+                <a:t>notes.txt</a:t>
+              </a:r>
+              <a:endParaRPr lang="en-US" dirty="0"/>
+            </a:p>
+          </p:txBody>
+        </p:sp>
+        <p:cxnSp>
+          <p:nvCxnSpPr>
+            <p:cNvPr id="20" name="Straight Connector 19">
+              <a:extLst>
+                <a:ext uri="{FF2B5EF4-FFF2-40B4-BE49-F238E27FC236}">
+                  <a16:creationId xmlns:a16="http://schemas.microsoft.com/office/drawing/2014/main" id="{066601BF-16D2-960B-D5DB-3D109FACF512}"/>
+                </a:ext>
+              </a:extLst>
+            </p:cNvPr>
+            <p:cNvCxnSpPr>
+              <a:stCxn id="4" idx="2"/>
+              <a:endCxn id="8" idx="0"/>
+            </p:cNvCxnSpPr>
+            <p:nvPr/>
+          </p:nvCxnSpPr>
+          <p:spPr>
+            <a:xfrm>
+              <a:off x="6273822" y="1323184"/>
+              <a:ext cx="1" cy="358394"/>
+            </a:xfrm>
+            <a:prstGeom prst="line">
+              <a:avLst/>
+            </a:prstGeom>
+          </p:spPr>
+          <p:style>
+            <a:lnRef idx="2">
+              <a:schemeClr val="accent1"/>
+            </a:lnRef>
+            <a:fillRef idx="0">
+              <a:schemeClr val="accent1"/>
+            </a:fillRef>
+            <a:effectRef idx="1">
+              <a:schemeClr val="accent1"/>
+            </a:effectRef>
+            <a:fontRef idx="minor">
+              <a:schemeClr val="tx1"/>
+            </a:fontRef>
+          </p:style>
+        </p:cxnSp>
+        <p:cxnSp>
+          <p:nvCxnSpPr>
+            <p:cNvPr id="21" name="Straight Connector 20">
+              <a:extLst>
+                <a:ext uri="{FF2B5EF4-FFF2-40B4-BE49-F238E27FC236}">
+                  <a16:creationId xmlns:a16="http://schemas.microsoft.com/office/drawing/2014/main" id="{1EBCE35E-89F1-9E8C-3F73-ACD8AC4E1150}"/>
+                </a:ext>
+              </a:extLst>
+            </p:cNvPr>
+            <p:cNvCxnSpPr>
+              <a:cxnSpLocks/>
+              <a:stCxn id="4" idx="2"/>
+              <a:endCxn id="6" idx="0"/>
+            </p:cNvCxnSpPr>
+            <p:nvPr/>
+          </p:nvCxnSpPr>
+          <p:spPr>
+            <a:xfrm flipH="1">
+              <a:off x="4840141" y="1323184"/>
+              <a:ext cx="1433681" cy="343005"/>
+            </a:xfrm>
+            <a:prstGeom prst="line">
+              <a:avLst/>
+            </a:prstGeom>
+          </p:spPr>
+          <p:style>
+            <a:lnRef idx="2">
+              <a:schemeClr val="accent1"/>
+            </a:lnRef>
+            <a:fillRef idx="0">
+              <a:schemeClr val="accent1"/>
+            </a:fillRef>
+            <a:effectRef idx="1">
+              <a:schemeClr val="accent1"/>
+            </a:effectRef>
+            <a:fontRef idx="minor">
+              <a:schemeClr val="tx1"/>
+            </a:fontRef>
+          </p:style>
+        </p:cxnSp>
+        <p:cxnSp>
+          <p:nvCxnSpPr>
+            <p:cNvPr id="24" name="Straight Connector 23">
+              <a:extLst>
+                <a:ext uri="{FF2B5EF4-FFF2-40B4-BE49-F238E27FC236}">
+                  <a16:creationId xmlns:a16="http://schemas.microsoft.com/office/drawing/2014/main" id="{0C9B2F68-4B7F-D4F0-9993-1D421F9CCE53}"/>
+                </a:ext>
+              </a:extLst>
+            </p:cNvPr>
+            <p:cNvCxnSpPr>
+              <a:cxnSpLocks/>
+              <a:stCxn id="4" idx="2"/>
+              <a:endCxn id="10" idx="0"/>
+            </p:cNvCxnSpPr>
+            <p:nvPr/>
+          </p:nvCxnSpPr>
+          <p:spPr>
+            <a:xfrm>
+              <a:off x="6273822" y="1323184"/>
+              <a:ext cx="1448476" cy="343005"/>
+            </a:xfrm>
+            <a:prstGeom prst="line">
+              <a:avLst/>
+            </a:prstGeom>
+          </p:spPr>
+          <p:style>
+            <a:lnRef idx="2">
+              <a:schemeClr val="accent1"/>
+            </a:lnRef>
+            <a:fillRef idx="0">
+              <a:schemeClr val="accent1"/>
+            </a:fillRef>
+            <a:effectRef idx="1">
+              <a:schemeClr val="accent1"/>
+            </a:effectRef>
+            <a:fontRef idx="minor">
+              <a:schemeClr val="tx1"/>
+            </a:fontRef>
+          </p:style>
+        </p:cxnSp>
+        <p:cxnSp>
+          <p:nvCxnSpPr>
+            <p:cNvPr id="27" name="Straight Connector 26">
+              <a:extLst>
+                <a:ext uri="{FF2B5EF4-FFF2-40B4-BE49-F238E27FC236}">
+                  <a16:creationId xmlns:a16="http://schemas.microsoft.com/office/drawing/2014/main" id="{30AB3E62-E587-47BC-B65C-6562AC60E87E}"/>
+                </a:ext>
+              </a:extLst>
+            </p:cNvPr>
+            <p:cNvCxnSpPr>
+              <a:cxnSpLocks/>
+              <a:stCxn id="6" idx="2"/>
+              <a:endCxn id="18" idx="0"/>
+            </p:cNvCxnSpPr>
+            <p:nvPr/>
+          </p:nvCxnSpPr>
+          <p:spPr>
+            <a:xfrm flipH="1">
+              <a:off x="3740297" y="2035521"/>
+              <a:ext cx="1099844" cy="280723"/>
+            </a:xfrm>
+            <a:prstGeom prst="line">
+              <a:avLst/>
+            </a:prstGeom>
+          </p:spPr>
+          <p:style>
+            <a:lnRef idx="2">
+              <a:schemeClr val="accent1"/>
+            </a:lnRef>
+            <a:fillRef idx="0">
+              <a:schemeClr val="accent1"/>
+            </a:fillRef>
+            <a:effectRef idx="1">
+              <a:schemeClr val="accent1"/>
+            </a:effectRef>
+            <a:fontRef idx="minor">
+              <a:schemeClr val="tx1"/>
+            </a:fontRef>
+          </p:style>
+        </p:cxnSp>
+        <p:cxnSp>
+          <p:nvCxnSpPr>
+            <p:cNvPr id="30" name="Straight Connector 29">
+              <a:extLst>
+                <a:ext uri="{FF2B5EF4-FFF2-40B4-BE49-F238E27FC236}">
+                  <a16:creationId xmlns:a16="http://schemas.microsoft.com/office/drawing/2014/main" id="{E52AE403-A3A6-7F2C-53B9-CC81B6BB7E03}"/>
+                </a:ext>
+              </a:extLst>
+            </p:cNvPr>
+            <p:cNvCxnSpPr>
+              <a:cxnSpLocks/>
+              <a:stCxn id="6" idx="2"/>
+              <a:endCxn id="16" idx="0"/>
+            </p:cNvCxnSpPr>
+            <p:nvPr/>
+          </p:nvCxnSpPr>
+          <p:spPr>
+            <a:xfrm>
+              <a:off x="4840141" y="2035521"/>
+              <a:ext cx="505872" cy="280723"/>
+            </a:xfrm>
+            <a:prstGeom prst="line">
+              <a:avLst/>
+            </a:prstGeom>
+          </p:spPr>
+          <p:style>
+            <a:lnRef idx="2">
+              <a:schemeClr val="accent1"/>
+            </a:lnRef>
+            <a:fillRef idx="0">
+              <a:schemeClr val="accent1"/>
+            </a:fillRef>
+            <a:effectRef idx="1">
+              <a:schemeClr val="accent1"/>
+            </a:effectRef>
+            <a:fontRef idx="minor">
+              <a:schemeClr val="tx1"/>
+            </a:fontRef>
+          </p:style>
+        </p:cxnSp>
+        <p:cxnSp>
+          <p:nvCxnSpPr>
+            <p:cNvPr id="33" name="Straight Connector 32">
+              <a:extLst>
+                <a:ext uri="{FF2B5EF4-FFF2-40B4-BE49-F238E27FC236}">
+                  <a16:creationId xmlns:a16="http://schemas.microsoft.com/office/drawing/2014/main" id="{32549293-27F8-A575-E242-4CDE74C6585D}"/>
+                </a:ext>
+              </a:extLst>
+            </p:cNvPr>
+            <p:cNvCxnSpPr>
+              <a:cxnSpLocks/>
+              <a:stCxn id="8" idx="2"/>
+              <a:endCxn id="12" idx="0"/>
+            </p:cNvCxnSpPr>
+            <p:nvPr/>
+          </p:nvCxnSpPr>
+          <p:spPr>
+            <a:xfrm>
+              <a:off x="6273823" y="2050910"/>
+              <a:ext cx="693753" cy="265334"/>
+            </a:xfrm>
+            <a:prstGeom prst="line">
+              <a:avLst/>
+            </a:prstGeom>
+          </p:spPr>
+          <p:style>
+            <a:lnRef idx="2">
+              <a:schemeClr val="accent1"/>
+            </a:lnRef>
+            <a:fillRef idx="0">
+              <a:schemeClr val="accent1"/>
+            </a:fillRef>
+            <a:effectRef idx="1">
+              <a:schemeClr val="accent1"/>
+            </a:effectRef>
+            <a:fontRef idx="minor">
+              <a:schemeClr val="tx1"/>
+            </a:fontRef>
+          </p:style>
+        </p:cxnSp>
+        <p:cxnSp>
+          <p:nvCxnSpPr>
+            <p:cNvPr id="36" name="Straight Connector 35">
+              <a:extLst>
+                <a:ext uri="{FF2B5EF4-FFF2-40B4-BE49-F238E27FC236}">
+                  <a16:creationId xmlns:a16="http://schemas.microsoft.com/office/drawing/2014/main" id="{CD0B4E94-8AAD-65EE-8B9F-44708BE1A474}"/>
+                </a:ext>
+              </a:extLst>
+            </p:cNvPr>
+            <p:cNvCxnSpPr>
+              <a:cxnSpLocks/>
+              <a:stCxn id="10" idx="2"/>
+              <a:endCxn id="14" idx="0"/>
+            </p:cNvCxnSpPr>
+            <p:nvPr/>
+          </p:nvCxnSpPr>
+          <p:spPr>
+            <a:xfrm>
+              <a:off x="7722298" y="2035521"/>
+              <a:ext cx="943806" cy="280723"/>
+            </a:xfrm>
+            <a:prstGeom prst="line">
+              <a:avLst/>
+            </a:prstGeom>
+          </p:spPr>
+          <p:style>
+            <a:lnRef idx="2">
+              <a:schemeClr val="accent1"/>
+            </a:lnRef>
+            <a:fillRef idx="0">
+              <a:schemeClr val="accent1"/>
+            </a:fillRef>
+            <a:effectRef idx="1">
+              <a:schemeClr val="accent1"/>
+            </a:effectRef>
+            <a:fontRef idx="minor">
+              <a:schemeClr val="tx1"/>
+            </a:fontRef>
+          </p:style>
+        </p:cxnSp>
+      </p:grpSp>
+    </p:spTree>
+    <p:extLst>
+      <p:ext uri="{BB962C8B-B14F-4D97-AF65-F5344CB8AC3E}">
+        <p14:creationId xmlns:p14="http://schemas.microsoft.com/office/powerpoint/2010/main" val="1492292829"/>
+      </p:ext>
+    </p:extLst>
+  </p:cSld>
+  <p:clrMapOvr>
+    <a:masterClrMapping/>
+  </p:clrMapOvr>
+</p:sld>
+</file>
+
 <file path=ppt/theme/theme1.xml><?xml version="1.0" encoding="utf-8"?>
 <a:theme xmlns:a="http://schemas.openxmlformats.org/drawingml/2006/main" name="Office Theme">
   <a:themeElements>

</xml_diff>